<commit_message>
Clarify end-to-end testing of automatic failover
Signed-off-by: Yury Tsarev <yury@0ttl.ai>
</commit_message>
<xml_diff>
--- a/slides/k8gb_sovereign_cloud_days_2026.pptx
+++ b/slides/k8gb_sovereign_cloud_days_2026.pptx
@@ -1521,7 +1521,7 @@
           <a:p/>
           <a:p>
             <a:r>
-              <a:t>Close with configure, verify, automate. Version the Gslb manifest; choose and own the delegated DNS path; use multiple observable authorities; make readiness describe the real operation; verify client-visible requests; automate failure and recovery tests. These absorb the separate operational checklist. Return to the title: control comes from choosing the configuration, seeing the result, and repeatedly testing recovery. Do not reopen the data discussion or recap every slide. Invite questions by minute 28.</a:t>
+              <a:t>Close with configure, verify, test. k8gb automatically reconciles traffic failover and failback; the team automates end-to-end tests of that behavior. Version the Gslb manifest; choose and own the delegated DNS path; use multiple observable authorities; make readiness describe the real operation; verify client-visible requests; automate failure and recovery tests. These absorb the separate operational checklist. Return to the title: control comes from choosing the configuration, seeing the result, and repeatedly testing recovery. Do not reopen the data discussion or recap every slide. Invite questions by minute 28.</a:t>
             </a:r>
           </a:p>
           <a:p/>
@@ -30210,7 +30210,7 @@
                 </a:solidFill>
                 <a:latin typeface="Arial"/>
               </a:rPr>
-              <a:t>Automate tested recovery.</a:t>
+              <a:t>Test recovery end to end.</a:t>
             </a:r>
           </a:p>
         </p:txBody>
@@ -31254,7 +31254,7 @@
                 </a:solidFill>
                 <a:latin typeface="Arial"/>
               </a:rPr>
-              <a:t>AUTOMATE</a:t>
+              <a:t>TEST</a:t>
             </a:r>
           </a:p>
         </p:txBody>
@@ -31299,7 +31299,7 @@
                 </a:solidFill>
                 <a:latin typeface="Arial"/>
               </a:rPr>
-              <a:t>Test failover.</a:t>
+              <a:t>Automate failover</a:t>
             </a:r>
           </a:p>
           <a:p>
@@ -31321,7 +31321,7 @@
                 </a:solidFill>
                 <a:latin typeface="Arial"/>
               </a:rPr>
-              <a:t>Automate recovery.</a:t>
+              <a:t>and failback tests.</a:t>
             </a:r>
           </a:p>
         </p:txBody>

</xml_diff>

<commit_message>
Show Kubernetes and DNS provider integrations
Signed-off-by: Yury Tsarev <yury@0ttl.ai>
</commit_message>
<xml_diff>
--- a/slides/k8gb_sovereign_cloud_days_2026.pptx
+++ b/slides/k8gb_sovereign_cloud_days_2026.pptx
@@ -740,7 +740,7 @@
           <a:p/>
           <a:p>
             <a:r>
-              <a:t>The parent DNS can be provider-operated or team-operated. ExternalDNS uses the selected provider API, or RFC 2136 with TSIG for BIND9. The Gslb strategy and application-zone CoreDNS layer remain the same. This is the concrete sovereignty choice: your team chooses the parent authority and its integration. Provider changes still require configuration and delegation planning; avoid a second delegation walkthrough.</a:t>
+              <a:t>Spend 75 seconds on integration breadth. k8gb runs on conformant Kubernetes in on-prem, cloud and hybrid setups. The four native resource integrations are Gateway API, Ingress, Istio VirtualService, and LoadBalancer Service; Gateway API is recommended for new deployments. Point to the documented DNS providers rather than reading every logo. RFC 2136 covers BIND9 and Windows DNS, using TSIG or GSS-TSIG as appropriate. ExternalDNS handles configured provider APIs and RFC 2136; Infoblox also has a dedicated integration. Your team chooses the parent authority while the Gslb traffic strategy and application-zone CoreDNS layer remain the same. Provider changes still require configuration and delegation planning. The local demo uses Ingress and BIND9. Move directly to the topology choices.</a:t>
             </a:r>
           </a:p>
           <a:p/>
@@ -756,12 +756,37 @@
           </a:p>
           <a:p>
             <a:r>
+              <a:t>https://github.com/k8gb-io/k8gb/blob/330d33335981b9716bc8ca245660d90893eae272/README.md</a:t>
+            </a:r>
+          </a:p>
+          <a:p>
+            <a:r>
+              <a:t>https://github.com/k8gb-io/k8gb/blob/330d33335981b9716bc8ca245660d90893eae272/docs/resource_ref.md</a:t>
+            </a:r>
+          </a:p>
+          <a:p>
+            <a:r>
+              <a:t>https://github.com/k8gb-io/k8gb/blob/330d33335981b9716bc8ca245660d90893eae272/docs/tutorials.md</a:t>
+            </a:r>
+          </a:p>
+          <a:p>
+            <a:r>
               <a:t>https://github.com/k8gb-io/k8gb/blob/330d33335981b9716bc8ca245660d90893eae272/docs/provider_rfc2136.md</a:t>
             </a:r>
           </a:p>
           <a:p>
             <a:r>
-              <a:t>https://github.com/k8gb-io/k8gb/blob/330d33335981b9716bc8ca245660d90893eae272/controllers/providers/dns/external.go</a:t>
+              <a:t>https://github.com/k8gb-io/k8gb/blob/330d33335981b9716bc8ca245660d90893eae272/docs/lbservice-integration.md</a:t>
+            </a:r>
+          </a:p>
+          <a:p>
+            <a:r>
+              <a:t>https://www.k8gb.io/master/resource_ref/</a:t>
+            </a:r>
+          </a:p>
+          <a:p>
+            <a:r>
+              <a:t>https://www.k8gb.io/master/tutorials/</a:t>
             </a:r>
           </a:p>
         </p:txBody>
@@ -10635,7 +10660,7 @@
                 </a:solidFill>
                 <a:latin typeface="Arial"/>
               </a:rPr>
-              <a:t>DNS PORTABILITY</a:t>
+              <a:t>INTEGRATIONS</a:t>
             </a:r>
           </a:p>
         </p:txBody>
@@ -10725,7 +10750,7 @@
                 </a:solidFill>
                 <a:latin typeface="Arial"/>
               </a:rPr>
-              <a:t>Choose parent DNS. Keep traffic steering.</a:t>
+              <a:t>Kubernetes and DNS integrations</a:t>
             </a:r>
           </a:p>
         </p:txBody>
@@ -10770,7 +10795,7 @@
                 </a:solidFill>
                 <a:latin typeface="Arial"/>
               </a:rPr>
-              <a:t>Managed or self-hosted: the application zone stays with CoreDNS.</a:t>
+              <a:t>Run on-prem, in the cloud, or across both.</a:t>
             </a:r>
           </a:p>
         </p:txBody>
@@ -10908,12 +10933,12 @@
         </p:nvSpPr>
         <p:spPr>
           <a:xfrm>
-            <a:off x="609600" y="2146300"/>
-            <a:ext cx="5181600" cy="1917700"/>
+            <a:off x="609600" y="2032000"/>
+            <a:ext cx="3479800" cy="3594100"/>
           </a:xfrm>
           <a:prstGeom prst="roundRect">
             <a:avLst>
-              <a:gd name="adj" fmla="val 6622"/>
+              <a:gd name="adj" fmla="val 3649"/>
             </a:avLst>
           </a:prstGeom>
           <a:solidFill>
@@ -10954,12 +10979,12 @@
         </p:nvSpPr>
         <p:spPr>
           <a:xfrm>
-            <a:off x="609600" y="2095500"/>
-            <a:ext cx="5181600" cy="1917700"/>
+            <a:off x="609600" y="1981200"/>
+            <a:ext cx="3479800" cy="3594100"/>
           </a:xfrm>
           <a:prstGeom prst="roundRect">
             <a:avLst>
-              <a:gd name="adj" fmla="val 6622"/>
+              <a:gd name="adj" fmla="val 3649"/>
             </a:avLst>
           </a:prstGeom>
           <a:solidFill>
@@ -11002,8 +11027,8 @@
         </p:nvCxnSpPr>
         <p:spPr>
           <a:xfrm>
-            <a:off x="914400" y="2108200"/>
-            <a:ext cx="4572000" cy="0"/>
+            <a:off x="889000" y="1993900"/>
+            <a:ext cx="2921000" cy="0"/>
           </a:xfrm>
           <a:prstGeom prst="line">
             <a:avLst/>
@@ -11029,21 +11054,190 @@
           </a:fontRef>
         </p:style>
       </p:cxnSp>
-      <p:sp>
-        <p:nvSpPr>
-          <p:cNvPr id="13" name="Rounded Rectangle 12"/>
+      <p:pic>
+        <p:nvPicPr>
+          <p:cNvPr id="13" name="Picture 12" descr="image.png"/>
+          <p:cNvPicPr>
+            <a:picLocks noChangeAspect="1"/>
+          </p:cNvPicPr>
+          <p:nvPr/>
+        </p:nvPicPr>
+        <p:blipFill>
+          <a:blip r:embed="rId2"/>
+          <a:stretch>
+            <a:fillRect/>
+          </a:stretch>
+        </p:blipFill>
+        <p:spPr>
+          <a:xfrm>
+            <a:off x="863600" y="2247900"/>
+            <a:ext cx="546100" cy="546100"/>
+          </a:xfrm>
+          <a:prstGeom prst="rect">
+            <a:avLst/>
+          </a:prstGeom>
+        </p:spPr>
+      </p:pic>
+      <p:sp>
+        <p:nvSpPr>
+          <p:cNvPr id="14" name="TextBox 13"/>
+          <p:cNvSpPr txBox="1"/>
+          <p:nvPr/>
+        </p:nvSpPr>
+        <p:spPr>
+          <a:xfrm>
+            <a:off x="1612900" y="2222500"/>
+            <a:ext cx="2222500" cy="635508"/>
+          </a:xfrm>
+          <a:prstGeom prst="rect">
+            <a:avLst/>
+          </a:prstGeom>
+          <a:noFill/>
+        </p:spPr>
+        <p:txBody>
+          <a:bodyPr wrap="none" lIns="0" rIns="0" tIns="0" bIns="0" anchor="t">
+            <a:noAutofit/>
+          </a:bodyPr>
+          <a:lstStyle/>
+          <a:p>
+            <a:pPr algn="l">
+              <a:lnSpc>
+                <a:spcPts val="2352"/>
+              </a:lnSpc>
+              <a:spcBef>
+                <a:spcPts val="0"/>
+              </a:spcBef>
+              <a:spcAft>
+                <a:spcPts val="0"/>
+              </a:spcAft>
+            </a:pPr>
+            <a:r>
+              <a:rPr sz="2100" b="1">
+                <a:solidFill>
+                  <a:srgbClr val="142338"/>
+                </a:solidFill>
+                <a:latin typeface="Arial"/>
+              </a:rPr>
+              <a:t>Conformant</a:t>
+            </a:r>
+          </a:p>
+          <a:p>
+            <a:pPr algn="l">
+              <a:lnSpc>
+                <a:spcPts val="2352"/>
+              </a:lnSpc>
+              <a:spcBef>
+                <a:spcPts val="0"/>
+              </a:spcBef>
+              <a:spcAft>
+                <a:spcPts val="0"/>
+              </a:spcAft>
+            </a:pPr>
+            <a:r>
+              <a:rPr sz="2100" b="1">
+                <a:solidFill>
+                  <a:srgbClr val="142338"/>
+                </a:solidFill>
+                <a:latin typeface="Arial"/>
+              </a:rPr>
+              <a:t>Kubernetes</a:t>
+            </a:r>
+          </a:p>
+        </p:txBody>
+      </p:sp>
+      <p:cxnSp>
+        <p:nvCxnSpPr>
+          <p:cNvPr id="15" name="Connector 14"/>
+          <p:cNvCxnSpPr/>
+          <p:nvPr/>
+        </p:nvCxnSpPr>
+        <p:spPr>
+          <a:xfrm>
+            <a:off x="863600" y="3035300"/>
+            <a:ext cx="2971800" cy="0"/>
+          </a:xfrm>
+          <a:prstGeom prst="line">
+            <a:avLst/>
+          </a:prstGeom>
+          <a:ln w="12700">
+            <a:solidFill>
+              <a:srgbClr val="DAE2EA"/>
+            </a:solidFill>
+          </a:ln>
+        </p:spPr>
+        <p:style>
+          <a:lnRef idx="2">
+            <a:schemeClr val="accent1"/>
+          </a:lnRef>
+          <a:fillRef idx="0">
+            <a:schemeClr val="accent1"/>
+          </a:fillRef>
+          <a:effectRef idx="1">
+            <a:schemeClr val="accent1"/>
+          </a:effectRef>
+          <a:fontRef idx="minor">
+            <a:schemeClr val="tx1"/>
+          </a:fontRef>
+        </p:style>
+      </p:cxnSp>
+      <p:sp>
+        <p:nvSpPr>
+          <p:cNvPr id="16" name="TextBox 15"/>
+          <p:cNvSpPr txBox="1"/>
+          <p:nvPr/>
+        </p:nvSpPr>
+        <p:spPr>
+          <a:xfrm>
+            <a:off x="863600" y="3200400"/>
+            <a:ext cx="2971800" cy="184150"/>
+          </a:xfrm>
+          <a:prstGeom prst="rect">
+            <a:avLst/>
+          </a:prstGeom>
+          <a:noFill/>
+        </p:spPr>
+        <p:txBody>
+          <a:bodyPr wrap="none" lIns="0" rIns="0" tIns="0" bIns="0" anchor="t">
+            <a:noAutofit/>
+          </a:bodyPr>
+          <a:lstStyle/>
+          <a:p>
+            <a:pPr algn="l">
+              <a:lnSpc>
+                <a:spcPts val="1150"/>
+              </a:lnSpc>
+              <a:spcBef>
+                <a:spcPts val="0"/>
+              </a:spcBef>
+              <a:spcAft>
+                <a:spcPts val="0"/>
+              </a:spcAft>
+            </a:pPr>
+            <a:r>
+              <a:rPr sz="1000" b="1">
+                <a:solidFill>
+                  <a:srgbClr val="2762C8"/>
+                </a:solidFill>
+                <a:latin typeface="Arial"/>
+              </a:rPr>
+              <a:t>NATIVE RESOURCE INTEGRATIONS</a:t>
+            </a:r>
+          </a:p>
+        </p:txBody>
+      </p:sp>
+      <p:sp>
+        <p:nvSpPr>
+          <p:cNvPr id="17" name="Oval 16"/>
           <p:cNvSpPr/>
           <p:nvPr/>
         </p:nvSpPr>
         <p:spPr>
           <a:xfrm>
-            <a:off x="914400" y="2349500"/>
-            <a:ext cx="812800" cy="812800"/>
-          </a:xfrm>
-          <a:prstGeom prst="roundRect">
-            <a:avLst>
-              <a:gd name="adj" fmla="val 18750"/>
-            </a:avLst>
+            <a:off x="863600" y="3556000"/>
+            <a:ext cx="228600" cy="228600"/>
+          </a:xfrm>
+          <a:prstGeom prst="ellipse">
+            <a:avLst/>
           </a:prstGeom>
           <a:solidFill>
             <a:srgbClr val="EAF0FB"/>
@@ -11075,16 +11269,86 @@
           </a:p>
         </p:txBody>
       </p:sp>
-      <p:sp>
-        <p:nvSpPr>
-          <p:cNvPr id="14" name="TextBox 13"/>
+      <p:cxnSp>
+        <p:nvCxnSpPr>
+          <p:cNvPr id="18" name="Connector 17"/>
+          <p:cNvCxnSpPr/>
+          <p:nvPr/>
+        </p:nvCxnSpPr>
+        <p:spPr>
+          <a:xfrm>
+            <a:off x="927100" y="3670300"/>
+            <a:ext cx="38100" cy="38100"/>
+          </a:xfrm>
+          <a:prstGeom prst="line">
+            <a:avLst/>
+          </a:prstGeom>
+          <a:ln w="19050">
+            <a:solidFill>
+              <a:srgbClr val="2762C8"/>
+            </a:solidFill>
+          </a:ln>
+        </p:spPr>
+        <p:style>
+          <a:lnRef idx="2">
+            <a:schemeClr val="accent1"/>
+          </a:lnRef>
+          <a:fillRef idx="0">
+            <a:schemeClr val="accent1"/>
+          </a:fillRef>
+          <a:effectRef idx="1">
+            <a:schemeClr val="accent1"/>
+          </a:effectRef>
+          <a:fontRef idx="minor">
+            <a:schemeClr val="tx1"/>
+          </a:fontRef>
+        </p:style>
+      </p:cxnSp>
+      <p:cxnSp>
+        <p:nvCxnSpPr>
+          <p:cNvPr id="19" name="Connector 18"/>
+          <p:cNvCxnSpPr/>
+          <p:nvPr/>
+        </p:nvCxnSpPr>
+        <p:spPr>
+          <a:xfrm flipV="1">
+            <a:off x="965200" y="3619500"/>
+            <a:ext cx="76200" cy="88900"/>
+          </a:xfrm>
+          <a:prstGeom prst="line">
+            <a:avLst/>
+          </a:prstGeom>
+          <a:ln w="19050">
+            <a:solidFill>
+              <a:srgbClr val="2762C8"/>
+            </a:solidFill>
+          </a:ln>
+        </p:spPr>
+        <p:style>
+          <a:lnRef idx="2">
+            <a:schemeClr val="accent1"/>
+          </a:lnRef>
+          <a:fillRef idx="0">
+            <a:schemeClr val="accent1"/>
+          </a:fillRef>
+          <a:effectRef idx="1">
+            <a:schemeClr val="accent1"/>
+          </a:effectRef>
+          <a:fontRef idx="minor">
+            <a:schemeClr val="tx1"/>
+          </a:fontRef>
+        </p:style>
+      </p:cxnSp>
+      <p:sp>
+        <p:nvSpPr>
+          <p:cNvPr id="20" name="TextBox 19"/>
           <p:cNvSpPr txBox="1"/>
           <p:nvPr/>
         </p:nvSpPr>
         <p:spPr>
           <a:xfrm>
-            <a:off x="1930400" y="2374900"/>
-            <a:ext cx="3556000" cy="403224"/>
+            <a:off x="1219200" y="3543300"/>
+            <a:ext cx="2616200" cy="300990"/>
           </a:xfrm>
           <a:prstGeom prst="rect">
             <a:avLst/>
@@ -11099,7 +11363,7 @@
           <a:p>
             <a:pPr algn="l">
               <a:lnSpc>
-                <a:spcPts val="2874"/>
+                <a:spcPts val="2070"/>
               </a:lnSpc>
               <a:spcBef>
                 <a:spcPts val="0"/>
@@ -11109,77 +11373,30 @@
               </a:spcAft>
             </a:pPr>
             <a:r>
-              <a:rPr sz="2500" b="1">
+              <a:rPr sz="1800" b="1">
                 <a:solidFill>
                   <a:srgbClr val="142338"/>
                 </a:solidFill>
                 <a:latin typeface="Arial"/>
               </a:rPr>
-              <a:t>Managed DNS</a:t>
-            </a:r>
-          </a:p>
-        </p:txBody>
-      </p:sp>
-      <p:sp>
-        <p:nvSpPr>
-          <p:cNvPr id="15" name="TextBox 14"/>
-          <p:cNvSpPr txBox="1"/>
-          <p:nvPr/>
-        </p:nvSpPr>
-        <p:spPr>
-          <a:xfrm>
-            <a:off x="1930400" y="2819400"/>
-            <a:ext cx="3556000" cy="257175"/>
-          </a:xfrm>
-          <a:prstGeom prst="rect">
-            <a:avLst/>
-          </a:prstGeom>
-          <a:noFill/>
-        </p:spPr>
-        <p:txBody>
-          <a:bodyPr wrap="none" lIns="0" rIns="0" tIns="0" bIns="0" anchor="t">
-            <a:noAutofit/>
-          </a:bodyPr>
-          <a:lstStyle/>
-          <a:p>
-            <a:pPr algn="l">
-              <a:lnSpc>
-                <a:spcPts val="1725"/>
-              </a:lnSpc>
-              <a:spcBef>
-                <a:spcPts val="0"/>
-              </a:spcBef>
-              <a:spcAft>
-                <a:spcPts val="0"/>
-              </a:spcAft>
-            </a:pPr>
-            <a:r>
-              <a:rPr sz="1500" b="0">
-                <a:solidFill>
-                  <a:srgbClr val="5D6F82"/>
-                </a:solidFill>
-                <a:latin typeface="Arial"/>
-              </a:rPr>
-              <a:t>Operated by your provider</a:t>
-            </a:r>
-          </a:p>
-        </p:txBody>
-      </p:sp>
-      <p:sp>
-        <p:nvSpPr>
-          <p:cNvPr id="16" name="Rounded Rectangle 15"/>
+              <a:t>Gateway API</a:t>
+            </a:r>
+          </a:p>
+        </p:txBody>
+      </p:sp>
+      <p:sp>
+        <p:nvSpPr>
+          <p:cNvPr id="21" name="Oval 20"/>
           <p:cNvSpPr/>
           <p:nvPr/>
         </p:nvSpPr>
         <p:spPr>
           <a:xfrm>
-            <a:off x="914400" y="3403600"/>
-            <a:ext cx="4572000" cy="393700"/>
-          </a:xfrm>
-          <a:prstGeom prst="roundRect">
-            <a:avLst>
-              <a:gd name="adj" fmla="val 19354"/>
-            </a:avLst>
+            <a:off x="863600" y="4038600"/>
+            <a:ext cx="228600" cy="228600"/>
+          </a:xfrm>
+          <a:prstGeom prst="ellipse">
+            <a:avLst/>
           </a:prstGeom>
           <a:solidFill>
             <a:srgbClr val="EAF0FB"/>
@@ -11211,16 +11428,86 @@
           </a:p>
         </p:txBody>
       </p:sp>
-      <p:sp>
-        <p:nvSpPr>
-          <p:cNvPr id="17" name="TextBox 16"/>
+      <p:cxnSp>
+        <p:nvCxnSpPr>
+          <p:cNvPr id="22" name="Connector 21"/>
+          <p:cNvCxnSpPr/>
+          <p:nvPr/>
+        </p:nvCxnSpPr>
+        <p:spPr>
+          <a:xfrm>
+            <a:off x="927100" y="4152900"/>
+            <a:ext cx="38100" cy="38100"/>
+          </a:xfrm>
+          <a:prstGeom prst="line">
+            <a:avLst/>
+          </a:prstGeom>
+          <a:ln w="19050">
+            <a:solidFill>
+              <a:srgbClr val="2762C8"/>
+            </a:solidFill>
+          </a:ln>
+        </p:spPr>
+        <p:style>
+          <a:lnRef idx="2">
+            <a:schemeClr val="accent1"/>
+          </a:lnRef>
+          <a:fillRef idx="0">
+            <a:schemeClr val="accent1"/>
+          </a:fillRef>
+          <a:effectRef idx="1">
+            <a:schemeClr val="accent1"/>
+          </a:effectRef>
+          <a:fontRef idx="minor">
+            <a:schemeClr val="tx1"/>
+          </a:fontRef>
+        </p:style>
+      </p:cxnSp>
+      <p:cxnSp>
+        <p:nvCxnSpPr>
+          <p:cNvPr id="23" name="Connector 22"/>
+          <p:cNvCxnSpPr/>
+          <p:nvPr/>
+        </p:nvCxnSpPr>
+        <p:spPr>
+          <a:xfrm flipV="1">
+            <a:off x="965200" y="4102100"/>
+            <a:ext cx="76200" cy="88900"/>
+          </a:xfrm>
+          <a:prstGeom prst="line">
+            <a:avLst/>
+          </a:prstGeom>
+          <a:ln w="19050">
+            <a:solidFill>
+              <a:srgbClr val="2762C8"/>
+            </a:solidFill>
+          </a:ln>
+        </p:spPr>
+        <p:style>
+          <a:lnRef idx="2">
+            <a:schemeClr val="accent1"/>
+          </a:lnRef>
+          <a:fillRef idx="0">
+            <a:schemeClr val="accent1"/>
+          </a:fillRef>
+          <a:effectRef idx="1">
+            <a:schemeClr val="accent1"/>
+          </a:effectRef>
+          <a:fontRef idx="minor">
+            <a:schemeClr val="tx1"/>
+          </a:fontRef>
+        </p:style>
+      </p:cxnSp>
+      <p:sp>
+        <p:nvSpPr>
+          <p:cNvPr id="24" name="TextBox 23"/>
           <p:cNvSpPr txBox="1"/>
           <p:nvPr/>
         </p:nvSpPr>
         <p:spPr>
           <a:xfrm>
-            <a:off x="1066800" y="3467100"/>
-            <a:ext cx="4267200" cy="301625"/>
+            <a:off x="1219200" y="4025900"/>
+            <a:ext cx="2616200" cy="300990"/>
           </a:xfrm>
           <a:prstGeom prst="rect">
             <a:avLst/>
@@ -11233,9 +11520,9 @@
           </a:bodyPr>
           <a:lstStyle/>
           <a:p>
-            <a:pPr algn="ctr">
+            <a:pPr algn="l">
               <a:lnSpc>
-                <a:spcPts val="1900"/>
+                <a:spcPts val="2070"/>
               </a:lnSpc>
               <a:spcBef>
                 <a:spcPts val="0"/>
@@ -11245,35 +11532,33 @@
               </a:spcAft>
             </a:pPr>
             <a:r>
-              <a:rPr sz="1900" b="1">
+              <a:rPr sz="1800" b="1">
                 <a:solidFill>
-                  <a:srgbClr val="2762C8"/>
+                  <a:srgbClr val="142338"/>
                 </a:solidFill>
                 <a:latin typeface="Arial"/>
               </a:rPr>
-              <a:t>Provider API</a:t>
-            </a:r>
-          </a:p>
-        </p:txBody>
-      </p:sp>
-      <p:sp>
-        <p:nvSpPr>
-          <p:cNvPr id="18" name="Rounded Rectangle 17"/>
+              <a:t>Ingress</a:t>
+            </a:r>
+          </a:p>
+        </p:txBody>
+      </p:sp>
+      <p:sp>
+        <p:nvSpPr>
+          <p:cNvPr id="25" name="Oval 24"/>
           <p:cNvSpPr/>
           <p:nvPr/>
         </p:nvSpPr>
         <p:spPr>
           <a:xfrm>
-            <a:off x="6400800" y="2146300"/>
-            <a:ext cx="5181600" cy="1917700"/>
-          </a:xfrm>
-          <a:prstGeom prst="roundRect">
-            <a:avLst>
-              <a:gd name="adj" fmla="val 6622"/>
-            </a:avLst>
+            <a:off x="863600" y="4521200"/>
+            <a:ext cx="228600" cy="228600"/>
+          </a:xfrm>
+          <a:prstGeom prst="ellipse">
+            <a:avLst/>
           </a:prstGeom>
           <a:solidFill>
-            <a:srgbClr val="E7ECF2"/>
+            <a:srgbClr val="EAF0FB"/>
           </a:solidFill>
           <a:ln>
             <a:noFill/>
@@ -11302,20 +11587,339 @@
           </a:p>
         </p:txBody>
       </p:sp>
-      <p:sp>
-        <p:nvSpPr>
-          <p:cNvPr id="19" name="Rounded Rectangle 18"/>
+      <p:cxnSp>
+        <p:nvCxnSpPr>
+          <p:cNvPr id="26" name="Connector 25"/>
+          <p:cNvCxnSpPr/>
+          <p:nvPr/>
+        </p:nvCxnSpPr>
+        <p:spPr>
+          <a:xfrm>
+            <a:off x="927100" y="4635500"/>
+            <a:ext cx="38100" cy="38100"/>
+          </a:xfrm>
+          <a:prstGeom prst="line">
+            <a:avLst/>
+          </a:prstGeom>
+          <a:ln w="19050">
+            <a:solidFill>
+              <a:srgbClr val="2762C8"/>
+            </a:solidFill>
+          </a:ln>
+        </p:spPr>
+        <p:style>
+          <a:lnRef idx="2">
+            <a:schemeClr val="accent1"/>
+          </a:lnRef>
+          <a:fillRef idx="0">
+            <a:schemeClr val="accent1"/>
+          </a:fillRef>
+          <a:effectRef idx="1">
+            <a:schemeClr val="accent1"/>
+          </a:effectRef>
+          <a:fontRef idx="minor">
+            <a:schemeClr val="tx1"/>
+          </a:fontRef>
+        </p:style>
+      </p:cxnSp>
+      <p:cxnSp>
+        <p:nvCxnSpPr>
+          <p:cNvPr id="27" name="Connector 26"/>
+          <p:cNvCxnSpPr/>
+          <p:nvPr/>
+        </p:nvCxnSpPr>
+        <p:spPr>
+          <a:xfrm flipV="1">
+            <a:off x="965200" y="4584700"/>
+            <a:ext cx="76200" cy="88900"/>
+          </a:xfrm>
+          <a:prstGeom prst="line">
+            <a:avLst/>
+          </a:prstGeom>
+          <a:ln w="19050">
+            <a:solidFill>
+              <a:srgbClr val="2762C8"/>
+            </a:solidFill>
+          </a:ln>
+        </p:spPr>
+        <p:style>
+          <a:lnRef idx="2">
+            <a:schemeClr val="accent1"/>
+          </a:lnRef>
+          <a:fillRef idx="0">
+            <a:schemeClr val="accent1"/>
+          </a:fillRef>
+          <a:effectRef idx="1">
+            <a:schemeClr val="accent1"/>
+          </a:effectRef>
+          <a:fontRef idx="minor">
+            <a:schemeClr val="tx1"/>
+          </a:fontRef>
+        </p:style>
+      </p:cxnSp>
+      <p:sp>
+        <p:nvSpPr>
+          <p:cNvPr id="28" name="TextBox 27"/>
+          <p:cNvSpPr txBox="1"/>
+          <p:nvPr/>
+        </p:nvSpPr>
+        <p:spPr>
+          <a:xfrm>
+            <a:off x="1219200" y="4508500"/>
+            <a:ext cx="2616200" cy="300990"/>
+          </a:xfrm>
+          <a:prstGeom prst="rect">
+            <a:avLst/>
+          </a:prstGeom>
+          <a:noFill/>
+        </p:spPr>
+        <p:txBody>
+          <a:bodyPr wrap="none" lIns="0" rIns="0" tIns="0" bIns="0" anchor="t">
+            <a:noAutofit/>
+          </a:bodyPr>
+          <a:lstStyle/>
+          <a:p>
+            <a:pPr algn="l">
+              <a:lnSpc>
+                <a:spcPts val="2070"/>
+              </a:lnSpc>
+              <a:spcBef>
+                <a:spcPts val="0"/>
+              </a:spcBef>
+              <a:spcAft>
+                <a:spcPts val="0"/>
+              </a:spcAft>
+            </a:pPr>
+            <a:r>
+              <a:rPr sz="1800" b="1">
+                <a:solidFill>
+                  <a:srgbClr val="142338"/>
+                </a:solidFill>
+                <a:latin typeface="Arial"/>
+              </a:rPr>
+              <a:t>Istio VirtualService</a:t>
+            </a:r>
+          </a:p>
+        </p:txBody>
+      </p:sp>
+      <p:sp>
+        <p:nvSpPr>
+          <p:cNvPr id="29" name="Oval 28"/>
           <p:cNvSpPr/>
           <p:nvPr/>
         </p:nvSpPr>
         <p:spPr>
           <a:xfrm>
-            <a:off x="6400800" y="2095500"/>
-            <a:ext cx="5181600" cy="1917700"/>
+            <a:off x="863600" y="5003800"/>
+            <a:ext cx="228600" cy="228600"/>
+          </a:xfrm>
+          <a:prstGeom prst="ellipse">
+            <a:avLst/>
+          </a:prstGeom>
+          <a:solidFill>
+            <a:srgbClr val="EAF0FB"/>
+          </a:solidFill>
+          <a:ln>
+            <a:noFill/>
+          </a:ln>
+          <a:effectLst/>
+        </p:spPr>
+        <p:style>
+          <a:lnRef idx="1">
+            <a:schemeClr val="accent1"/>
+          </a:lnRef>
+          <a:fillRef idx="3">
+            <a:schemeClr val="accent1"/>
+          </a:fillRef>
+          <a:effectRef idx="2">
+            <a:schemeClr val="accent1"/>
+          </a:effectRef>
+          <a:fontRef idx="minor">
+            <a:schemeClr val="lt1"/>
+          </a:fontRef>
+        </p:style>
+        <p:txBody>
+          <a:bodyPr rtlCol="0" anchor="ctr"/>
+          <a:lstStyle/>
+          <a:p>
+            <a:pPr algn="ctr"/>
+          </a:p>
+        </p:txBody>
+      </p:sp>
+      <p:cxnSp>
+        <p:nvCxnSpPr>
+          <p:cNvPr id="30" name="Connector 29"/>
+          <p:cNvCxnSpPr/>
+          <p:nvPr/>
+        </p:nvCxnSpPr>
+        <p:spPr>
+          <a:xfrm>
+            <a:off x="927100" y="5118100"/>
+            <a:ext cx="38100" cy="38100"/>
+          </a:xfrm>
+          <a:prstGeom prst="line">
+            <a:avLst/>
+          </a:prstGeom>
+          <a:ln w="19050">
+            <a:solidFill>
+              <a:srgbClr val="2762C8"/>
+            </a:solidFill>
+          </a:ln>
+        </p:spPr>
+        <p:style>
+          <a:lnRef idx="2">
+            <a:schemeClr val="accent1"/>
+          </a:lnRef>
+          <a:fillRef idx="0">
+            <a:schemeClr val="accent1"/>
+          </a:fillRef>
+          <a:effectRef idx="1">
+            <a:schemeClr val="accent1"/>
+          </a:effectRef>
+          <a:fontRef idx="minor">
+            <a:schemeClr val="tx1"/>
+          </a:fontRef>
+        </p:style>
+      </p:cxnSp>
+      <p:cxnSp>
+        <p:nvCxnSpPr>
+          <p:cNvPr id="31" name="Connector 30"/>
+          <p:cNvCxnSpPr/>
+          <p:nvPr/>
+        </p:nvCxnSpPr>
+        <p:spPr>
+          <a:xfrm flipV="1">
+            <a:off x="965200" y="5067300"/>
+            <a:ext cx="76200" cy="88900"/>
+          </a:xfrm>
+          <a:prstGeom prst="line">
+            <a:avLst/>
+          </a:prstGeom>
+          <a:ln w="19050">
+            <a:solidFill>
+              <a:srgbClr val="2762C8"/>
+            </a:solidFill>
+          </a:ln>
+        </p:spPr>
+        <p:style>
+          <a:lnRef idx="2">
+            <a:schemeClr val="accent1"/>
+          </a:lnRef>
+          <a:fillRef idx="0">
+            <a:schemeClr val="accent1"/>
+          </a:fillRef>
+          <a:effectRef idx="1">
+            <a:schemeClr val="accent1"/>
+          </a:effectRef>
+          <a:fontRef idx="minor">
+            <a:schemeClr val="tx1"/>
+          </a:fontRef>
+        </p:style>
+      </p:cxnSp>
+      <p:sp>
+        <p:nvSpPr>
+          <p:cNvPr id="32" name="TextBox 31"/>
+          <p:cNvSpPr txBox="1"/>
+          <p:nvPr/>
+        </p:nvSpPr>
+        <p:spPr>
+          <a:xfrm>
+            <a:off x="1219200" y="4991100"/>
+            <a:ext cx="2616200" cy="300990"/>
+          </a:xfrm>
+          <a:prstGeom prst="rect">
+            <a:avLst/>
+          </a:prstGeom>
+          <a:noFill/>
+        </p:spPr>
+        <p:txBody>
+          <a:bodyPr wrap="none" lIns="0" rIns="0" tIns="0" bIns="0" anchor="t">
+            <a:noAutofit/>
+          </a:bodyPr>
+          <a:lstStyle/>
+          <a:p>
+            <a:pPr algn="l">
+              <a:lnSpc>
+                <a:spcPts val="2070"/>
+              </a:lnSpc>
+              <a:spcBef>
+                <a:spcPts val="0"/>
+              </a:spcBef>
+              <a:spcAft>
+                <a:spcPts val="0"/>
+              </a:spcAft>
+            </a:pPr>
+            <a:r>
+              <a:rPr sz="1800" b="1">
+                <a:solidFill>
+                  <a:srgbClr val="142338"/>
+                </a:solidFill>
+                <a:latin typeface="Arial"/>
+              </a:rPr>
+              <a:t>LoadBalancer Service</a:t>
+            </a:r>
+          </a:p>
+        </p:txBody>
+      </p:sp>
+      <p:sp>
+        <p:nvSpPr>
+          <p:cNvPr id="33" name="TextBox 32"/>
+          <p:cNvSpPr txBox="1"/>
+          <p:nvPr/>
+        </p:nvSpPr>
+        <p:spPr>
+          <a:xfrm>
+            <a:off x="4445000" y="2044700"/>
+            <a:ext cx="7137400" cy="213359"/>
+          </a:xfrm>
+          <a:prstGeom prst="rect">
+            <a:avLst/>
+          </a:prstGeom>
+          <a:noFill/>
+        </p:spPr>
+        <p:txBody>
+          <a:bodyPr wrap="none" lIns="0" rIns="0" tIns="0" bIns="0" anchor="t">
+            <a:noAutofit/>
+          </a:bodyPr>
+          <a:lstStyle/>
+          <a:p>
+            <a:pPr algn="l">
+              <a:lnSpc>
+                <a:spcPts val="1380"/>
+              </a:lnSpc>
+              <a:spcBef>
+                <a:spcPts val="0"/>
+              </a:spcBef>
+              <a:spcAft>
+                <a:spcPts val="0"/>
+              </a:spcAft>
+            </a:pPr>
+            <a:r>
+              <a:rPr sz="1200" b="1">
+                <a:solidFill>
+                  <a:srgbClr val="CF0035"/>
+                </a:solidFill>
+                <a:latin typeface="Arial"/>
+              </a:rPr>
+              <a:t>AUTOMATED PARENT-ZONE DELEGATION</a:t>
+            </a:r>
+          </a:p>
+        </p:txBody>
+      </p:sp>
+      <p:sp>
+        <p:nvSpPr>
+          <p:cNvPr id="34" name="Rounded Rectangle 33"/>
+          <p:cNvSpPr/>
+          <p:nvPr/>
+        </p:nvSpPr>
+        <p:spPr>
+          <a:xfrm>
+            <a:off x="4445000" y="2451100"/>
+            <a:ext cx="2235200" cy="990600"/>
           </a:xfrm>
           <a:prstGeom prst="roundRect">
             <a:avLst>
-              <a:gd name="adj" fmla="val 6622"/>
+              <a:gd name="adj" fmla="val 10256"/>
             </a:avLst>
           </a:prstGeom>
           <a:solidFill>
@@ -11350,97 +11954,40 @@
           </a:p>
         </p:txBody>
       </p:sp>
-      <p:cxnSp>
-        <p:nvCxnSpPr>
-          <p:cNvPr id="20" name="Connector 19"/>
-          <p:cNvCxnSpPr/>
-          <p:nvPr/>
-        </p:nvCxnSpPr>
-        <p:spPr>
-          <a:xfrm>
-            <a:off x="6705600" y="2108200"/>
-            <a:ext cx="4572000" cy="0"/>
-          </a:xfrm>
-          <a:prstGeom prst="line">
-            <a:avLst/>
-          </a:prstGeom>
-          <a:ln w="38100">
-            <a:solidFill>
-              <a:srgbClr val="087F85"/>
-            </a:solidFill>
-          </a:ln>
-        </p:spPr>
-        <p:style>
-          <a:lnRef idx="2">
-            <a:schemeClr val="accent1"/>
-          </a:lnRef>
-          <a:fillRef idx="0">
-            <a:schemeClr val="accent1"/>
-          </a:fillRef>
-          <a:effectRef idx="1">
-            <a:schemeClr val="accent1"/>
-          </a:effectRef>
-          <a:fontRef idx="minor">
-            <a:schemeClr val="tx1"/>
-          </a:fontRef>
-        </p:style>
-      </p:cxnSp>
-      <p:sp>
-        <p:nvSpPr>
-          <p:cNvPr id="21" name="Rounded Rectangle 20"/>
-          <p:cNvSpPr/>
-          <p:nvPr/>
-        </p:nvSpPr>
-        <p:spPr>
-          <a:xfrm>
-            <a:off x="6705600" y="2349500"/>
-            <a:ext cx="812800" cy="812800"/>
-          </a:xfrm>
-          <a:prstGeom prst="roundRect">
-            <a:avLst>
-              <a:gd name="adj" fmla="val 18750"/>
-            </a:avLst>
-          </a:prstGeom>
-          <a:solidFill>
-            <a:srgbClr val="E8F4F3"/>
-          </a:solidFill>
-          <a:ln>
-            <a:noFill/>
-          </a:ln>
-          <a:effectLst/>
-        </p:spPr>
-        <p:style>
-          <a:lnRef idx="1">
-            <a:schemeClr val="accent1"/>
-          </a:lnRef>
-          <a:fillRef idx="3">
-            <a:schemeClr val="accent1"/>
-          </a:fillRef>
-          <a:effectRef idx="2">
-            <a:schemeClr val="accent1"/>
-          </a:effectRef>
-          <a:fontRef idx="minor">
-            <a:schemeClr val="lt1"/>
-          </a:fontRef>
-        </p:style>
-        <p:txBody>
-          <a:bodyPr rtlCol="0" anchor="ctr"/>
-          <a:lstStyle/>
-          <a:p>
-            <a:pPr algn="ctr"/>
-          </a:p>
-        </p:txBody>
-      </p:sp>
-      <p:sp>
-        <p:nvSpPr>
-          <p:cNvPr id="22" name="TextBox 21"/>
+      <p:pic>
+        <p:nvPicPr>
+          <p:cNvPr id="35" name="Picture 34" descr="image.png"/>
+          <p:cNvPicPr>
+            <a:picLocks noChangeAspect="1"/>
+          </p:cNvPicPr>
+          <p:nvPr/>
+        </p:nvPicPr>
+        <p:blipFill>
+          <a:blip r:embed="rId3"/>
+          <a:stretch>
+            <a:fillRect/>
+          </a:stretch>
+        </p:blipFill>
+        <p:spPr>
+          <a:xfrm>
+            <a:off x="5159088" y="2552700"/>
+            <a:ext cx="807023" cy="482600"/>
+          </a:xfrm>
+          <a:prstGeom prst="rect">
+            <a:avLst/>
+          </a:prstGeom>
+        </p:spPr>
+      </p:pic>
+      <p:sp>
+        <p:nvSpPr>
+          <p:cNvPr id="36" name="TextBox 35"/>
           <p:cNvSpPr txBox="1"/>
           <p:nvPr/>
         </p:nvSpPr>
         <p:spPr>
           <a:xfrm>
-            <a:off x="7721600" y="2374900"/>
-            <a:ext cx="3556000" cy="403224"/>
+            <a:off x="4546600" y="3149600"/>
+            <a:ext cx="2032000" cy="230187"/>
           </a:xfrm>
           <a:prstGeom prst="rect">
             <a:avLst/>
@@ -11453,9 +12000,9 @@
           </a:bodyPr>
           <a:lstStyle/>
           <a:p>
-            <a:pPr algn="l">
+            <a:pPr algn="ctr">
               <a:lnSpc>
-                <a:spcPts val="2874"/>
+                <a:spcPts val="1450"/>
               </a:lnSpc>
               <a:spcBef>
                 <a:spcPts val="0"/>
@@ -11465,1027 +12012,31 @@
               </a:spcAft>
             </a:pPr>
             <a:r>
-              <a:rPr sz="2500" b="1">
+              <a:rPr sz="1450" b="1">
                 <a:solidFill>
                   <a:srgbClr val="142338"/>
                 </a:solidFill>
                 <a:latin typeface="Arial"/>
               </a:rPr>
-              <a:t>Self-hosted DNS</a:t>
-            </a:r>
-          </a:p>
-        </p:txBody>
-      </p:sp>
-      <p:sp>
-        <p:nvSpPr>
-          <p:cNvPr id="23" name="TextBox 22"/>
-          <p:cNvSpPr txBox="1"/>
-          <p:nvPr/>
-        </p:nvSpPr>
-        <p:spPr>
-          <a:xfrm>
-            <a:off x="7721600" y="2819400"/>
-            <a:ext cx="3556000" cy="257175"/>
-          </a:xfrm>
-          <a:prstGeom prst="rect">
-            <a:avLst/>
-          </a:prstGeom>
-          <a:noFill/>
-        </p:spPr>
-        <p:txBody>
-          <a:bodyPr wrap="none" lIns="0" rIns="0" tIns="0" bIns="0" anchor="t">
-            <a:noAutofit/>
-          </a:bodyPr>
-          <a:lstStyle/>
-          <a:p>
-            <a:pPr algn="l">
-              <a:lnSpc>
-                <a:spcPts val="1725"/>
-              </a:lnSpc>
-              <a:spcBef>
-                <a:spcPts val="0"/>
-              </a:spcBef>
-              <a:spcAft>
-                <a:spcPts val="0"/>
-              </a:spcAft>
-            </a:pPr>
-            <a:r>
-              <a:rPr sz="1500" b="0">
-                <a:solidFill>
-                  <a:srgbClr val="5D6F82"/>
-                </a:solidFill>
-                <a:latin typeface="Arial"/>
-              </a:rPr>
-              <a:t>Operated by your team · BIND9</a:t>
-            </a:r>
-          </a:p>
-        </p:txBody>
-      </p:sp>
-      <p:sp>
-        <p:nvSpPr>
-          <p:cNvPr id="24" name="Rounded Rectangle 23"/>
+              <a:t>AWS Route 53</a:t>
+            </a:r>
+          </a:p>
+        </p:txBody>
+      </p:sp>
+      <p:sp>
+        <p:nvSpPr>
+          <p:cNvPr id="37" name="Rounded Rectangle 36"/>
           <p:cNvSpPr/>
           <p:nvPr/>
         </p:nvSpPr>
         <p:spPr>
           <a:xfrm>
-            <a:off x="6705600" y="3403600"/>
-            <a:ext cx="4572000" cy="393700"/>
+            <a:off x="6896100" y="2451100"/>
+            <a:ext cx="2235200" cy="990600"/>
           </a:xfrm>
           <a:prstGeom prst="roundRect">
             <a:avLst>
-              <a:gd name="adj" fmla="val 19354"/>
-            </a:avLst>
-          </a:prstGeom>
-          <a:solidFill>
-            <a:srgbClr val="E8F4F3"/>
-          </a:solidFill>
-          <a:ln>
-            <a:noFill/>
-          </a:ln>
-          <a:effectLst/>
-        </p:spPr>
-        <p:style>
-          <a:lnRef idx="1">
-            <a:schemeClr val="accent1"/>
-          </a:lnRef>
-          <a:fillRef idx="3">
-            <a:schemeClr val="accent1"/>
-          </a:fillRef>
-          <a:effectRef idx="2">
-            <a:schemeClr val="accent1"/>
-          </a:effectRef>
-          <a:fontRef idx="minor">
-            <a:schemeClr val="lt1"/>
-          </a:fontRef>
-        </p:style>
-        <p:txBody>
-          <a:bodyPr rtlCol="0" anchor="ctr"/>
-          <a:lstStyle/>
-          <a:p>
-            <a:pPr algn="ctr"/>
-          </a:p>
-        </p:txBody>
-      </p:sp>
-      <p:sp>
-        <p:nvSpPr>
-          <p:cNvPr id="25" name="TextBox 24"/>
-          <p:cNvSpPr txBox="1"/>
-          <p:nvPr/>
-        </p:nvSpPr>
-        <p:spPr>
-          <a:xfrm>
-            <a:off x="6858000" y="3467100"/>
-            <a:ext cx="4267200" cy="301625"/>
-          </a:xfrm>
-          <a:prstGeom prst="rect">
-            <a:avLst/>
-          </a:prstGeom>
-          <a:noFill/>
-        </p:spPr>
-        <p:txBody>
-          <a:bodyPr wrap="none" lIns="0" rIns="0" tIns="0" bIns="0" anchor="t">
-            <a:noAutofit/>
-          </a:bodyPr>
-          <a:lstStyle/>
-          <a:p>
-            <a:pPr algn="ctr">
-              <a:lnSpc>
-                <a:spcPts val="1900"/>
-              </a:lnSpc>
-              <a:spcBef>
-                <a:spcPts val="0"/>
-              </a:spcBef>
-              <a:spcAft>
-                <a:spcPts val="0"/>
-              </a:spcAft>
-            </a:pPr>
-            <a:r>
-              <a:rPr sz="1900" b="1">
-                <a:solidFill>
-                  <a:srgbClr val="087F85"/>
-                </a:solidFill>
-                <a:latin typeface="Arial"/>
-              </a:rPr>
-              <a:t>RFC 2136 + TSIG</a:t>
-            </a:r>
-          </a:p>
-        </p:txBody>
-      </p:sp>
-      <p:sp>
-        <p:nvSpPr>
-          <p:cNvPr id="26" name="Oval 25"/>
-          <p:cNvSpPr/>
-          <p:nvPr/>
-        </p:nvSpPr>
-        <p:spPr>
-          <a:xfrm>
-            <a:off x="1003300" y="2654300"/>
-            <a:ext cx="254000" cy="254000"/>
-          </a:xfrm>
-          <a:prstGeom prst="ellipse">
-            <a:avLst/>
-          </a:prstGeom>
-          <a:solidFill>
-            <a:srgbClr val="2762C8"/>
-          </a:solidFill>
-          <a:ln>
-            <a:noFill/>
-          </a:ln>
-          <a:effectLst/>
-        </p:spPr>
-        <p:style>
-          <a:lnRef idx="1">
-            <a:schemeClr val="accent1"/>
-          </a:lnRef>
-          <a:fillRef idx="3">
-            <a:schemeClr val="accent1"/>
-          </a:fillRef>
-          <a:effectRef idx="2">
-            <a:schemeClr val="accent1"/>
-          </a:effectRef>
-          <a:fontRef idx="minor">
-            <a:schemeClr val="lt1"/>
-          </a:fontRef>
-        </p:style>
-        <p:txBody>
-          <a:bodyPr rtlCol="0" anchor="ctr"/>
-          <a:lstStyle/>
-          <a:p>
-            <a:pPr algn="ctr"/>
-          </a:p>
-        </p:txBody>
-      </p:sp>
-      <p:sp>
-        <p:nvSpPr>
-          <p:cNvPr id="27" name="Oval 26"/>
-          <p:cNvSpPr/>
-          <p:nvPr/>
-        </p:nvSpPr>
-        <p:spPr>
-          <a:xfrm>
-            <a:off x="1117600" y="2489200"/>
-            <a:ext cx="330200" cy="330200"/>
-          </a:xfrm>
-          <a:prstGeom prst="ellipse">
-            <a:avLst/>
-          </a:prstGeom>
-          <a:solidFill>
-            <a:srgbClr val="2762C8"/>
-          </a:solidFill>
-          <a:ln>
-            <a:noFill/>
-          </a:ln>
-          <a:effectLst/>
-        </p:spPr>
-        <p:style>
-          <a:lnRef idx="1">
-            <a:schemeClr val="accent1"/>
-          </a:lnRef>
-          <a:fillRef idx="3">
-            <a:schemeClr val="accent1"/>
-          </a:fillRef>
-          <a:effectRef idx="2">
-            <a:schemeClr val="accent1"/>
-          </a:effectRef>
-          <a:fontRef idx="minor">
-            <a:schemeClr val="lt1"/>
-          </a:fontRef>
-        </p:style>
-        <p:txBody>
-          <a:bodyPr rtlCol="0" anchor="ctr"/>
-          <a:lstStyle/>
-          <a:p>
-            <a:pPr algn="ctr"/>
-          </a:p>
-        </p:txBody>
-      </p:sp>
-      <p:sp>
-        <p:nvSpPr>
-          <p:cNvPr id="28" name="Oval 27"/>
-          <p:cNvSpPr/>
-          <p:nvPr/>
-        </p:nvSpPr>
-        <p:spPr>
-          <a:xfrm>
-            <a:off x="1333500" y="2628900"/>
-            <a:ext cx="279400" cy="279400"/>
-          </a:xfrm>
-          <a:prstGeom prst="ellipse">
-            <a:avLst/>
-          </a:prstGeom>
-          <a:solidFill>
-            <a:srgbClr val="2762C8"/>
-          </a:solidFill>
-          <a:ln>
-            <a:noFill/>
-          </a:ln>
-          <a:effectLst/>
-        </p:spPr>
-        <p:style>
-          <a:lnRef idx="1">
-            <a:schemeClr val="accent1"/>
-          </a:lnRef>
-          <a:fillRef idx="3">
-            <a:schemeClr val="accent1"/>
-          </a:fillRef>
-          <a:effectRef idx="2">
-            <a:schemeClr val="accent1"/>
-          </a:effectRef>
-          <a:fontRef idx="minor">
-            <a:schemeClr val="lt1"/>
-          </a:fontRef>
-        </p:style>
-        <p:txBody>
-          <a:bodyPr rtlCol="0" anchor="ctr"/>
-          <a:lstStyle/>
-          <a:p>
-            <a:pPr algn="ctr"/>
-          </a:p>
-        </p:txBody>
-      </p:sp>
-      <p:sp>
-        <p:nvSpPr>
-          <p:cNvPr id="29" name="Rectangle 28"/>
-          <p:cNvSpPr/>
-          <p:nvPr/>
-        </p:nvSpPr>
-        <p:spPr>
-          <a:xfrm>
-            <a:off x="1130300" y="2768600"/>
-            <a:ext cx="342900" cy="139700"/>
-          </a:xfrm>
-          <a:prstGeom prst="rect">
-            <a:avLst/>
-          </a:prstGeom>
-          <a:solidFill>
-            <a:srgbClr val="2762C8"/>
-          </a:solidFill>
-          <a:ln>
-            <a:noFill/>
-          </a:ln>
-          <a:effectLst/>
-        </p:spPr>
-        <p:style>
-          <a:lnRef idx="1">
-            <a:schemeClr val="accent1"/>
-          </a:lnRef>
-          <a:fillRef idx="3">
-            <a:schemeClr val="accent1"/>
-          </a:fillRef>
-          <a:effectRef idx="2">
-            <a:schemeClr val="accent1"/>
-          </a:effectRef>
-          <a:fontRef idx="minor">
-            <a:schemeClr val="lt1"/>
-          </a:fontRef>
-        </p:style>
-        <p:txBody>
-          <a:bodyPr rtlCol="0" anchor="ctr"/>
-          <a:lstStyle/>
-          <a:p>
-            <a:pPr algn="ctr"/>
-          </a:p>
-        </p:txBody>
-      </p:sp>
-      <p:sp>
-        <p:nvSpPr>
-          <p:cNvPr id="30" name="Rounded Rectangle 29"/>
-          <p:cNvSpPr/>
-          <p:nvPr/>
-        </p:nvSpPr>
-        <p:spPr>
-          <a:xfrm>
-            <a:off x="6858000" y="2489200"/>
-            <a:ext cx="508000" cy="127000"/>
-          </a:xfrm>
-          <a:prstGeom prst="roundRect">
-            <a:avLst>
-              <a:gd name="adj" fmla="val 20000"/>
-            </a:avLst>
-          </a:prstGeom>
-          <a:solidFill>
-            <a:srgbClr val="FFFFFF"/>
-          </a:solidFill>
-          <a:ln w="16510">
-            <a:solidFill>
-              <a:srgbClr val="087F85"/>
-            </a:solidFill>
-          </a:ln>
-          <a:effectLst/>
-        </p:spPr>
-        <p:style>
-          <a:lnRef idx="1">
-            <a:schemeClr val="accent1"/>
-          </a:lnRef>
-          <a:fillRef idx="3">
-            <a:schemeClr val="accent1"/>
-          </a:fillRef>
-          <a:effectRef idx="2">
-            <a:schemeClr val="accent1"/>
-          </a:effectRef>
-          <a:fontRef idx="minor">
-            <a:schemeClr val="lt1"/>
-          </a:fontRef>
-        </p:style>
-        <p:txBody>
-          <a:bodyPr rtlCol="0" anchor="ctr"/>
-          <a:lstStyle/>
-          <a:p>
-            <a:pPr algn="ctr"/>
-          </a:p>
-        </p:txBody>
-      </p:sp>
-      <p:cxnSp>
-        <p:nvCxnSpPr>
-          <p:cNvPr id="31" name="Connector 30"/>
-          <p:cNvCxnSpPr/>
-          <p:nvPr/>
-        </p:nvCxnSpPr>
-        <p:spPr>
-          <a:xfrm>
-            <a:off x="6934200" y="2552700"/>
-            <a:ext cx="177800" cy="0"/>
-          </a:xfrm>
-          <a:prstGeom prst="line">
-            <a:avLst/>
-          </a:prstGeom>
-          <a:ln w="15240">
-            <a:solidFill>
-              <a:srgbClr val="087F85"/>
-            </a:solidFill>
-          </a:ln>
-        </p:spPr>
-        <p:style>
-          <a:lnRef idx="2">
-            <a:schemeClr val="accent1"/>
-          </a:lnRef>
-          <a:fillRef idx="0">
-            <a:schemeClr val="accent1"/>
-          </a:fillRef>
-          <a:effectRef idx="1">
-            <a:schemeClr val="accent1"/>
-          </a:effectRef>
-          <a:fontRef idx="minor">
-            <a:schemeClr val="tx1"/>
-          </a:fontRef>
-        </p:style>
-      </p:cxnSp>
-      <p:sp>
-        <p:nvSpPr>
-          <p:cNvPr id="32" name="Oval 31"/>
-          <p:cNvSpPr/>
-          <p:nvPr/>
-        </p:nvSpPr>
-        <p:spPr>
-          <a:xfrm>
-            <a:off x="7258050" y="2533650"/>
-            <a:ext cx="38100" cy="38100"/>
-          </a:xfrm>
-          <a:prstGeom prst="ellipse">
-            <a:avLst/>
-          </a:prstGeom>
-          <a:solidFill>
-            <a:srgbClr val="087F85"/>
-          </a:solidFill>
-          <a:ln>
-            <a:noFill/>
-          </a:ln>
-          <a:effectLst/>
-        </p:spPr>
-        <p:style>
-          <a:lnRef idx="1">
-            <a:schemeClr val="accent1"/>
-          </a:lnRef>
-          <a:fillRef idx="3">
-            <a:schemeClr val="accent1"/>
-          </a:fillRef>
-          <a:effectRef idx="2">
-            <a:schemeClr val="accent1"/>
-          </a:effectRef>
-          <a:fontRef idx="minor">
-            <a:schemeClr val="lt1"/>
-          </a:fontRef>
-        </p:style>
-        <p:txBody>
-          <a:bodyPr rtlCol="0" anchor="ctr"/>
-          <a:lstStyle/>
-          <a:p>
-            <a:pPr algn="ctr"/>
-          </a:p>
-        </p:txBody>
-      </p:sp>
-      <p:sp>
-        <p:nvSpPr>
-          <p:cNvPr id="33" name="Rounded Rectangle 32"/>
-          <p:cNvSpPr/>
-          <p:nvPr/>
-        </p:nvSpPr>
-        <p:spPr>
-          <a:xfrm>
-            <a:off x="6858000" y="2679700"/>
-            <a:ext cx="508000" cy="127000"/>
-          </a:xfrm>
-          <a:prstGeom prst="roundRect">
-            <a:avLst>
-              <a:gd name="adj" fmla="val 20000"/>
-            </a:avLst>
-          </a:prstGeom>
-          <a:solidFill>
-            <a:srgbClr val="FFFFFF"/>
-          </a:solidFill>
-          <a:ln w="16510">
-            <a:solidFill>
-              <a:srgbClr val="087F85"/>
-            </a:solidFill>
-          </a:ln>
-          <a:effectLst/>
-        </p:spPr>
-        <p:style>
-          <a:lnRef idx="1">
-            <a:schemeClr val="accent1"/>
-          </a:lnRef>
-          <a:fillRef idx="3">
-            <a:schemeClr val="accent1"/>
-          </a:fillRef>
-          <a:effectRef idx="2">
-            <a:schemeClr val="accent1"/>
-          </a:effectRef>
-          <a:fontRef idx="minor">
-            <a:schemeClr val="lt1"/>
-          </a:fontRef>
-        </p:style>
-        <p:txBody>
-          <a:bodyPr rtlCol="0" anchor="ctr"/>
-          <a:lstStyle/>
-          <a:p>
-            <a:pPr algn="ctr"/>
-          </a:p>
-        </p:txBody>
-      </p:sp>
-      <p:cxnSp>
-        <p:nvCxnSpPr>
-          <p:cNvPr id="34" name="Connector 33"/>
-          <p:cNvCxnSpPr/>
-          <p:nvPr/>
-        </p:nvCxnSpPr>
-        <p:spPr>
-          <a:xfrm>
-            <a:off x="6934200" y="2743200"/>
-            <a:ext cx="177800" cy="0"/>
-          </a:xfrm>
-          <a:prstGeom prst="line">
-            <a:avLst/>
-          </a:prstGeom>
-          <a:ln w="15240">
-            <a:solidFill>
-              <a:srgbClr val="087F85"/>
-            </a:solidFill>
-          </a:ln>
-        </p:spPr>
-        <p:style>
-          <a:lnRef idx="2">
-            <a:schemeClr val="accent1"/>
-          </a:lnRef>
-          <a:fillRef idx="0">
-            <a:schemeClr val="accent1"/>
-          </a:fillRef>
-          <a:effectRef idx="1">
-            <a:schemeClr val="accent1"/>
-          </a:effectRef>
-          <a:fontRef idx="minor">
-            <a:schemeClr val="tx1"/>
-          </a:fontRef>
-        </p:style>
-      </p:cxnSp>
-      <p:sp>
-        <p:nvSpPr>
-          <p:cNvPr id="35" name="Oval 34"/>
-          <p:cNvSpPr/>
-          <p:nvPr/>
-        </p:nvSpPr>
-        <p:spPr>
-          <a:xfrm>
-            <a:off x="7258050" y="2724150"/>
-            <a:ext cx="38100" cy="38100"/>
-          </a:xfrm>
-          <a:prstGeom prst="ellipse">
-            <a:avLst/>
-          </a:prstGeom>
-          <a:solidFill>
-            <a:srgbClr val="087F85"/>
-          </a:solidFill>
-          <a:ln>
-            <a:noFill/>
-          </a:ln>
-          <a:effectLst/>
-        </p:spPr>
-        <p:style>
-          <a:lnRef idx="1">
-            <a:schemeClr val="accent1"/>
-          </a:lnRef>
-          <a:fillRef idx="3">
-            <a:schemeClr val="accent1"/>
-          </a:fillRef>
-          <a:effectRef idx="2">
-            <a:schemeClr val="accent1"/>
-          </a:effectRef>
-          <a:fontRef idx="minor">
-            <a:schemeClr val="lt1"/>
-          </a:fontRef>
-        </p:style>
-        <p:txBody>
-          <a:bodyPr rtlCol="0" anchor="ctr"/>
-          <a:lstStyle/>
-          <a:p>
-            <a:pPr algn="ctr"/>
-          </a:p>
-        </p:txBody>
-      </p:sp>
-      <p:sp>
-        <p:nvSpPr>
-          <p:cNvPr id="36" name="Rounded Rectangle 35"/>
-          <p:cNvSpPr/>
-          <p:nvPr/>
-        </p:nvSpPr>
-        <p:spPr>
-          <a:xfrm>
-            <a:off x="6858000" y="2870200"/>
-            <a:ext cx="508000" cy="127000"/>
-          </a:xfrm>
-          <a:prstGeom prst="roundRect">
-            <a:avLst>
-              <a:gd name="adj" fmla="val 20000"/>
-            </a:avLst>
-          </a:prstGeom>
-          <a:solidFill>
-            <a:srgbClr val="FFFFFF"/>
-          </a:solidFill>
-          <a:ln w="16510">
-            <a:solidFill>
-              <a:srgbClr val="087F85"/>
-            </a:solidFill>
-          </a:ln>
-          <a:effectLst/>
-        </p:spPr>
-        <p:style>
-          <a:lnRef idx="1">
-            <a:schemeClr val="accent1"/>
-          </a:lnRef>
-          <a:fillRef idx="3">
-            <a:schemeClr val="accent1"/>
-          </a:fillRef>
-          <a:effectRef idx="2">
-            <a:schemeClr val="accent1"/>
-          </a:effectRef>
-          <a:fontRef idx="minor">
-            <a:schemeClr val="lt1"/>
-          </a:fontRef>
-        </p:style>
-        <p:txBody>
-          <a:bodyPr rtlCol="0" anchor="ctr"/>
-          <a:lstStyle/>
-          <a:p>
-            <a:pPr algn="ctr"/>
-          </a:p>
-        </p:txBody>
-      </p:sp>
-      <p:cxnSp>
-        <p:nvCxnSpPr>
-          <p:cNvPr id="37" name="Connector 36"/>
-          <p:cNvCxnSpPr/>
-          <p:nvPr/>
-        </p:nvCxnSpPr>
-        <p:spPr>
-          <a:xfrm>
-            <a:off x="6934200" y="2933700"/>
-            <a:ext cx="177800" cy="0"/>
-          </a:xfrm>
-          <a:prstGeom prst="line">
-            <a:avLst/>
-          </a:prstGeom>
-          <a:ln w="15240">
-            <a:solidFill>
-              <a:srgbClr val="087F85"/>
-            </a:solidFill>
-          </a:ln>
-        </p:spPr>
-        <p:style>
-          <a:lnRef idx="2">
-            <a:schemeClr val="accent1"/>
-          </a:lnRef>
-          <a:fillRef idx="0">
-            <a:schemeClr val="accent1"/>
-          </a:fillRef>
-          <a:effectRef idx="1">
-            <a:schemeClr val="accent1"/>
-          </a:effectRef>
-          <a:fontRef idx="minor">
-            <a:schemeClr val="tx1"/>
-          </a:fontRef>
-        </p:style>
-      </p:cxnSp>
-      <p:sp>
-        <p:nvSpPr>
-          <p:cNvPr id="38" name="Oval 37"/>
-          <p:cNvSpPr/>
-          <p:nvPr/>
-        </p:nvSpPr>
-        <p:spPr>
-          <a:xfrm>
-            <a:off x="7258050" y="2914650"/>
-            <a:ext cx="38100" cy="38100"/>
-          </a:xfrm>
-          <a:prstGeom prst="ellipse">
-            <a:avLst/>
-          </a:prstGeom>
-          <a:solidFill>
-            <a:srgbClr val="087F85"/>
-          </a:solidFill>
-          <a:ln>
-            <a:noFill/>
-          </a:ln>
-          <a:effectLst/>
-        </p:spPr>
-        <p:style>
-          <a:lnRef idx="1">
-            <a:schemeClr val="accent1"/>
-          </a:lnRef>
-          <a:fillRef idx="3">
-            <a:schemeClr val="accent1"/>
-          </a:fillRef>
-          <a:effectRef idx="2">
-            <a:schemeClr val="accent1"/>
-          </a:effectRef>
-          <a:fontRef idx="minor">
-            <a:schemeClr val="lt1"/>
-          </a:fontRef>
-        </p:style>
-        <p:txBody>
-          <a:bodyPr rtlCol="0" anchor="ctr"/>
-          <a:lstStyle/>
-          <a:p>
-            <a:pPr algn="ctr"/>
-          </a:p>
-        </p:txBody>
-      </p:sp>
-      <p:sp>
-        <p:nvSpPr>
-          <p:cNvPr id="39" name="Oval 38"/>
-          <p:cNvSpPr/>
-          <p:nvPr/>
-        </p:nvSpPr>
-        <p:spPr>
-          <a:xfrm>
-            <a:off x="5918200" y="2857500"/>
-            <a:ext cx="355600" cy="355600"/>
-          </a:xfrm>
-          <a:prstGeom prst="ellipse">
-            <a:avLst/>
-          </a:prstGeom>
-          <a:solidFill>
-            <a:srgbClr val="F8FAFC"/>
-          </a:solidFill>
-          <a:ln w="12700">
-            <a:solidFill>
-              <a:srgbClr val="DAE2EA"/>
-            </a:solidFill>
-          </a:ln>
-          <a:effectLst/>
-        </p:spPr>
-        <p:style>
-          <a:lnRef idx="1">
-            <a:schemeClr val="accent1"/>
-          </a:lnRef>
-          <a:fillRef idx="3">
-            <a:schemeClr val="accent1"/>
-          </a:fillRef>
-          <a:effectRef idx="2">
-            <a:schemeClr val="accent1"/>
-          </a:effectRef>
-          <a:fontRef idx="minor">
-            <a:schemeClr val="lt1"/>
-          </a:fontRef>
-        </p:style>
-        <p:txBody>
-          <a:bodyPr rtlCol="0" anchor="ctr"/>
-          <a:lstStyle/>
-          <a:p>
-            <a:pPr algn="ctr"/>
-          </a:p>
-        </p:txBody>
-      </p:sp>
-      <p:sp>
-        <p:nvSpPr>
-          <p:cNvPr id="40" name="TextBox 39"/>
-          <p:cNvSpPr txBox="1"/>
-          <p:nvPr/>
-        </p:nvSpPr>
-        <p:spPr>
-          <a:xfrm>
-            <a:off x="5918200" y="2959100"/>
-            <a:ext cx="355600" cy="177800"/>
-          </a:xfrm>
-          <a:prstGeom prst="rect">
-            <a:avLst/>
-          </a:prstGeom>
-          <a:noFill/>
-        </p:spPr>
-        <p:txBody>
-          <a:bodyPr wrap="none" lIns="0" rIns="0" tIns="0" bIns="0" anchor="t">
-            <a:noAutofit/>
-          </a:bodyPr>
-          <a:lstStyle/>
-          <a:p>
-            <a:pPr algn="ctr">
-              <a:lnSpc>
-                <a:spcPts val="1100"/>
-              </a:lnSpc>
-              <a:spcBef>
-                <a:spcPts val="0"/>
-              </a:spcBef>
-              <a:spcAft>
-                <a:spcPts val="0"/>
-              </a:spcAft>
-            </a:pPr>
-            <a:r>
-              <a:rPr sz="1100" b="1">
-                <a:solidFill>
-                  <a:srgbClr val="5D6F82"/>
-                </a:solidFill>
-                <a:latin typeface="Arial"/>
-              </a:rPr>
-              <a:t>OR</a:t>
-            </a:r>
-          </a:p>
-        </p:txBody>
-      </p:sp>
-      <p:cxnSp>
-        <p:nvCxnSpPr>
-          <p:cNvPr id="41" name="Connector 40"/>
-          <p:cNvCxnSpPr/>
-          <p:nvPr/>
-        </p:nvCxnSpPr>
-        <p:spPr>
-          <a:xfrm flipV="1">
-            <a:off x="5181600" y="4229100"/>
-            <a:ext cx="0" cy="215900"/>
-          </a:xfrm>
-          <a:prstGeom prst="line">
-            <a:avLst/>
-          </a:prstGeom>
-          <a:ln w="22860">
-            <a:solidFill>
-              <a:srgbClr val="2762C8"/>
-            </a:solidFill>
-          </a:ln>
-        </p:spPr>
-        <p:style>
-          <a:lnRef idx="2">
-            <a:schemeClr val="accent1"/>
-          </a:lnRef>
-          <a:fillRef idx="0">
-            <a:schemeClr val="accent1"/>
-          </a:fillRef>
-          <a:effectRef idx="1">
-            <a:schemeClr val="accent1"/>
-          </a:effectRef>
-          <a:fontRef idx="minor">
-            <a:schemeClr val="tx1"/>
-          </a:fontRef>
-        </p:style>
-      </p:cxnSp>
-      <p:cxnSp>
-        <p:nvCxnSpPr>
-          <p:cNvPr id="42" name="Connector 41"/>
-          <p:cNvCxnSpPr/>
-          <p:nvPr/>
-        </p:nvCxnSpPr>
-        <p:spPr>
-          <a:xfrm flipH="1">
-            <a:off x="3200400" y="4229100"/>
-            <a:ext cx="1981200" cy="0"/>
-          </a:xfrm>
-          <a:prstGeom prst="line">
-            <a:avLst/>
-          </a:prstGeom>
-          <a:ln w="22860">
-            <a:solidFill>
-              <a:srgbClr val="2762C8"/>
-            </a:solidFill>
-          </a:ln>
-        </p:spPr>
-        <p:style>
-          <a:lnRef idx="2">
-            <a:schemeClr val="accent1"/>
-          </a:lnRef>
-          <a:fillRef idx="0">
-            <a:schemeClr val="accent1"/>
-          </a:fillRef>
-          <a:effectRef idx="1">
-            <a:schemeClr val="accent1"/>
-          </a:effectRef>
-          <a:fontRef idx="minor">
-            <a:schemeClr val="tx1"/>
-          </a:fontRef>
-        </p:style>
-      </p:cxnSp>
-      <p:cxnSp>
-        <p:nvCxnSpPr>
-          <p:cNvPr id="43" name="Connector 42"/>
-          <p:cNvCxnSpPr/>
-          <p:nvPr/>
-        </p:nvCxnSpPr>
-        <p:spPr>
-          <a:xfrm flipV="1">
-            <a:off x="3200400" y="4013200"/>
-            <a:ext cx="0" cy="215900"/>
-          </a:xfrm>
-          <a:prstGeom prst="line">
-            <a:avLst/>
-          </a:prstGeom>
-          <a:ln w="22860">
-            <a:solidFill>
-              <a:srgbClr val="2762C8"/>
-            </a:solidFill>
-            <a:tailEnd type="triangle" w="med" len="med"/>
-          </a:ln>
-        </p:spPr>
-        <p:style>
-          <a:lnRef idx="2">
-            <a:schemeClr val="accent1"/>
-          </a:lnRef>
-          <a:fillRef idx="0">
-            <a:schemeClr val="accent1"/>
-          </a:fillRef>
-          <a:effectRef idx="1">
-            <a:schemeClr val="accent1"/>
-          </a:effectRef>
-          <a:fontRef idx="minor">
-            <a:schemeClr val="tx1"/>
-          </a:fontRef>
-        </p:style>
-      </p:cxnSp>
-      <p:cxnSp>
-        <p:nvCxnSpPr>
-          <p:cNvPr id="44" name="Connector 43"/>
-          <p:cNvCxnSpPr/>
-          <p:nvPr/>
-        </p:nvCxnSpPr>
-        <p:spPr>
-          <a:xfrm flipV="1">
-            <a:off x="7010400" y="4229100"/>
-            <a:ext cx="0" cy="215900"/>
-          </a:xfrm>
-          <a:prstGeom prst="line">
-            <a:avLst/>
-          </a:prstGeom>
-          <a:ln w="22860">
-            <a:solidFill>
-              <a:srgbClr val="087F85"/>
-            </a:solidFill>
-          </a:ln>
-        </p:spPr>
-        <p:style>
-          <a:lnRef idx="2">
-            <a:schemeClr val="accent1"/>
-          </a:lnRef>
-          <a:fillRef idx="0">
-            <a:schemeClr val="accent1"/>
-          </a:fillRef>
-          <a:effectRef idx="1">
-            <a:schemeClr val="accent1"/>
-          </a:effectRef>
-          <a:fontRef idx="minor">
-            <a:schemeClr val="tx1"/>
-          </a:fontRef>
-        </p:style>
-      </p:cxnSp>
-      <p:cxnSp>
-        <p:nvCxnSpPr>
-          <p:cNvPr id="45" name="Connector 44"/>
-          <p:cNvCxnSpPr/>
-          <p:nvPr/>
-        </p:nvCxnSpPr>
-        <p:spPr>
-          <a:xfrm>
-            <a:off x="7010400" y="4229100"/>
-            <a:ext cx="1981200" cy="0"/>
-          </a:xfrm>
-          <a:prstGeom prst="line">
-            <a:avLst/>
-          </a:prstGeom>
-          <a:ln w="22860">
-            <a:solidFill>
-              <a:srgbClr val="087F85"/>
-            </a:solidFill>
-          </a:ln>
-        </p:spPr>
-        <p:style>
-          <a:lnRef idx="2">
-            <a:schemeClr val="accent1"/>
-          </a:lnRef>
-          <a:fillRef idx="0">
-            <a:schemeClr val="accent1"/>
-          </a:fillRef>
-          <a:effectRef idx="1">
-            <a:schemeClr val="accent1"/>
-          </a:effectRef>
-          <a:fontRef idx="minor">
-            <a:schemeClr val="tx1"/>
-          </a:fontRef>
-        </p:style>
-      </p:cxnSp>
-      <p:cxnSp>
-        <p:nvCxnSpPr>
-          <p:cNvPr id="46" name="Connector 45"/>
-          <p:cNvCxnSpPr/>
-          <p:nvPr/>
-        </p:nvCxnSpPr>
-        <p:spPr>
-          <a:xfrm flipV="1">
-            <a:off x="8991600" y="4013200"/>
-            <a:ext cx="0" cy="215900"/>
-          </a:xfrm>
-          <a:prstGeom prst="line">
-            <a:avLst/>
-          </a:prstGeom>
-          <a:ln w="22860">
-            <a:solidFill>
-              <a:srgbClr val="087F85"/>
-            </a:solidFill>
-            <a:tailEnd type="triangle" w="med" len="med"/>
-          </a:ln>
-        </p:spPr>
-        <p:style>
-          <a:lnRef idx="2">
-            <a:schemeClr val="accent1"/>
-          </a:lnRef>
-          <a:fillRef idx="0">
-            <a:schemeClr val="accent1"/>
-          </a:fillRef>
-          <a:effectRef idx="1">
-            <a:schemeClr val="accent1"/>
-          </a:effectRef>
-          <a:fontRef idx="minor">
-            <a:schemeClr val="tx1"/>
-          </a:fontRef>
-        </p:style>
-      </p:cxnSp>
-      <p:sp>
-        <p:nvSpPr>
-          <p:cNvPr id="47" name="Rounded Rectangle 46"/>
-          <p:cNvSpPr/>
-          <p:nvPr/>
-        </p:nvSpPr>
-        <p:spPr>
-          <a:xfrm>
-            <a:off x="4216400" y="4445000"/>
-            <a:ext cx="3759200" cy="660400"/>
-          </a:xfrm>
-          <a:prstGeom prst="roundRect">
-            <a:avLst>
-              <a:gd name="adj" fmla="val 15384"/>
+              <a:gd name="adj" fmla="val 10256"/>
             </a:avLst>
           </a:prstGeom>
           <a:solidFill>
@@ -12522,317 +12073,7 @@
       </p:sp>
       <p:pic>
         <p:nvPicPr>
-          <p:cNvPr id="48" name="Picture 47" descr="image.png"/>
-          <p:cNvPicPr>
-            <a:picLocks noChangeAspect="1"/>
-          </p:cNvPicPr>
-          <p:nvPr/>
-        </p:nvPicPr>
-        <p:blipFill>
-          <a:blip r:embed="rId2"/>
-          <a:stretch>
-            <a:fillRect/>
-          </a:stretch>
-        </p:blipFill>
-        <p:spPr>
-          <a:xfrm>
-            <a:off x="4394348" y="4546600"/>
-            <a:ext cx="469603" cy="469900"/>
-          </a:xfrm>
-          <a:prstGeom prst="rect">
-            <a:avLst/>
-          </a:prstGeom>
-        </p:spPr>
-      </p:pic>
-      <p:sp>
-        <p:nvSpPr>
-          <p:cNvPr id="49" name="TextBox 48"/>
-          <p:cNvSpPr txBox="1"/>
-          <p:nvPr/>
-        </p:nvSpPr>
-        <p:spPr>
-          <a:xfrm>
-            <a:off x="5041900" y="4521200"/>
-            <a:ext cx="2743200" cy="344805"/>
-          </a:xfrm>
-          <a:prstGeom prst="rect">
-            <a:avLst/>
-          </a:prstGeom>
-          <a:noFill/>
-        </p:spPr>
-        <p:txBody>
-          <a:bodyPr wrap="none" lIns="0" rIns="0" tIns="0" bIns="0" anchor="t">
-            <a:noAutofit/>
-          </a:bodyPr>
-          <a:lstStyle/>
-          <a:p>
-            <a:pPr algn="l">
-              <a:lnSpc>
-                <a:spcPts val="2415"/>
-              </a:lnSpc>
-              <a:spcBef>
-                <a:spcPts val="0"/>
-              </a:spcBef>
-              <a:spcAft>
-                <a:spcPts val="0"/>
-              </a:spcAft>
-            </a:pPr>
-            <a:r>
-              <a:rPr sz="2100" b="1">
-                <a:solidFill>
-                  <a:srgbClr val="142338"/>
-                </a:solidFill>
-                <a:latin typeface="Arial"/>
-              </a:rPr>
-              <a:t>ExternalDNS</a:t>
-            </a:r>
-          </a:p>
-        </p:txBody>
-      </p:sp>
-      <p:sp>
-        <p:nvSpPr>
-          <p:cNvPr id="50" name="TextBox 49"/>
-          <p:cNvSpPr txBox="1"/>
-          <p:nvPr/>
-        </p:nvSpPr>
-        <p:spPr>
-          <a:xfrm>
-            <a:off x="5041900" y="4851400"/>
-            <a:ext cx="2743200" cy="227965"/>
-          </a:xfrm>
-          <a:prstGeom prst="rect">
-            <a:avLst/>
-          </a:prstGeom>
-          <a:noFill/>
-        </p:spPr>
-        <p:txBody>
-          <a:bodyPr wrap="none" lIns="0" rIns="0" tIns="0" bIns="0" anchor="t">
-            <a:noAutofit/>
-          </a:bodyPr>
-          <a:lstStyle/>
-          <a:p>
-            <a:pPr algn="l">
-              <a:lnSpc>
-                <a:spcPts val="1495"/>
-              </a:lnSpc>
-              <a:spcBef>
-                <a:spcPts val="0"/>
-              </a:spcBef>
-              <a:spcAft>
-                <a:spcPts val="0"/>
-              </a:spcAft>
-            </a:pPr>
-            <a:r>
-              <a:rPr sz="1300" b="0">
-                <a:solidFill>
-                  <a:srgbClr val="5D6F82"/>
-                </a:solidFill>
-                <a:latin typeface="Arial"/>
-              </a:rPr>
-              <a:t>Updates parent-zone delegation</a:t>
-            </a:r>
-          </a:p>
-        </p:txBody>
-      </p:sp>
-      <p:sp>
-        <p:nvSpPr>
-          <p:cNvPr id="51" name="Rounded Rectangle 50"/>
-          <p:cNvSpPr/>
-          <p:nvPr/>
-        </p:nvSpPr>
-        <p:spPr>
-          <a:xfrm>
-            <a:off x="609600" y="5321300"/>
-            <a:ext cx="10972800" cy="952500"/>
-          </a:xfrm>
-          <a:prstGeom prst="roundRect">
-            <a:avLst>
-              <a:gd name="adj" fmla="val 10666"/>
-            </a:avLst>
-          </a:prstGeom>
-          <a:solidFill>
-            <a:srgbClr val="142338"/>
-          </a:solidFill>
-          <a:ln>
-            <a:noFill/>
-          </a:ln>
-          <a:effectLst/>
-        </p:spPr>
-        <p:style>
-          <a:lnRef idx="1">
-            <a:schemeClr val="accent1"/>
-          </a:lnRef>
-          <a:fillRef idx="3">
-            <a:schemeClr val="accent1"/>
-          </a:fillRef>
-          <a:effectRef idx="2">
-            <a:schemeClr val="accent1"/>
-          </a:effectRef>
-          <a:fontRef idx="minor">
-            <a:schemeClr val="lt1"/>
-          </a:fontRef>
-        </p:style>
-        <p:txBody>
-          <a:bodyPr rtlCol="0" anchor="ctr"/>
-          <a:lstStyle/>
-          <a:p>
-            <a:pPr algn="ctr"/>
-          </a:p>
-        </p:txBody>
-      </p:sp>
-      <p:sp>
-        <p:nvSpPr>
-          <p:cNvPr id="52" name="TextBox 51"/>
-          <p:cNvSpPr txBox="1"/>
-          <p:nvPr/>
-        </p:nvSpPr>
-        <p:spPr>
-          <a:xfrm>
-            <a:off x="863600" y="5461000"/>
-            <a:ext cx="6350000" cy="198754"/>
-          </a:xfrm>
-          <a:prstGeom prst="rect">
-            <a:avLst/>
-          </a:prstGeom>
-          <a:noFill/>
-        </p:spPr>
-        <p:txBody>
-          <a:bodyPr wrap="none" lIns="0" rIns="0" tIns="0" bIns="0" anchor="t">
-            <a:noAutofit/>
-          </a:bodyPr>
-          <a:lstStyle/>
-          <a:p>
-            <a:pPr algn="l">
-              <a:lnSpc>
-                <a:spcPts val="1264"/>
-              </a:lnSpc>
-              <a:spcBef>
-                <a:spcPts val="0"/>
-              </a:spcBef>
-              <a:spcAft>
-                <a:spcPts val="0"/>
-              </a:spcAft>
-            </a:pPr>
-            <a:r>
-              <a:rPr sz="1100" b="1">
-                <a:solidFill>
-                  <a:srgbClr val="B8C8D9"/>
-                </a:solidFill>
-                <a:latin typeface="Arial"/>
-              </a:rPr>
-              <a:t>SAME TRAFFIC STEERING IN EVERY CLUSTER</a:t>
-            </a:r>
-          </a:p>
-        </p:txBody>
-      </p:sp>
-      <p:pic>
-        <p:nvPicPr>
-          <p:cNvPr id="53" name="Picture 52" descr="image.png"/>
-          <p:cNvPicPr>
-            <a:picLocks noChangeAspect="1"/>
-          </p:cNvPicPr>
-          <p:nvPr/>
-        </p:nvPicPr>
-        <p:blipFill>
-          <a:blip r:embed="rId3"/>
-          <a:stretch>
-            <a:fillRect/>
-          </a:stretch>
-        </p:blipFill>
-        <p:spPr>
-          <a:xfrm>
-            <a:off x="863600" y="5732415"/>
-            <a:ext cx="393700" cy="384268"/>
-          </a:xfrm>
-          <a:prstGeom prst="rect">
-            <a:avLst/>
-          </a:prstGeom>
-        </p:spPr>
-      </p:pic>
-      <p:sp>
-        <p:nvSpPr>
-          <p:cNvPr id="54" name="TextBox 53"/>
-          <p:cNvSpPr txBox="1"/>
-          <p:nvPr/>
-        </p:nvSpPr>
-        <p:spPr>
-          <a:xfrm>
-            <a:off x="1422400" y="5715000"/>
-            <a:ext cx="2489200" cy="344805"/>
-          </a:xfrm>
-          <a:prstGeom prst="rect">
-            <a:avLst/>
-          </a:prstGeom>
-          <a:noFill/>
-        </p:spPr>
-        <p:txBody>
-          <a:bodyPr wrap="none" lIns="0" rIns="0" tIns="0" bIns="0" anchor="t">
-            <a:noAutofit/>
-          </a:bodyPr>
-          <a:lstStyle/>
-          <a:p>
-            <a:pPr algn="l">
-              <a:lnSpc>
-                <a:spcPts val="2415"/>
-              </a:lnSpc>
-              <a:spcBef>
-                <a:spcPts val="0"/>
-              </a:spcBef>
-              <a:spcAft>
-                <a:spcPts val="0"/>
-              </a:spcAft>
-            </a:pPr>
-            <a:r>
-              <a:rPr sz="2100" b="1">
-                <a:solidFill>
-                  <a:srgbClr val="FFFFFF"/>
-                </a:solidFill>
-                <a:latin typeface="Arial"/>
-              </a:rPr>
-              <a:t>Gslb + k8gb</a:t>
-            </a:r>
-          </a:p>
-        </p:txBody>
-      </p:sp>
-      <p:cxnSp>
-        <p:nvCxnSpPr>
-          <p:cNvPr id="55" name="Connector 54"/>
-          <p:cNvCxnSpPr/>
-          <p:nvPr/>
-        </p:nvCxnSpPr>
-        <p:spPr>
-          <a:xfrm>
-            <a:off x="4013200" y="5930900"/>
-            <a:ext cx="711200" cy="0"/>
-          </a:xfrm>
-          <a:prstGeom prst="line">
-            <a:avLst/>
-          </a:prstGeom>
-          <a:ln w="22860">
-            <a:solidFill>
-              <a:srgbClr val="B8C8D9"/>
-            </a:solidFill>
-            <a:tailEnd type="triangle" w="med" len="med"/>
-          </a:ln>
-        </p:spPr>
-        <p:style>
-          <a:lnRef idx="2">
-            <a:schemeClr val="accent1"/>
-          </a:lnRef>
-          <a:fillRef idx="0">
-            <a:schemeClr val="accent1"/>
-          </a:fillRef>
-          <a:effectRef idx="1">
-            <a:schemeClr val="accent1"/>
-          </a:effectRef>
-          <a:fontRef idx="minor">
-            <a:schemeClr val="tx1"/>
-          </a:fontRef>
-        </p:style>
-      </p:cxnSp>
-      <p:pic>
-        <p:nvPicPr>
-          <p:cNvPr id="56" name="Picture 55" descr="image.png"/>
+          <p:cNvPr id="38" name="Picture 37" descr="image.png"/>
           <p:cNvPicPr>
             <a:picLocks noChangeAspect="1"/>
           </p:cNvPicPr>
@@ -12846,8 +12087,8 @@
         </p:blipFill>
         <p:spPr>
           <a:xfrm>
-            <a:off x="4953000" y="5727700"/>
-            <a:ext cx="393700" cy="393700"/>
+            <a:off x="7251700" y="2559304"/>
+            <a:ext cx="1524000" cy="469392"/>
           </a:xfrm>
           <a:prstGeom prst="rect">
             <a:avLst/>
@@ -12856,14 +12097,14 @@
       </p:pic>
       <p:sp>
         <p:nvSpPr>
-          <p:cNvPr id="57" name="TextBox 56"/>
+          <p:cNvPr id="39" name="TextBox 38"/>
           <p:cNvSpPr txBox="1"/>
           <p:nvPr/>
         </p:nvSpPr>
         <p:spPr>
           <a:xfrm>
-            <a:off x="5499100" y="5715000"/>
-            <a:ext cx="1892300" cy="344805"/>
+            <a:off x="6997700" y="3149600"/>
+            <a:ext cx="2032000" cy="230187"/>
           </a:xfrm>
           <a:prstGeom prst="rect">
             <a:avLst/>
@@ -12876,9 +12117,1151 @@
           </a:bodyPr>
           <a:lstStyle/>
           <a:p>
+            <a:pPr algn="ctr">
+              <a:lnSpc>
+                <a:spcPts val="1450"/>
+              </a:lnSpc>
+              <a:spcBef>
+                <a:spcPts val="0"/>
+              </a:spcBef>
+              <a:spcAft>
+                <a:spcPts val="0"/>
+              </a:spcAft>
+            </a:pPr>
+            <a:r>
+              <a:rPr sz="1450" b="1">
+                <a:solidFill>
+                  <a:srgbClr val="142338"/>
+                </a:solidFill>
+                <a:latin typeface="Arial"/>
+              </a:rPr>
+              <a:t>Azure Public DNS</a:t>
+            </a:r>
+          </a:p>
+        </p:txBody>
+      </p:sp>
+      <p:sp>
+        <p:nvSpPr>
+          <p:cNvPr id="40" name="Rounded Rectangle 39"/>
+          <p:cNvSpPr/>
+          <p:nvPr/>
+        </p:nvSpPr>
+        <p:spPr>
+          <a:xfrm>
+            <a:off x="9347200" y="2451100"/>
+            <a:ext cx="2235200" cy="990600"/>
+          </a:xfrm>
+          <a:prstGeom prst="roundRect">
+            <a:avLst>
+              <a:gd name="adj" fmla="val 10256"/>
+            </a:avLst>
+          </a:prstGeom>
+          <a:solidFill>
+            <a:srgbClr val="FFFFFF"/>
+          </a:solidFill>
+          <a:ln w="12700">
+            <a:solidFill>
+              <a:srgbClr val="DAE2EA"/>
+            </a:solidFill>
+          </a:ln>
+          <a:effectLst/>
+        </p:spPr>
+        <p:style>
+          <a:lnRef idx="1">
+            <a:schemeClr val="accent1"/>
+          </a:lnRef>
+          <a:fillRef idx="3">
+            <a:schemeClr val="accent1"/>
+          </a:fillRef>
+          <a:effectRef idx="2">
+            <a:schemeClr val="accent1"/>
+          </a:effectRef>
+          <a:fontRef idx="minor">
+            <a:schemeClr val="lt1"/>
+          </a:fontRef>
+        </p:style>
+        <p:txBody>
+          <a:bodyPr rtlCol="0" anchor="ctr"/>
+          <a:lstStyle/>
+          <a:p>
+            <a:pPr algn="ctr"/>
+          </a:p>
+        </p:txBody>
+      </p:sp>
+      <p:pic>
+        <p:nvPicPr>
+          <p:cNvPr id="41" name="Picture 40" descr="image.png"/>
+          <p:cNvPicPr>
+            <a:picLocks noChangeAspect="1"/>
+          </p:cNvPicPr>
+          <p:nvPr/>
+        </p:nvPicPr>
+        <p:blipFill>
+          <a:blip r:embed="rId5"/>
+          <a:stretch>
+            <a:fillRect/>
+          </a:stretch>
+        </p:blipFill>
+        <p:spPr>
+          <a:xfrm>
+            <a:off x="9702800" y="2661412"/>
+            <a:ext cx="1524000" cy="265176"/>
+          </a:xfrm>
+          <a:prstGeom prst="rect">
+            <a:avLst/>
+          </a:prstGeom>
+        </p:spPr>
+      </p:pic>
+      <p:sp>
+        <p:nvSpPr>
+          <p:cNvPr id="42" name="TextBox 41"/>
+          <p:cNvSpPr txBox="1"/>
+          <p:nvPr/>
+        </p:nvSpPr>
+        <p:spPr>
+          <a:xfrm>
+            <a:off x="9448800" y="3149600"/>
+            <a:ext cx="2032000" cy="230187"/>
+          </a:xfrm>
+          <a:prstGeom prst="rect">
+            <a:avLst/>
+          </a:prstGeom>
+          <a:noFill/>
+        </p:spPr>
+        <p:txBody>
+          <a:bodyPr wrap="none" lIns="0" rIns="0" tIns="0" bIns="0" anchor="t">
+            <a:noAutofit/>
+          </a:bodyPr>
+          <a:lstStyle/>
+          <a:p>
+            <a:pPr algn="ctr">
+              <a:lnSpc>
+                <a:spcPts val="1450"/>
+              </a:lnSpc>
+              <a:spcBef>
+                <a:spcPts val="0"/>
+              </a:spcBef>
+              <a:spcAft>
+                <a:spcPts val="0"/>
+              </a:spcAft>
+            </a:pPr>
+            <a:r>
+              <a:rPr sz="1450" b="1">
+                <a:solidFill>
+                  <a:srgbClr val="142338"/>
+                </a:solidFill>
+                <a:latin typeface="Arial"/>
+              </a:rPr>
+              <a:t>Google Cloud DNS</a:t>
+            </a:r>
+          </a:p>
+        </p:txBody>
+      </p:sp>
+      <p:sp>
+        <p:nvSpPr>
+          <p:cNvPr id="43" name="Rounded Rectangle 42"/>
+          <p:cNvSpPr/>
+          <p:nvPr/>
+        </p:nvSpPr>
+        <p:spPr>
+          <a:xfrm>
+            <a:off x="4445000" y="3581400"/>
+            <a:ext cx="2235200" cy="990600"/>
+          </a:xfrm>
+          <a:prstGeom prst="roundRect">
+            <a:avLst>
+              <a:gd name="adj" fmla="val 10256"/>
+            </a:avLst>
+          </a:prstGeom>
+          <a:solidFill>
+            <a:srgbClr val="FFFFFF"/>
+          </a:solidFill>
+          <a:ln w="12700">
+            <a:solidFill>
+              <a:srgbClr val="DAE2EA"/>
+            </a:solidFill>
+          </a:ln>
+          <a:effectLst/>
+        </p:spPr>
+        <p:style>
+          <a:lnRef idx="1">
+            <a:schemeClr val="accent1"/>
+          </a:lnRef>
+          <a:fillRef idx="3">
+            <a:schemeClr val="accent1"/>
+          </a:fillRef>
+          <a:effectRef idx="2">
+            <a:schemeClr val="accent1"/>
+          </a:effectRef>
+          <a:fontRef idx="minor">
+            <a:schemeClr val="lt1"/>
+          </a:fontRef>
+        </p:style>
+        <p:txBody>
+          <a:bodyPr rtlCol="0" anchor="ctr"/>
+          <a:lstStyle/>
+          <a:p>
+            <a:pPr algn="ctr"/>
+          </a:p>
+        </p:txBody>
+      </p:sp>
+      <p:pic>
+        <p:nvPicPr>
+          <p:cNvPr id="44" name="Picture 43" descr="image.png"/>
+          <p:cNvPicPr>
+            <a:picLocks noChangeAspect="1"/>
+          </p:cNvPicPr>
+          <p:nvPr/>
+        </p:nvPicPr>
+        <p:blipFill>
+          <a:blip r:embed="rId6"/>
+          <a:stretch>
+            <a:fillRect/>
+          </a:stretch>
+        </p:blipFill>
+        <p:spPr>
+          <a:xfrm>
+            <a:off x="5226050" y="3594100"/>
+            <a:ext cx="673100" cy="673100"/>
+          </a:xfrm>
+          <a:prstGeom prst="rect">
+            <a:avLst/>
+          </a:prstGeom>
+        </p:spPr>
+      </p:pic>
+      <p:sp>
+        <p:nvSpPr>
+          <p:cNvPr id="45" name="TextBox 44"/>
+          <p:cNvSpPr txBox="1"/>
+          <p:nvPr/>
+        </p:nvSpPr>
+        <p:spPr>
+          <a:xfrm>
+            <a:off x="4546600" y="4279900"/>
+            <a:ext cx="2032000" cy="230187"/>
+          </a:xfrm>
+          <a:prstGeom prst="rect">
+            <a:avLst/>
+          </a:prstGeom>
+          <a:noFill/>
+        </p:spPr>
+        <p:txBody>
+          <a:bodyPr wrap="none" lIns="0" rIns="0" tIns="0" bIns="0" anchor="t">
+            <a:noAutofit/>
+          </a:bodyPr>
+          <a:lstStyle/>
+          <a:p>
+            <a:pPr algn="ctr">
+              <a:lnSpc>
+                <a:spcPts val="1450"/>
+              </a:lnSpc>
+              <a:spcBef>
+                <a:spcPts val="0"/>
+              </a:spcBef>
+              <a:spcAft>
+                <a:spcPts val="0"/>
+              </a:spcAft>
+            </a:pPr>
+            <a:r>
+              <a:rPr sz="1450" b="1">
+                <a:solidFill>
+                  <a:srgbClr val="142338"/>
+                </a:solidFill>
+                <a:latin typeface="Arial"/>
+              </a:rPr>
+              <a:t>NS1</a:t>
+            </a:r>
+          </a:p>
+        </p:txBody>
+      </p:sp>
+      <p:sp>
+        <p:nvSpPr>
+          <p:cNvPr id="46" name="Rounded Rectangle 45"/>
+          <p:cNvSpPr/>
+          <p:nvPr/>
+        </p:nvSpPr>
+        <p:spPr>
+          <a:xfrm>
+            <a:off x="6896100" y="3581400"/>
+            <a:ext cx="2235200" cy="990600"/>
+          </a:xfrm>
+          <a:prstGeom prst="roundRect">
+            <a:avLst>
+              <a:gd name="adj" fmla="val 10256"/>
+            </a:avLst>
+          </a:prstGeom>
+          <a:solidFill>
+            <a:srgbClr val="FFFFFF"/>
+          </a:solidFill>
+          <a:ln w="12700">
+            <a:solidFill>
+              <a:srgbClr val="DAE2EA"/>
+            </a:solidFill>
+          </a:ln>
+          <a:effectLst/>
+        </p:spPr>
+        <p:style>
+          <a:lnRef idx="1">
+            <a:schemeClr val="accent1"/>
+          </a:lnRef>
+          <a:fillRef idx="3">
+            <a:schemeClr val="accent1"/>
+          </a:fillRef>
+          <a:effectRef idx="2">
+            <a:schemeClr val="accent1"/>
+          </a:effectRef>
+          <a:fontRef idx="minor">
+            <a:schemeClr val="lt1"/>
+          </a:fontRef>
+        </p:style>
+        <p:txBody>
+          <a:bodyPr rtlCol="0" anchor="ctr"/>
+          <a:lstStyle/>
+          <a:p>
+            <a:pPr algn="ctr"/>
+          </a:p>
+        </p:txBody>
+      </p:sp>
+      <p:pic>
+        <p:nvPicPr>
+          <p:cNvPr id="47" name="Picture 46" descr="image.png"/>
+          <p:cNvPicPr>
+            <a:picLocks noChangeAspect="1"/>
+          </p:cNvPicPr>
+          <p:nvPr/>
+        </p:nvPicPr>
+        <p:blipFill>
+          <a:blip r:embed="rId7"/>
+          <a:stretch>
+            <a:fillRect/>
+          </a:stretch>
+        </p:blipFill>
+        <p:spPr>
+          <a:xfrm>
+            <a:off x="7251700" y="3683508"/>
+            <a:ext cx="1524000" cy="481584"/>
+          </a:xfrm>
+          <a:prstGeom prst="rect">
+            <a:avLst/>
+          </a:prstGeom>
+        </p:spPr>
+      </p:pic>
+      <p:sp>
+        <p:nvSpPr>
+          <p:cNvPr id="48" name="TextBox 47"/>
+          <p:cNvSpPr txBox="1"/>
+          <p:nvPr/>
+        </p:nvSpPr>
+        <p:spPr>
+          <a:xfrm>
+            <a:off x="6997700" y="4279900"/>
+            <a:ext cx="2032000" cy="230187"/>
+          </a:xfrm>
+          <a:prstGeom prst="rect">
+            <a:avLst/>
+          </a:prstGeom>
+          <a:noFill/>
+        </p:spPr>
+        <p:txBody>
+          <a:bodyPr wrap="none" lIns="0" rIns="0" tIns="0" bIns="0" anchor="t">
+            <a:noAutofit/>
+          </a:bodyPr>
+          <a:lstStyle/>
+          <a:p>
+            <a:pPr algn="ctr">
+              <a:lnSpc>
+                <a:spcPts val="1450"/>
+              </a:lnSpc>
+              <a:spcBef>
+                <a:spcPts val="0"/>
+              </a:spcBef>
+              <a:spcAft>
+                <a:spcPts val="0"/>
+              </a:spcAft>
+            </a:pPr>
+            <a:r>
+              <a:rPr sz="1450" b="1">
+                <a:solidFill>
+                  <a:srgbClr val="142338"/>
+                </a:solidFill>
+                <a:latin typeface="Arial"/>
+              </a:rPr>
+              <a:t>Infoblox</a:t>
+            </a:r>
+          </a:p>
+        </p:txBody>
+      </p:sp>
+      <p:sp>
+        <p:nvSpPr>
+          <p:cNvPr id="49" name="Rounded Rectangle 48"/>
+          <p:cNvSpPr/>
+          <p:nvPr/>
+        </p:nvSpPr>
+        <p:spPr>
+          <a:xfrm>
+            <a:off x="9347200" y="3581400"/>
+            <a:ext cx="2235200" cy="990600"/>
+          </a:xfrm>
+          <a:prstGeom prst="roundRect">
+            <a:avLst>
+              <a:gd name="adj" fmla="val 10256"/>
+            </a:avLst>
+          </a:prstGeom>
+          <a:solidFill>
+            <a:srgbClr val="FFFFFF"/>
+          </a:solidFill>
+          <a:ln w="12700">
+            <a:solidFill>
+              <a:srgbClr val="DAE2EA"/>
+            </a:solidFill>
+          </a:ln>
+          <a:effectLst/>
+        </p:spPr>
+        <p:style>
+          <a:lnRef idx="1">
+            <a:schemeClr val="accent1"/>
+          </a:lnRef>
+          <a:fillRef idx="3">
+            <a:schemeClr val="accent1"/>
+          </a:fillRef>
+          <a:effectRef idx="2">
+            <a:schemeClr val="accent1"/>
+          </a:effectRef>
+          <a:fontRef idx="minor">
+            <a:schemeClr val="lt1"/>
+          </a:fontRef>
+        </p:style>
+        <p:txBody>
+          <a:bodyPr rtlCol="0" anchor="ctr"/>
+          <a:lstStyle/>
+          <a:p>
+            <a:pPr algn="ctr"/>
+          </a:p>
+        </p:txBody>
+      </p:sp>
+      <p:pic>
+        <p:nvPicPr>
+          <p:cNvPr id="50" name="Picture 49" descr="image.jpg"/>
+          <p:cNvPicPr>
+            <a:picLocks noChangeAspect="1"/>
+          </p:cNvPicPr>
+          <p:nvPr/>
+        </p:nvPicPr>
+        <p:blipFill>
+          <a:blip r:embed="rId8"/>
+          <a:stretch>
+            <a:fillRect/>
+          </a:stretch>
+        </p:blipFill>
+        <p:spPr>
+          <a:xfrm>
+            <a:off x="10128250" y="3594100"/>
+            <a:ext cx="673100" cy="673100"/>
+          </a:xfrm>
+          <a:prstGeom prst="rect">
+            <a:avLst/>
+          </a:prstGeom>
+        </p:spPr>
+      </p:pic>
+      <p:sp>
+        <p:nvSpPr>
+          <p:cNvPr id="51" name="TextBox 50"/>
+          <p:cNvSpPr txBox="1"/>
+          <p:nvPr/>
+        </p:nvSpPr>
+        <p:spPr>
+          <a:xfrm>
+            <a:off x="9448800" y="4279900"/>
+            <a:ext cx="2032000" cy="230187"/>
+          </a:xfrm>
+          <a:prstGeom prst="rect">
+            <a:avLst/>
+          </a:prstGeom>
+          <a:noFill/>
+        </p:spPr>
+        <p:txBody>
+          <a:bodyPr wrap="none" lIns="0" rIns="0" tIns="0" bIns="0" anchor="t">
+            <a:noAutofit/>
+          </a:bodyPr>
+          <a:lstStyle/>
+          <a:p>
+            <a:pPr algn="ctr">
+              <a:lnSpc>
+                <a:spcPts val="1450"/>
+              </a:lnSpc>
+              <a:spcBef>
+                <a:spcPts val="0"/>
+              </a:spcBef>
+              <a:spcAft>
+                <a:spcPts val="0"/>
+              </a:spcAft>
+            </a:pPr>
+            <a:r>
+              <a:rPr sz="1450" b="1">
+                <a:solidFill>
+                  <a:srgbClr val="142338"/>
+                </a:solidFill>
+                <a:latin typeface="Arial"/>
+              </a:rPr>
+              <a:t>Cloudflare</a:t>
+            </a:r>
+          </a:p>
+        </p:txBody>
+      </p:sp>
+      <p:sp>
+        <p:nvSpPr>
+          <p:cNvPr id="52" name="Rounded Rectangle 51"/>
+          <p:cNvSpPr/>
+          <p:nvPr/>
+        </p:nvSpPr>
+        <p:spPr>
+          <a:xfrm>
+            <a:off x="4445000" y="4762500"/>
+            <a:ext cx="7137400" cy="812800"/>
+          </a:xfrm>
+          <a:prstGeom prst="roundRect">
+            <a:avLst>
+              <a:gd name="adj" fmla="val 12500"/>
+            </a:avLst>
+          </a:prstGeom>
+          <a:solidFill>
+            <a:srgbClr val="E8F4F3"/>
+          </a:solidFill>
+          <a:ln>
+            <a:noFill/>
+          </a:ln>
+          <a:effectLst/>
+        </p:spPr>
+        <p:style>
+          <a:lnRef idx="1">
+            <a:schemeClr val="accent1"/>
+          </a:lnRef>
+          <a:fillRef idx="3">
+            <a:schemeClr val="accent1"/>
+          </a:fillRef>
+          <a:effectRef idx="2">
+            <a:schemeClr val="accent1"/>
+          </a:effectRef>
+          <a:fontRef idx="minor">
+            <a:schemeClr val="lt1"/>
+          </a:fontRef>
+        </p:style>
+        <p:txBody>
+          <a:bodyPr rtlCol="0" anchor="ctr"/>
+          <a:lstStyle/>
+          <a:p>
+            <a:pPr algn="ctr"/>
+          </a:p>
+        </p:txBody>
+      </p:sp>
+      <p:sp>
+        <p:nvSpPr>
+          <p:cNvPr id="53" name="Rounded Rectangle 52"/>
+          <p:cNvSpPr/>
+          <p:nvPr/>
+        </p:nvSpPr>
+        <p:spPr>
+          <a:xfrm>
+            <a:off x="4648200" y="4940300"/>
+            <a:ext cx="431800" cy="431800"/>
+          </a:xfrm>
+          <a:prstGeom prst="roundRect">
+            <a:avLst>
+              <a:gd name="adj" fmla="val 20588"/>
+            </a:avLst>
+          </a:prstGeom>
+          <a:solidFill>
+            <a:srgbClr val="FFFFFF"/>
+          </a:solidFill>
+          <a:ln>
+            <a:noFill/>
+          </a:ln>
+          <a:effectLst/>
+        </p:spPr>
+        <p:style>
+          <a:lnRef idx="1">
+            <a:schemeClr val="accent1"/>
+          </a:lnRef>
+          <a:fillRef idx="3">
+            <a:schemeClr val="accent1"/>
+          </a:fillRef>
+          <a:effectRef idx="2">
+            <a:schemeClr val="accent1"/>
+          </a:effectRef>
+          <a:fontRef idx="minor">
+            <a:schemeClr val="lt1"/>
+          </a:fontRef>
+        </p:style>
+        <p:txBody>
+          <a:bodyPr rtlCol="0" anchor="ctr"/>
+          <a:lstStyle/>
+          <a:p>
+            <a:pPr algn="ctr"/>
+          </a:p>
+        </p:txBody>
+      </p:sp>
+      <p:sp>
+        <p:nvSpPr>
+          <p:cNvPr id="54" name="Rounded Rectangle 53"/>
+          <p:cNvSpPr/>
+          <p:nvPr/>
+        </p:nvSpPr>
+        <p:spPr>
+          <a:xfrm>
+            <a:off x="4737100" y="5041900"/>
+            <a:ext cx="254000" cy="63500"/>
+          </a:xfrm>
+          <a:prstGeom prst="roundRect">
+            <a:avLst>
+              <a:gd name="adj" fmla="val 20000"/>
+            </a:avLst>
+          </a:prstGeom>
+          <a:solidFill>
+            <a:srgbClr val="FFFFFF"/>
+          </a:solidFill>
+          <a:ln w="10160">
+            <a:solidFill>
+              <a:srgbClr val="087F85"/>
+            </a:solidFill>
+          </a:ln>
+          <a:effectLst/>
+        </p:spPr>
+        <p:style>
+          <a:lnRef idx="1">
+            <a:schemeClr val="accent1"/>
+          </a:lnRef>
+          <a:fillRef idx="3">
+            <a:schemeClr val="accent1"/>
+          </a:fillRef>
+          <a:effectRef idx="2">
+            <a:schemeClr val="accent1"/>
+          </a:effectRef>
+          <a:fontRef idx="minor">
+            <a:schemeClr val="lt1"/>
+          </a:fontRef>
+        </p:style>
+        <p:txBody>
+          <a:bodyPr rtlCol="0" anchor="ctr"/>
+          <a:lstStyle/>
+          <a:p>
+            <a:pPr algn="ctr"/>
+          </a:p>
+        </p:txBody>
+      </p:sp>
+      <p:sp>
+        <p:nvSpPr>
+          <p:cNvPr id="55" name="Oval 54"/>
+          <p:cNvSpPr/>
+          <p:nvPr/>
+        </p:nvSpPr>
+        <p:spPr>
+          <a:xfrm>
+            <a:off x="4931410" y="5064760"/>
+            <a:ext cx="17780" cy="17780"/>
+          </a:xfrm>
+          <a:prstGeom prst="ellipse">
+            <a:avLst/>
+          </a:prstGeom>
+          <a:solidFill>
+            <a:srgbClr val="087F85"/>
+          </a:solidFill>
+          <a:ln>
+            <a:noFill/>
+          </a:ln>
+          <a:effectLst/>
+        </p:spPr>
+        <p:style>
+          <a:lnRef idx="1">
+            <a:schemeClr val="accent1"/>
+          </a:lnRef>
+          <a:fillRef idx="3">
+            <a:schemeClr val="accent1"/>
+          </a:fillRef>
+          <a:effectRef idx="2">
+            <a:schemeClr val="accent1"/>
+          </a:effectRef>
+          <a:fontRef idx="minor">
+            <a:schemeClr val="lt1"/>
+          </a:fontRef>
+        </p:style>
+        <p:txBody>
+          <a:bodyPr rtlCol="0" anchor="ctr"/>
+          <a:lstStyle/>
+          <a:p>
+            <a:pPr algn="ctr"/>
+          </a:p>
+        </p:txBody>
+      </p:sp>
+      <p:sp>
+        <p:nvSpPr>
+          <p:cNvPr id="56" name="Rounded Rectangle 55"/>
+          <p:cNvSpPr/>
+          <p:nvPr/>
+        </p:nvSpPr>
+        <p:spPr>
+          <a:xfrm>
+            <a:off x="4737100" y="5143500"/>
+            <a:ext cx="254000" cy="63500"/>
+          </a:xfrm>
+          <a:prstGeom prst="roundRect">
+            <a:avLst>
+              <a:gd name="adj" fmla="val 20000"/>
+            </a:avLst>
+          </a:prstGeom>
+          <a:solidFill>
+            <a:srgbClr val="FFFFFF"/>
+          </a:solidFill>
+          <a:ln w="10160">
+            <a:solidFill>
+              <a:srgbClr val="087F85"/>
+            </a:solidFill>
+          </a:ln>
+          <a:effectLst/>
+        </p:spPr>
+        <p:style>
+          <a:lnRef idx="1">
+            <a:schemeClr val="accent1"/>
+          </a:lnRef>
+          <a:fillRef idx="3">
+            <a:schemeClr val="accent1"/>
+          </a:fillRef>
+          <a:effectRef idx="2">
+            <a:schemeClr val="accent1"/>
+          </a:effectRef>
+          <a:fontRef idx="minor">
+            <a:schemeClr val="lt1"/>
+          </a:fontRef>
+        </p:style>
+        <p:txBody>
+          <a:bodyPr rtlCol="0" anchor="ctr"/>
+          <a:lstStyle/>
+          <a:p>
+            <a:pPr algn="ctr"/>
+          </a:p>
+        </p:txBody>
+      </p:sp>
+      <p:sp>
+        <p:nvSpPr>
+          <p:cNvPr id="57" name="Oval 56"/>
+          <p:cNvSpPr/>
+          <p:nvPr/>
+        </p:nvSpPr>
+        <p:spPr>
+          <a:xfrm>
+            <a:off x="4931410" y="5166360"/>
+            <a:ext cx="17780" cy="17780"/>
+          </a:xfrm>
+          <a:prstGeom prst="ellipse">
+            <a:avLst/>
+          </a:prstGeom>
+          <a:solidFill>
+            <a:srgbClr val="087F85"/>
+          </a:solidFill>
+          <a:ln>
+            <a:noFill/>
+          </a:ln>
+          <a:effectLst/>
+        </p:spPr>
+        <p:style>
+          <a:lnRef idx="1">
+            <a:schemeClr val="accent1"/>
+          </a:lnRef>
+          <a:fillRef idx="3">
+            <a:schemeClr val="accent1"/>
+          </a:fillRef>
+          <a:effectRef idx="2">
+            <a:schemeClr val="accent1"/>
+          </a:effectRef>
+          <a:fontRef idx="minor">
+            <a:schemeClr val="lt1"/>
+          </a:fontRef>
+        </p:style>
+        <p:txBody>
+          <a:bodyPr rtlCol="0" anchor="ctr"/>
+          <a:lstStyle/>
+          <a:p>
+            <a:pPr algn="ctr"/>
+          </a:p>
+        </p:txBody>
+      </p:sp>
+      <p:sp>
+        <p:nvSpPr>
+          <p:cNvPr id="58" name="Rounded Rectangle 57"/>
+          <p:cNvSpPr/>
+          <p:nvPr/>
+        </p:nvSpPr>
+        <p:spPr>
+          <a:xfrm>
+            <a:off x="4737100" y="5245100"/>
+            <a:ext cx="254000" cy="63500"/>
+          </a:xfrm>
+          <a:prstGeom prst="roundRect">
+            <a:avLst>
+              <a:gd name="adj" fmla="val 20000"/>
+            </a:avLst>
+          </a:prstGeom>
+          <a:solidFill>
+            <a:srgbClr val="FFFFFF"/>
+          </a:solidFill>
+          <a:ln w="10160">
+            <a:solidFill>
+              <a:srgbClr val="087F85"/>
+            </a:solidFill>
+          </a:ln>
+          <a:effectLst/>
+        </p:spPr>
+        <p:style>
+          <a:lnRef idx="1">
+            <a:schemeClr val="accent1"/>
+          </a:lnRef>
+          <a:fillRef idx="3">
+            <a:schemeClr val="accent1"/>
+          </a:fillRef>
+          <a:effectRef idx="2">
+            <a:schemeClr val="accent1"/>
+          </a:effectRef>
+          <a:fontRef idx="minor">
+            <a:schemeClr val="lt1"/>
+          </a:fontRef>
+        </p:style>
+        <p:txBody>
+          <a:bodyPr rtlCol="0" anchor="ctr"/>
+          <a:lstStyle/>
+          <a:p>
+            <a:pPr algn="ctr"/>
+          </a:p>
+        </p:txBody>
+      </p:sp>
+      <p:sp>
+        <p:nvSpPr>
+          <p:cNvPr id="59" name="Oval 58"/>
+          <p:cNvSpPr/>
+          <p:nvPr/>
+        </p:nvSpPr>
+        <p:spPr>
+          <a:xfrm>
+            <a:off x="4931410" y="5267960"/>
+            <a:ext cx="17780" cy="17780"/>
+          </a:xfrm>
+          <a:prstGeom prst="ellipse">
+            <a:avLst/>
+          </a:prstGeom>
+          <a:solidFill>
+            <a:srgbClr val="087F85"/>
+          </a:solidFill>
+          <a:ln>
+            <a:noFill/>
+          </a:ln>
+          <a:effectLst/>
+        </p:spPr>
+        <p:style>
+          <a:lnRef idx="1">
+            <a:schemeClr val="accent1"/>
+          </a:lnRef>
+          <a:fillRef idx="3">
+            <a:schemeClr val="accent1"/>
+          </a:fillRef>
+          <a:effectRef idx="2">
+            <a:schemeClr val="accent1"/>
+          </a:effectRef>
+          <a:fontRef idx="minor">
+            <a:schemeClr val="lt1"/>
+          </a:fontRef>
+        </p:style>
+        <p:txBody>
+          <a:bodyPr rtlCol="0" anchor="ctr"/>
+          <a:lstStyle/>
+          <a:p>
+            <a:pPr algn="ctr"/>
+          </a:p>
+        </p:txBody>
+      </p:sp>
+      <p:sp>
+        <p:nvSpPr>
+          <p:cNvPr id="60" name="TextBox 59"/>
+          <p:cNvSpPr txBox="1"/>
+          <p:nvPr/>
+        </p:nvSpPr>
+        <p:spPr>
+          <a:xfrm>
+            <a:off x="5257800" y="4927600"/>
+            <a:ext cx="1905000" cy="330200"/>
+          </a:xfrm>
+          <a:prstGeom prst="rect">
+            <a:avLst/>
+          </a:prstGeom>
+          <a:noFill/>
+        </p:spPr>
+        <p:txBody>
+          <a:bodyPr wrap="none" lIns="0" rIns="0" tIns="0" bIns="0" anchor="t">
+            <a:noAutofit/>
+          </a:bodyPr>
+          <a:lstStyle/>
+          <a:p>
             <a:pPr algn="l">
               <a:lnSpc>
-                <a:spcPts val="2415"/>
+                <a:spcPts val="2300"/>
+              </a:lnSpc>
+              <a:spcBef>
+                <a:spcPts val="0"/>
+              </a:spcBef>
+              <a:spcAft>
+                <a:spcPts val="0"/>
+              </a:spcAft>
+            </a:pPr>
+            <a:r>
+              <a:rPr sz="2000" b="1">
+                <a:solidFill>
+                  <a:srgbClr val="087F85"/>
+                </a:solidFill>
+                <a:latin typeface="Arial"/>
+              </a:rPr>
+              <a:t>RFC 2136</a:t>
+            </a:r>
+          </a:p>
+        </p:txBody>
+      </p:sp>
+      <p:sp>
+        <p:nvSpPr>
+          <p:cNvPr id="61" name="TextBox 60"/>
+          <p:cNvSpPr txBox="1"/>
+          <p:nvPr/>
+        </p:nvSpPr>
+        <p:spPr>
+          <a:xfrm>
+            <a:off x="5257800" y="5270500"/>
+            <a:ext cx="1905000" cy="198754"/>
+          </a:xfrm>
+          <a:prstGeom prst="rect">
+            <a:avLst/>
+          </a:prstGeom>
+          <a:noFill/>
+        </p:spPr>
+        <p:txBody>
+          <a:bodyPr wrap="none" lIns="0" rIns="0" tIns="0" bIns="0" anchor="t">
+            <a:noAutofit/>
+          </a:bodyPr>
+          <a:lstStyle/>
+          <a:p>
+            <a:pPr algn="l">
+              <a:lnSpc>
+                <a:spcPts val="1264"/>
+              </a:lnSpc>
+              <a:spcBef>
+                <a:spcPts val="0"/>
+              </a:spcBef>
+              <a:spcAft>
+                <a:spcPts val="0"/>
+              </a:spcAft>
+            </a:pPr>
+            <a:r>
+              <a:rPr sz="1100" b="0">
+                <a:solidFill>
+                  <a:srgbClr val="087F85"/>
+                </a:solidFill>
+                <a:latin typeface="Arial"/>
+              </a:rPr>
+              <a:t>DNS updates</a:t>
+            </a:r>
+          </a:p>
+        </p:txBody>
+      </p:sp>
+      <p:cxnSp>
+        <p:nvCxnSpPr>
+          <p:cNvPr id="62" name="Connector 61"/>
+          <p:cNvCxnSpPr/>
+          <p:nvPr/>
+        </p:nvCxnSpPr>
+        <p:spPr>
+          <a:xfrm>
+            <a:off x="7340600" y="4927600"/>
+            <a:ext cx="0" cy="482600"/>
+          </a:xfrm>
+          <a:prstGeom prst="line">
+            <a:avLst/>
+          </a:prstGeom>
+          <a:ln w="12700">
+            <a:solidFill>
+              <a:srgbClr val="B3D6D5"/>
+            </a:solidFill>
+          </a:ln>
+        </p:spPr>
+        <p:style>
+          <a:lnRef idx="2">
+            <a:schemeClr val="accent1"/>
+          </a:lnRef>
+          <a:fillRef idx="0">
+            <a:schemeClr val="accent1"/>
+          </a:fillRef>
+          <a:effectRef idx="1">
+            <a:schemeClr val="accent1"/>
+          </a:effectRef>
+          <a:fontRef idx="minor">
+            <a:schemeClr val="tx1"/>
+          </a:fontRef>
+        </p:style>
+      </p:cxnSp>
+      <p:sp>
+        <p:nvSpPr>
+          <p:cNvPr id="63" name="TextBox 62"/>
+          <p:cNvSpPr txBox="1"/>
+          <p:nvPr/>
+        </p:nvSpPr>
+        <p:spPr>
+          <a:xfrm>
+            <a:off x="7581900" y="4927600"/>
+            <a:ext cx="3746500" cy="315595"/>
+          </a:xfrm>
+          <a:prstGeom prst="rect">
+            <a:avLst/>
+          </a:prstGeom>
+          <a:noFill/>
+        </p:spPr>
+        <p:txBody>
+          <a:bodyPr wrap="none" lIns="0" rIns="0" tIns="0" bIns="0" anchor="t">
+            <a:noAutofit/>
+          </a:bodyPr>
+          <a:lstStyle/>
+          <a:p>
+            <a:pPr algn="l">
+              <a:lnSpc>
+                <a:spcPts val="2185"/>
+              </a:lnSpc>
+              <a:spcBef>
+                <a:spcPts val="0"/>
+              </a:spcBef>
+              <a:spcAft>
+                <a:spcPts val="0"/>
+              </a:spcAft>
+            </a:pPr>
+            <a:r>
+              <a:rPr sz="1900" b="1">
+                <a:solidFill>
+                  <a:srgbClr val="142338"/>
+                </a:solidFill>
+                <a:latin typeface="Arial"/>
+              </a:rPr>
+              <a:t>BIND9 · Windows DNS</a:t>
+            </a:r>
+          </a:p>
+        </p:txBody>
+      </p:sp>
+      <p:sp>
+        <p:nvSpPr>
+          <p:cNvPr id="64" name="TextBox 63"/>
+          <p:cNvSpPr txBox="1"/>
+          <p:nvPr/>
+        </p:nvSpPr>
+        <p:spPr>
+          <a:xfrm>
+            <a:off x="7581900" y="5270500"/>
+            <a:ext cx="3746500" cy="198754"/>
+          </a:xfrm>
+          <a:prstGeom prst="rect">
+            <a:avLst/>
+          </a:prstGeom>
+          <a:noFill/>
+        </p:spPr>
+        <p:txBody>
+          <a:bodyPr wrap="none" lIns="0" rIns="0" tIns="0" bIns="0" anchor="t">
+            <a:noAutofit/>
+          </a:bodyPr>
+          <a:lstStyle/>
+          <a:p>
+            <a:pPr algn="l">
+              <a:lnSpc>
+                <a:spcPts val="1264"/>
+              </a:lnSpc>
+              <a:spcBef>
+                <a:spcPts val="0"/>
+              </a:spcBef>
+              <a:spcAft>
+                <a:spcPts val="0"/>
+              </a:spcAft>
+            </a:pPr>
+            <a:r>
+              <a:rPr sz="1100" b="0">
+                <a:solidFill>
+                  <a:srgbClr val="5D6F82"/>
+                </a:solidFill>
+                <a:latin typeface="Arial"/>
+              </a:rPr>
+              <a:t>TSIG / GSS-TSIG authentication</a:t>
+            </a:r>
+          </a:p>
+        </p:txBody>
+      </p:sp>
+      <p:sp>
+        <p:nvSpPr>
+          <p:cNvPr id="65" name="Rounded Rectangle 64"/>
+          <p:cNvSpPr/>
+          <p:nvPr/>
+        </p:nvSpPr>
+        <p:spPr>
+          <a:xfrm>
+            <a:off x="609600" y="5816600"/>
+            <a:ext cx="10972800" cy="457200"/>
+          </a:xfrm>
+          <a:prstGeom prst="roundRect">
+            <a:avLst>
+              <a:gd name="adj" fmla="val 16666"/>
+            </a:avLst>
+          </a:prstGeom>
+          <a:solidFill>
+            <a:srgbClr val="142338"/>
+          </a:solidFill>
+          <a:ln>
+            <a:noFill/>
+          </a:ln>
+          <a:effectLst/>
+        </p:spPr>
+        <p:style>
+          <a:lnRef idx="1">
+            <a:schemeClr val="accent1"/>
+          </a:lnRef>
+          <a:fillRef idx="3">
+            <a:schemeClr val="accent1"/>
+          </a:fillRef>
+          <a:effectRef idx="2">
+            <a:schemeClr val="accent1"/>
+          </a:effectRef>
+          <a:fontRef idx="minor">
+            <a:schemeClr val="lt1"/>
+          </a:fontRef>
+        </p:style>
+        <p:txBody>
+          <a:bodyPr rtlCol="0" anchor="ctr"/>
+          <a:lstStyle/>
+          <a:p>
+            <a:pPr algn="ctr"/>
+          </a:p>
+        </p:txBody>
+      </p:sp>
+      <p:sp>
+        <p:nvSpPr>
+          <p:cNvPr id="66" name="TextBox 65"/>
+          <p:cNvSpPr txBox="1"/>
+          <p:nvPr/>
+        </p:nvSpPr>
+        <p:spPr>
+          <a:xfrm>
+            <a:off x="838200" y="5918200"/>
+            <a:ext cx="10515600" cy="333375"/>
+          </a:xfrm>
+          <a:prstGeom prst="rect">
+            <a:avLst/>
+          </a:prstGeom>
+          <a:noFill/>
+        </p:spPr>
+        <p:txBody>
+          <a:bodyPr wrap="none" lIns="0" rIns="0" tIns="0" bIns="0" anchor="t">
+            <a:noAutofit/>
+          </a:bodyPr>
+          <a:lstStyle/>
+          <a:p>
+            <a:pPr algn="ctr">
+              <a:lnSpc>
+                <a:spcPts val="2100"/>
               </a:lnSpc>
               <a:spcBef>
                 <a:spcPts val="0"/>
@@ -12894,132 +13277,7 @@
                 </a:solidFill>
                 <a:latin typeface="Arial"/>
               </a:rPr>
-              <a:t>CoreDNS</a:t>
-            </a:r>
-          </a:p>
-        </p:txBody>
-      </p:sp>
-      <p:cxnSp>
-        <p:nvCxnSpPr>
-          <p:cNvPr id="58" name="Connector 57"/>
-          <p:cNvCxnSpPr/>
-          <p:nvPr/>
-        </p:nvCxnSpPr>
-        <p:spPr>
-          <a:xfrm>
-            <a:off x="7569200" y="5562600"/>
-            <a:ext cx="0" cy="520700"/>
-          </a:xfrm>
-          <a:prstGeom prst="line">
-            <a:avLst/>
-          </a:prstGeom>
-          <a:ln w="12700">
-            <a:solidFill>
-              <a:srgbClr val="385068"/>
-            </a:solidFill>
-          </a:ln>
-        </p:spPr>
-        <p:style>
-          <a:lnRef idx="2">
-            <a:schemeClr val="accent1"/>
-          </a:lnRef>
-          <a:fillRef idx="0">
-            <a:schemeClr val="accent1"/>
-          </a:fillRef>
-          <a:effectRef idx="1">
-            <a:schemeClr val="accent1"/>
-          </a:effectRef>
-          <a:fontRef idx="minor">
-            <a:schemeClr val="tx1"/>
-          </a:fontRef>
-        </p:style>
-      </p:cxnSp>
-      <p:sp>
-        <p:nvSpPr>
-          <p:cNvPr id="59" name="TextBox 58"/>
-          <p:cNvSpPr txBox="1"/>
-          <p:nvPr/>
-        </p:nvSpPr>
-        <p:spPr>
-          <a:xfrm>
-            <a:off x="7848600" y="5499100"/>
-            <a:ext cx="3454400" cy="286384"/>
-          </a:xfrm>
-          <a:prstGeom prst="rect">
-            <a:avLst/>
-          </a:prstGeom>
-          <a:noFill/>
-        </p:spPr>
-        <p:txBody>
-          <a:bodyPr wrap="none" lIns="0" rIns="0" tIns="0" bIns="0" anchor="t">
-            <a:noAutofit/>
-          </a:bodyPr>
-          <a:lstStyle/>
-          <a:p>
-            <a:pPr algn="l">
-              <a:lnSpc>
-                <a:spcPts val="1954"/>
-              </a:lnSpc>
-              <a:spcBef>
-                <a:spcPts val="0"/>
-              </a:spcBef>
-              <a:spcAft>
-                <a:spcPts val="0"/>
-              </a:spcAft>
-            </a:pPr>
-            <a:r>
-              <a:rPr sz="1700" b="1">
-                <a:solidFill>
-                  <a:srgbClr val="FFFFFF"/>
-                </a:solidFill>
-                <a:latin typeface="Arial"/>
-              </a:rPr>
-              <a:t>Your choice of parent DNS.</a:t>
-            </a:r>
-          </a:p>
-        </p:txBody>
-      </p:sp>
-      <p:sp>
-        <p:nvSpPr>
-          <p:cNvPr id="60" name="TextBox 59"/>
-          <p:cNvSpPr txBox="1"/>
-          <p:nvPr/>
-        </p:nvSpPr>
-        <p:spPr>
-          <a:xfrm>
-            <a:off x="7848600" y="5854700"/>
-            <a:ext cx="3454400" cy="257175"/>
-          </a:xfrm>
-          <a:prstGeom prst="rect">
-            <a:avLst/>
-          </a:prstGeom>
-          <a:noFill/>
-        </p:spPr>
-        <p:txBody>
-          <a:bodyPr wrap="none" lIns="0" rIns="0" tIns="0" bIns="0" anchor="t">
-            <a:noAutofit/>
-          </a:bodyPr>
-          <a:lstStyle/>
-          <a:p>
-            <a:pPr algn="l">
-              <a:lnSpc>
-                <a:spcPts val="1725"/>
-              </a:lnSpc>
-              <a:spcBef>
-                <a:spcPts val="0"/>
-              </a:spcBef>
-              <a:spcAft>
-                <a:spcPts val="0"/>
-              </a:spcAft>
-            </a:pPr>
-            <a:r>
-              <a:rPr sz="1500" b="0">
-                <a:solidFill>
-                  <a:srgbClr val="B8C8D9"/>
-                </a:solidFill>
-                <a:latin typeface="Arial"/>
-              </a:rPr>
-              <a:t>Your Gslb strategy stays the same.</a:t>
+              <a:t>Choose your parent DNS. Keep your Gslb traffic strategy.</a:t>
             </a:r>
           </a:p>
         </p:txBody>

</xml_diff>

<commit_message>
Align node status badges with their cards
Signed-off-by: Yury Tsarev <yury@0ttl.ai>
</commit_message>
<xml_diff>
--- a/slides/k8gb_sovereign_cloud_days_2026.pptx
+++ b/slides/k8gb_sovereign_cloud_days_2026.pptx
@@ -37061,7 +37061,7 @@
         </p:nvSpPr>
         <p:spPr>
           <a:xfrm>
-            <a:off x="1422400" y="3086100"/>
+            <a:off x="1422400" y="3187700"/>
             <a:ext cx="228600" cy="228600"/>
           </a:xfrm>
           <a:prstGeom prst="ellipse">
@@ -37105,7 +37105,7 @@
         </p:nvCxnSpPr>
         <p:spPr>
           <a:xfrm>
-            <a:off x="1485900" y="3149600"/>
+            <a:off x="1485900" y="3251200"/>
             <a:ext cx="101600" cy="101600"/>
           </a:xfrm>
           <a:prstGeom prst="line">
@@ -37140,7 +37140,7 @@
         </p:nvCxnSpPr>
         <p:spPr>
           <a:xfrm flipV="1">
-            <a:off x="1485900" y="3149600"/>
+            <a:off x="1485900" y="3251200"/>
             <a:ext cx="101600" cy="101600"/>
           </a:xfrm>
           <a:prstGeom prst="line">
@@ -37361,7 +37361,7 @@
         </p:nvSpPr>
         <p:spPr>
           <a:xfrm>
-            <a:off x="2425700" y="3086100"/>
+            <a:off x="2425700" y="3187700"/>
             <a:ext cx="228600" cy="228600"/>
           </a:xfrm>
           <a:prstGeom prst="ellipse">
@@ -37405,7 +37405,7 @@
         </p:nvCxnSpPr>
         <p:spPr>
           <a:xfrm>
-            <a:off x="2476500" y="3200400"/>
+            <a:off x="2476500" y="3302000"/>
             <a:ext cx="50800" cy="50800"/>
           </a:xfrm>
           <a:prstGeom prst="line">
@@ -37440,7 +37440,7 @@
         </p:nvCxnSpPr>
         <p:spPr>
           <a:xfrm flipV="1">
-            <a:off x="2527300" y="3149600"/>
+            <a:off x="2527300" y="3251200"/>
             <a:ext cx="76200" cy="101600"/>
           </a:xfrm>
           <a:prstGeom prst="line">
@@ -37661,7 +37661,7 @@
         </p:nvSpPr>
         <p:spPr>
           <a:xfrm>
-            <a:off x="3429000" y="3086100"/>
+            <a:off x="3429000" y="3187700"/>
             <a:ext cx="228600" cy="228600"/>
           </a:xfrm>
           <a:prstGeom prst="ellipse">
@@ -37705,7 +37705,7 @@
         </p:nvCxnSpPr>
         <p:spPr>
           <a:xfrm>
-            <a:off x="3479800" y="3200400"/>
+            <a:off x="3479800" y="3302000"/>
             <a:ext cx="50800" cy="50800"/>
           </a:xfrm>
           <a:prstGeom prst="line">
@@ -37740,7 +37740,7 @@
         </p:nvCxnSpPr>
         <p:spPr>
           <a:xfrm flipV="1">
-            <a:off x="3530600" y="3149600"/>
+            <a:off x="3530600" y="3251200"/>
             <a:ext cx="76200" cy="101600"/>
           </a:xfrm>
           <a:prstGeom prst="line">

</xml_diff>

<commit_message>
Close the talk with sovereignty and distributed DNS
Signed-off-by: Yury Tsarev <yury@0ttl.ai>
</commit_message>
<xml_diff>
--- a/slides/k8gb_sovereign_cloud_days_2026.pptx
+++ b/slides/k8gb_sovereign_cloud_days_2026.pptx
@@ -31,6 +31,7 @@
     <p:sldId id="279" r:id="rId31"/>
     <p:sldId id="280" r:id="rId32"/>
     <p:sldId id="281" r:id="rId33"/>
+    <p:sldId id="282" r:id="rId34"/>
   </p:sldIdLst>
   <p:sldSz cx="12192000" cy="6858000" type="screen4x3"/>
   <p:notesSz cx="6858000" cy="9144000"/>
@@ -539,7 +540,7 @@
           <a:p/>
           <a:p>
             <a:r>
-              <a:t>Open with one question: when a cluster disappears, who controls the next connection? Introduce yourself as k8gb creator and project lead. Set the route: first the product and a working local demo, then the operational cases to test. Reach Questions at 28:30 elapsed; reserve six minutes and thirty seconds for discussion.</a:t>
+              <a:t>Open with one question: when a cluster disappears, who controls the next connection? Introduce yourself as k8gb creator and project lead. Set the route: first the product and a working local demo, then the operational cases to test. Reach Questions at 29:00 elapsed; reserve six minutes for discussion.</a:t>
             </a:r>
           </a:p>
           <a:p/>
@@ -2263,7 +2264,7 @@
           <a:p/>
           <a:p>
             <a:r>
-              <a:t>Spend one minute on the people behind the project. k8gb is CNCF Incubating, with seven public adopters, 46 contributors and 1,335 GitHub stars, checked on 23 October 2026. The contributor count uses the complete GitHub contributors API response and excludes three automated accounts (renovate, github-actions and dependabot). Mention the breadth of public users without reading every name. The adopter list is voluntary and is not the total installation count. Logos shown: Absa, Millennium bcp, Eficode, Open Systems, PagBank, Darede and Envio. Official brand artwork retains its original colors and proportions. Open Systems logo credit: Uvifian, CC BY-SA 4.0, https://commons.wikimedia.org/wiki/File:Open-systems-logo.svg; original artwork unchanged apart from proportional scaling and PNG rendering. Star count indicates interest, not reliability. Invite the audience to a community meeting; dates and local time are in the linked calendar. At 27:45 elapsed, move from the public adopter logos to the Millennium bcp case study. Questions follow at 28:30 elapsed.</a:t>
+              <a:t>Spend one minute on the people behind the project. k8gb is CNCF Incubating, with seven public adopters, 46 contributors and 1,335 GitHub stars, checked on 23 October 2026. The contributor count uses the complete GitHub contributors API response and excludes three automated accounts (renovate, github-actions and dependabot). Mention the breadth of public users without reading every name. The adopter list is voluntary and is not the total installation count. Logos shown: Absa, Millennium bcp, Eficode, Open Systems, PagBank, Darede and Envio. Official brand artwork retains its original colors and proportions. Open Systems logo credit: Uvifian, CC BY-SA 4.0, https://commons.wikimedia.org/wiki/File:Open-systems-logo.svg; original artwork unchanged apart from proportional scaling and PNG rendering. Star count indicates interest, not reliability. Invite the audience to a community meeting; dates and local time are in the linked calendar. At 27:45 elapsed, move from the public adopter logos to the Millennium bcp case study. The sovereignty closing follows the case study at 28:30 elapsed; Questions starts at 29:00.</a:t>
             </a:r>
           </a:p>
           <a:p/>
@@ -2426,7 +2427,7 @@
           <a:p/>
           <a:p>
             <a:r>
-              <a:t>Follow the public adopter logos with one concrete production example. Spend 45 seconds on Millennium bcp. Millennium bcp reports five regions across two cloud providers and on-premises, shorter DNS incident response, and zero downtime in the reported regional failover tests. These are the case study’s reported results for that deployment. Keep to the three displayed facts, then invite questions at 28:30 elapsed.</a:t>
+              <a:t>Follow the public adopter logos with one concrete production example. Spend 45 seconds on Millennium bcp. Millennium bcp reports five regions across two cloud providers and on-premises, shorter DNS incident response, and zero downtime in the reported regional failover tests. These are the case study’s reported results for that deployment. Keep to the three displayed facts, then return to the sovereignty theme at 28:30 elapsed.</a:t>
             </a:r>
           </a:p>
           <a:p/>
@@ -2512,19 +2513,127 @@
           <a:lstStyle/>
           <a:p>
             <a:r>
-              <a:t>Target delivery: 6.5 minutes.</a:t>
+              <a:t>Target delivery: 0.5 minutes.</a:t>
             </a:r>
           </a:p>
           <a:p/>
           <a:p>
             <a:r>
-              <a:t>RUN OF SHOW: 28.5–35 minutes elapsed.</a:t>
+              <a:t>RUN OF SHOW: 28.5–29 minutes elapsed.</a:t>
             </a:r>
           </a:p>
           <a:p/>
           <a:p>
             <a:r>
-              <a:t>Reserve six minutes and thirty seconds for questions, from 28:30 to 35:00 elapsed. Leave the QR code, GitHub, Slack, community-calendar, adopters and LinkedIn links visible. Questions is the final slide. If a question needs the failover-state diagrams, revisit the demo recap on slides 16–18. All 26 slides are part of the main slideshow.</a:t>
+              <a:t>Spend 30 seconds returning to the opening question: who controls the failover? Point to the three cards once. Environment agnostic: k8gb runs on conformant Kubernetes across cloud, on-premises and hybrid environments; your team chooses the infrastructure and participating locations. Distributed DNS: each participating cluster runs a k8gb controller and its own authoritative CoreDNS for the delegated zone. This is the k8gb DNS component, separate from Kubernetes internal service discovery. Own your DNS: the parent can be a self-hosted BIND9 deployment, with delegation to those cluster CoreDNS authorities; the local demo used this arrangement. BIND9 does not replace the per-cluster CoreDNS role. The project is open source, and the configured Gslb strategy drives automatic steering. Close with the footer: you define the traffic strategy; k8gb automates it. Move to Questions at 29:00. Keep the detailed architecture and operating qualifications in the earlier slides; this closing summarizes infrastructure and DNS control, not a compliance guarantee.</a:t>
+            </a:r>
+          </a:p>
+          <a:p/>
+          <a:p>
+            <a:r>
+              <a:t>SOURCE CHECK</a:t>
+            </a:r>
+          </a:p>
+          <a:p>
+            <a:r>
+              <a:t>Local k8gb checkout: 330d33335981b9716bc8ca245660d90893eae272</a:t>
+            </a:r>
+          </a:p>
+          <a:p>
+            <a:r>
+              <a:t>https://github.com/k8gb-io/k8gb/blob/330d33335981b9716bc8ca245660d90893eae272/README.md</a:t>
+            </a:r>
+          </a:p>
+          <a:p>
+            <a:r>
+              <a:t>https://github.com/k8gb-io/k8gb/blob/330d33335981b9716bc8ca245660d90893eae272/docs/components.md</a:t>
+            </a:r>
+          </a:p>
+          <a:p>
+            <a:r>
+              <a:t>https://github.com/k8gb-io/k8gb/blob/330d33335981b9716bc8ca245660d90893eae272/docs/provider_rfc2136.md</a:t>
+            </a:r>
+          </a:p>
+        </p:txBody>
+      </p:sp>
+      <p:sp>
+        <p:nvSpPr>
+          <p:cNvPr id="4" name="Slide Number Placeholder 3"/>
+          <p:cNvSpPr>
+            <a:spLocks noGrp="1"/>
+          </p:cNvSpPr>
+          <p:nvPr>
+            <p:ph type="sldNum" idx="5" sz="quarter"/>
+          </p:nvPr>
+        </p:nvSpPr>
+        <p:spPr/>
+      </p:sp>
+    </p:spTree>
+  </p:cSld>
+  <p:clrMapOvr>
+    <a:masterClrMapping/>
+  </p:clrMapOvr>
+</p:notes>
+</file>
+
+<file path=ppt/notesSlides/notesSlide27.xml><?xml version="1.0" encoding="utf-8"?>
+<p:notes xmlns:a="http://schemas.openxmlformats.org/drawingml/2006/main" xmlns:p="http://schemas.openxmlformats.org/presentationml/2006/main" xmlns:r="http://schemas.openxmlformats.org/officeDocument/2006/relationships">
+  <p:cSld>
+    <p:spTree>
+      <p:nvGrpSpPr>
+        <p:cNvPr id="1" name=""/>
+        <p:cNvGrpSpPr/>
+        <p:nvPr/>
+      </p:nvGrpSpPr>
+      <p:grpSpPr>
+        <a:xfrm>
+          <a:off x="0" y="0"/>
+          <a:ext cx="0" cy="0"/>
+          <a:chOff x="0" y="0"/>
+          <a:chExt cx="0" cy="0"/>
+        </a:xfrm>
+      </p:grpSpPr>
+      <p:sp>
+        <p:nvSpPr>
+          <p:cNvPr id="2" name="Slide Image Placeholder 1"/>
+          <p:cNvSpPr>
+            <a:spLocks noGrp="1"/>
+          </p:cNvSpPr>
+          <p:nvPr>
+            <p:ph type="sldImg" idx="2"/>
+          </p:nvPr>
+        </p:nvSpPr>
+        <p:spPr/>
+      </p:sp>
+      <p:sp>
+        <p:nvSpPr>
+          <p:cNvPr id="3" name="Notes Placeholder 2"/>
+          <p:cNvSpPr>
+            <a:spLocks noGrp="1"/>
+          </p:cNvSpPr>
+          <p:nvPr>
+            <p:ph type="body" idx="3" sz="quarter"/>
+          </p:nvPr>
+        </p:nvSpPr>
+        <p:spPr/>
+        <p:txBody>
+          <a:bodyPr/>
+          <a:lstStyle/>
+          <a:p>
+            <a:r>
+              <a:t>Target delivery: 6 minutes.</a:t>
+            </a:r>
+          </a:p>
+          <a:p/>
+          <a:p>
+            <a:r>
+              <a:t>RUN OF SHOW: 29–35 minutes elapsed.</a:t>
+            </a:r>
+          </a:p>
+          <a:p/>
+          <a:p>
+            <a:r>
+              <a:t>Reserve six minutes for questions, from 29:00 to 35:00 elapsed. Leave the QR code, GitHub, Slack, community-calendar, adopters and LinkedIn links visible. Questions is the final slide. If a question needs the failover-state diagrams, revisit the demo recap on slides 16–18. All 27 slides are part of the main slideshow.</a:t>
             </a:r>
           </a:p>
           <a:p/>
@@ -6481,7 +6590,7 @@
                 </a:solidFill>
                 <a:latin typeface="Arial"/>
               </a:rPr>
-              <a:t>01 / 26</a:t>
+              <a:t>01 / 27</a:t>
             </a:r>
           </a:p>
         </p:txBody>
@@ -7308,7 +7417,7 @@
                 </a:solidFill>
                 <a:latin typeface="Arial"/>
               </a:rPr>
-              <a:t>10 / 26</a:t>
+              <a:t>10 / 27</a:t>
             </a:r>
           </a:p>
         </p:txBody>
@@ -9857,7 +9966,7 @@
                 </a:solidFill>
                 <a:latin typeface="Arial"/>
               </a:rPr>
-              <a:t>11 / 26</a:t>
+              <a:t>11 / 27</a:t>
             </a:r>
           </a:p>
         </p:txBody>
@@ -13561,7 +13670,7 @@
                 </a:solidFill>
                 <a:latin typeface="Arial"/>
               </a:rPr>
-              <a:t>12 / 26</a:t>
+              <a:t>12 / 27</a:t>
             </a:r>
           </a:p>
         </p:txBody>
@@ -17047,7 +17156,7 @@
                 </a:solidFill>
                 <a:latin typeface="Arial"/>
               </a:rPr>
-              <a:t>13 / 26</a:t>
+              <a:t>13 / 27</a:t>
             </a:r>
           </a:p>
         </p:txBody>
@@ -19771,7 +19880,7 @@
                 </a:solidFill>
                 <a:latin typeface="Arial"/>
               </a:rPr>
-              <a:t>14 / 26</a:t>
+              <a:t>14 / 27</a:t>
             </a:r>
           </a:p>
         </p:txBody>
@@ -23800,7 +23909,7 @@
                 </a:solidFill>
                 <a:latin typeface="Arial"/>
               </a:rPr>
-              <a:t>15 / 26</a:t>
+              <a:t>15 / 27</a:t>
             </a:r>
           </a:p>
         </p:txBody>
@@ -26713,7 +26822,7 @@
                 </a:solidFill>
                 <a:latin typeface="Arial"/>
               </a:rPr>
-              <a:t>16 / 26</a:t>
+              <a:t>16 / 27</a:t>
             </a:r>
           </a:p>
         </p:txBody>
@@ -28737,7 +28846,7 @@
                 </a:solidFill>
                 <a:latin typeface="Arial"/>
               </a:rPr>
-              <a:t>17 / 26</a:t>
+              <a:t>17 / 27</a:t>
             </a:r>
           </a:p>
         </p:txBody>
@@ -30761,7 +30870,7 @@
                 </a:solidFill>
                 <a:latin typeface="Arial"/>
               </a:rPr>
-              <a:t>18 / 26</a:t>
+              <a:t>18 / 27</a:t>
             </a:r>
           </a:p>
         </p:txBody>
@@ -32785,7 +32894,7 @@
                 </a:solidFill>
                 <a:latin typeface="Arial"/>
               </a:rPr>
-              <a:t>19 / 26</a:t>
+              <a:t>19 / 27</a:t>
             </a:r>
           </a:p>
         </p:txBody>
@@ -35361,7 +35470,7 @@
                 </a:solidFill>
                 <a:latin typeface="Arial"/>
               </a:rPr>
-              <a:t>02 / 26</a:t>
+              <a:t>02 / 27</a:t>
             </a:r>
           </a:p>
         </p:txBody>
@@ -39587,7 +39696,7 @@
                 </a:solidFill>
                 <a:latin typeface="Arial"/>
               </a:rPr>
-              <a:t>20 / 26</a:t>
+              <a:t>20 / 27</a:t>
             </a:r>
           </a:p>
         </p:txBody>
@@ -41794,7 +41903,7 @@
                 </a:solidFill>
                 <a:latin typeface="Arial"/>
               </a:rPr>
-              <a:t>21 / 26</a:t>
+              <a:t>21 / 27</a:t>
             </a:r>
           </a:p>
         </p:txBody>
@@ -44168,7 +44277,7 @@
                 </a:solidFill>
                 <a:latin typeface="Arial"/>
               </a:rPr>
-              <a:t>22 / 26</a:t>
+              <a:t>22 / 27</a:t>
             </a:r>
           </a:p>
         </p:txBody>
@@ -46398,7 +46507,7 @@
                 </a:solidFill>
                 <a:latin typeface="Arial"/>
               </a:rPr>
-              <a:t>23 / 26</a:t>
+              <a:t>23 / 27</a:t>
             </a:r>
           </a:p>
         </p:txBody>
@@ -47322,7 +47431,7 @@
                 </a:solidFill>
                 <a:latin typeface="Arial"/>
               </a:rPr>
-              <a:t>24 / 26</a:t>
+              <a:t>24 / 27</a:t>
             </a:r>
           </a:p>
         </p:txBody>
@@ -49377,7 +49486,7 @@
                 </a:solidFill>
                 <a:latin typeface="Arial"/>
               </a:rPr>
-              <a:t>25 / 26</a:t>
+              <a:t>25 / 27</a:t>
             </a:r>
           </a:p>
         </p:txBody>
@@ -51016,6 +51125,2497 @@
             <a:avLst/>
           </a:prstGeom>
           <a:solidFill>
+            <a:srgbClr val="102033"/>
+          </a:solidFill>
+          <a:ln>
+            <a:noFill/>
+          </a:ln>
+          <a:effectLst/>
+        </p:spPr>
+        <p:style>
+          <a:lnRef idx="1">
+            <a:schemeClr val="accent1"/>
+          </a:lnRef>
+          <a:fillRef idx="3">
+            <a:schemeClr val="accent1"/>
+          </a:fillRef>
+          <a:effectRef idx="2">
+            <a:schemeClr val="accent1"/>
+          </a:effectRef>
+          <a:fontRef idx="minor">
+            <a:schemeClr val="lt1"/>
+          </a:fontRef>
+        </p:style>
+        <p:txBody>
+          <a:bodyPr rtlCol="0" anchor="ctr"/>
+          <a:lstStyle/>
+          <a:p>
+            <a:pPr algn="ctr"/>
+          </a:p>
+        </p:txBody>
+      </p:sp>
+      <p:sp>
+        <p:nvSpPr>
+          <p:cNvPr id="3" name="TextBox 2"/>
+          <p:cNvSpPr txBox="1"/>
+          <p:nvPr/>
+        </p:nvSpPr>
+        <p:spPr>
+          <a:xfrm>
+            <a:off x="609600" y="279400"/>
+            <a:ext cx="9144000" cy="184150"/>
+          </a:xfrm>
+          <a:prstGeom prst="rect">
+            <a:avLst/>
+          </a:prstGeom>
+          <a:noFill/>
+        </p:spPr>
+        <p:txBody>
+          <a:bodyPr wrap="none" lIns="0" rIns="0" tIns="0" bIns="0" anchor="t">
+            <a:noAutofit/>
+          </a:bodyPr>
+          <a:lstStyle/>
+          <a:p>
+            <a:pPr algn="l">
+              <a:lnSpc>
+                <a:spcPts val="1150"/>
+              </a:lnSpc>
+              <a:spcBef>
+                <a:spcPts val="0"/>
+              </a:spcBef>
+              <a:spcAft>
+                <a:spcPts val="0"/>
+              </a:spcAft>
+            </a:pPr>
+            <a:r>
+              <a:rPr sz="1000" b="1">
+                <a:solidFill>
+                  <a:srgbClr val="F46A87"/>
+                </a:solidFill>
+                <a:latin typeface="Arial"/>
+              </a:rPr>
+              <a:t>SOVEREIGNTY WITH K8GB</a:t>
+            </a:r>
+          </a:p>
+        </p:txBody>
+      </p:sp>
+      <p:sp>
+        <p:nvSpPr>
+          <p:cNvPr id="4" name="TextBox 3"/>
+          <p:cNvSpPr txBox="1"/>
+          <p:nvPr/>
+        </p:nvSpPr>
+        <p:spPr>
+          <a:xfrm>
+            <a:off x="10693400" y="279400"/>
+            <a:ext cx="889000" cy="184150"/>
+          </a:xfrm>
+          <a:prstGeom prst="rect">
+            <a:avLst/>
+          </a:prstGeom>
+          <a:noFill/>
+        </p:spPr>
+        <p:txBody>
+          <a:bodyPr wrap="none" lIns="0" rIns="0" tIns="0" bIns="0" anchor="t">
+            <a:noAutofit/>
+          </a:bodyPr>
+          <a:lstStyle/>
+          <a:p>
+            <a:pPr algn="r">
+              <a:lnSpc>
+                <a:spcPts val="1150"/>
+              </a:lnSpc>
+              <a:spcBef>
+                <a:spcPts val="0"/>
+              </a:spcBef>
+              <a:spcAft>
+                <a:spcPts val="0"/>
+              </a:spcAft>
+            </a:pPr>
+            <a:r>
+              <a:rPr sz="1000" b="0">
+                <a:solidFill>
+                  <a:srgbClr val="B8C8D9"/>
+                </a:solidFill>
+                <a:latin typeface="Arial"/>
+              </a:rPr>
+              <a:t>26 / 27</a:t>
+            </a:r>
+          </a:p>
+        </p:txBody>
+      </p:sp>
+      <p:cxnSp>
+        <p:nvCxnSpPr>
+          <p:cNvPr id="5" name="Connector 4"/>
+          <p:cNvCxnSpPr/>
+          <p:nvPr/>
+        </p:nvCxnSpPr>
+        <p:spPr>
+          <a:xfrm>
+            <a:off x="609600" y="6426200"/>
+            <a:ext cx="10972800" cy="0"/>
+          </a:xfrm>
+          <a:prstGeom prst="line">
+            <a:avLst/>
+          </a:prstGeom>
+          <a:ln w="8890">
+            <a:solidFill>
+              <a:srgbClr val="385068"/>
+            </a:solidFill>
+          </a:ln>
+        </p:spPr>
+        <p:style>
+          <a:lnRef idx="2">
+            <a:schemeClr val="accent1"/>
+          </a:lnRef>
+          <a:fillRef idx="0">
+            <a:schemeClr val="accent1"/>
+          </a:fillRef>
+          <a:effectRef idx="1">
+            <a:schemeClr val="accent1"/>
+          </a:effectRef>
+          <a:fontRef idx="minor">
+            <a:schemeClr val="tx1"/>
+          </a:fontRef>
+        </p:style>
+      </p:cxnSp>
+      <p:sp>
+        <p:nvSpPr>
+          <p:cNvPr id="6" name="TextBox 5"/>
+          <p:cNvSpPr txBox="1"/>
+          <p:nvPr/>
+        </p:nvSpPr>
+        <p:spPr>
+          <a:xfrm>
+            <a:off x="609600" y="6553200"/>
+            <a:ext cx="4318000" cy="169545"/>
+          </a:xfrm>
+          <a:prstGeom prst="rect">
+            <a:avLst/>
+          </a:prstGeom>
+          <a:noFill/>
+        </p:spPr>
+        <p:txBody>
+          <a:bodyPr wrap="none" lIns="0" rIns="0" tIns="0" bIns="0" anchor="t">
+            <a:noAutofit/>
+          </a:bodyPr>
+          <a:lstStyle/>
+          <a:p>
+            <a:pPr algn="l">
+              <a:lnSpc>
+                <a:spcPts val="1035"/>
+              </a:lnSpc>
+              <a:spcBef>
+                <a:spcPts val="0"/>
+              </a:spcBef>
+              <a:spcAft>
+                <a:spcPts val="0"/>
+              </a:spcAft>
+            </a:pPr>
+            <a:r>
+              <a:rPr sz="900" b="1">
+                <a:solidFill>
+                  <a:srgbClr val="B8C8D9"/>
+                </a:solidFill>
+                <a:latin typeface="Arial"/>
+              </a:rPr>
+              <a:t>SOVEREIGN CLOUD DAYS 2026</a:t>
+            </a:r>
+          </a:p>
+        </p:txBody>
+      </p:sp>
+      <p:sp>
+        <p:nvSpPr>
+          <p:cNvPr id="7" name="TextBox 6"/>
+          <p:cNvSpPr txBox="1"/>
+          <p:nvPr/>
+        </p:nvSpPr>
+        <p:spPr>
+          <a:xfrm>
+            <a:off x="8255000" y="6553200"/>
+            <a:ext cx="3327400" cy="169545"/>
+          </a:xfrm>
+          <a:prstGeom prst="rect">
+            <a:avLst/>
+          </a:prstGeom>
+          <a:noFill/>
+        </p:spPr>
+        <p:txBody>
+          <a:bodyPr wrap="none" lIns="0" rIns="0" tIns="0" bIns="0" anchor="t">
+            <a:noAutofit/>
+          </a:bodyPr>
+          <a:lstStyle/>
+          <a:p>
+            <a:pPr algn="r">
+              <a:lnSpc>
+                <a:spcPts val="1035"/>
+              </a:lnSpc>
+              <a:spcBef>
+                <a:spcPts val="0"/>
+              </a:spcBef>
+              <a:spcAft>
+                <a:spcPts val="0"/>
+              </a:spcAft>
+            </a:pPr>
+            <a:r>
+              <a:rPr sz="900" b="0">
+                <a:solidFill>
+                  <a:srgbClr val="B8C8D9"/>
+                </a:solidFill>
+                <a:latin typeface="Arial"/>
+              </a:rPr>
+              <a:t>YURY TSAREV  /  K8GB</a:t>
+            </a:r>
+          </a:p>
+        </p:txBody>
+      </p:sp>
+      <p:sp>
+        <p:nvSpPr>
+          <p:cNvPr id="8" name="TextBox 7"/>
+          <p:cNvSpPr txBox="1"/>
+          <p:nvPr/>
+        </p:nvSpPr>
+        <p:spPr>
+          <a:xfrm>
+            <a:off x="609600" y="825500"/>
+            <a:ext cx="9271000" cy="1135380"/>
+          </a:xfrm>
+          <a:prstGeom prst="rect">
+            <a:avLst/>
+          </a:prstGeom>
+          <a:noFill/>
+        </p:spPr>
+        <p:txBody>
+          <a:bodyPr wrap="none" lIns="0" rIns="0" tIns="0" bIns="0" anchor="t">
+            <a:noAutofit/>
+          </a:bodyPr>
+          <a:lstStyle/>
+          <a:p>
+            <a:pPr algn="l">
+              <a:lnSpc>
+                <a:spcPts val="4320"/>
+              </a:lnSpc>
+              <a:spcBef>
+                <a:spcPts val="0"/>
+              </a:spcBef>
+              <a:spcAft>
+                <a:spcPts val="0"/>
+              </a:spcAft>
+            </a:pPr>
+            <a:r>
+              <a:rPr sz="4000" b="1">
+                <a:solidFill>
+                  <a:srgbClr val="FFFFFF"/>
+                </a:solidFill>
+                <a:latin typeface="Arial"/>
+              </a:rPr>
+              <a:t>Your infrastructure.</a:t>
+            </a:r>
+          </a:p>
+          <a:p>
+            <a:pPr algn="l">
+              <a:lnSpc>
+                <a:spcPts val="4320"/>
+              </a:lnSpc>
+              <a:spcBef>
+                <a:spcPts val="0"/>
+              </a:spcBef>
+              <a:spcAft>
+                <a:spcPts val="0"/>
+              </a:spcAft>
+            </a:pPr>
+            <a:r>
+              <a:rPr sz="4000" b="1">
+                <a:solidFill>
+                  <a:srgbClr val="FFFFFF"/>
+                </a:solidFill>
+                <a:latin typeface="Arial"/>
+              </a:rPr>
+              <a:t>Your DNS. Your failover.</a:t>
+            </a:r>
+          </a:p>
+        </p:txBody>
+      </p:sp>
+      <p:pic>
+        <p:nvPicPr>
+          <p:cNvPr id="9" name="Picture 8" descr="image.png"/>
+          <p:cNvPicPr>
+            <a:picLocks noChangeAspect="1"/>
+          </p:cNvPicPr>
+          <p:nvPr/>
+        </p:nvPicPr>
+        <p:blipFill>
+          <a:blip r:embed="rId2"/>
+          <a:stretch>
+            <a:fillRect/>
+          </a:stretch>
+        </p:blipFill>
+        <p:spPr>
+          <a:xfrm>
+            <a:off x="10388600" y="940486"/>
+            <a:ext cx="1117600" cy="1090827"/>
+          </a:xfrm>
+          <a:prstGeom prst="rect">
+            <a:avLst/>
+          </a:prstGeom>
+        </p:spPr>
+      </p:pic>
+      <p:sp>
+        <p:nvSpPr>
+          <p:cNvPr id="10" name="Rounded Rectangle 9"/>
+          <p:cNvSpPr/>
+          <p:nvPr/>
+        </p:nvSpPr>
+        <p:spPr>
+          <a:xfrm>
+            <a:off x="609600" y="2654300"/>
+            <a:ext cx="3352800" cy="2705100"/>
+          </a:xfrm>
+          <a:prstGeom prst="roundRect">
+            <a:avLst>
+              <a:gd name="adj" fmla="val 4225"/>
+            </a:avLst>
+          </a:prstGeom>
+          <a:solidFill>
+            <a:srgbClr val="1A3047"/>
+          </a:solidFill>
+          <a:ln>
+            <a:noFill/>
+          </a:ln>
+          <a:effectLst/>
+        </p:spPr>
+        <p:style>
+          <a:lnRef idx="1">
+            <a:schemeClr val="accent1"/>
+          </a:lnRef>
+          <a:fillRef idx="3">
+            <a:schemeClr val="accent1"/>
+          </a:fillRef>
+          <a:effectRef idx="2">
+            <a:schemeClr val="accent1"/>
+          </a:effectRef>
+          <a:fontRef idx="minor">
+            <a:schemeClr val="lt1"/>
+          </a:fontRef>
+        </p:style>
+        <p:txBody>
+          <a:bodyPr rtlCol="0" anchor="ctr"/>
+          <a:lstStyle/>
+          <a:p>
+            <a:pPr algn="ctr"/>
+          </a:p>
+        </p:txBody>
+      </p:sp>
+      <p:cxnSp>
+        <p:nvCxnSpPr>
+          <p:cNvPr id="11" name="Connector 10"/>
+          <p:cNvCxnSpPr/>
+          <p:nvPr/>
+        </p:nvCxnSpPr>
+        <p:spPr>
+          <a:xfrm>
+            <a:off x="812800" y="2654300"/>
+            <a:ext cx="2946400" cy="0"/>
+          </a:xfrm>
+          <a:prstGeom prst="line">
+            <a:avLst/>
+          </a:prstGeom>
+          <a:ln w="31750">
+            <a:solidFill>
+              <a:srgbClr val="83ADFF"/>
+            </a:solidFill>
+          </a:ln>
+        </p:spPr>
+        <p:style>
+          <a:lnRef idx="2">
+            <a:schemeClr val="accent1"/>
+          </a:lnRef>
+          <a:fillRef idx="0">
+            <a:schemeClr val="accent1"/>
+          </a:fillRef>
+          <a:effectRef idx="1">
+            <a:schemeClr val="accent1"/>
+          </a:effectRef>
+          <a:fontRef idx="minor">
+            <a:schemeClr val="tx1"/>
+          </a:fontRef>
+        </p:style>
+      </p:cxnSp>
+      <p:sp>
+        <p:nvSpPr>
+          <p:cNvPr id="12" name="Rounded Rectangle 11"/>
+          <p:cNvSpPr/>
+          <p:nvPr/>
+        </p:nvSpPr>
+        <p:spPr>
+          <a:xfrm>
+            <a:off x="812800" y="2870200"/>
+            <a:ext cx="609600" cy="609600"/>
+          </a:xfrm>
+          <a:prstGeom prst="roundRect">
+            <a:avLst>
+              <a:gd name="adj" fmla="val 18750"/>
+            </a:avLst>
+          </a:prstGeom>
+          <a:solidFill>
+            <a:srgbClr val="FFFFFF"/>
+          </a:solidFill>
+          <a:ln>
+            <a:noFill/>
+          </a:ln>
+          <a:effectLst/>
+        </p:spPr>
+        <p:style>
+          <a:lnRef idx="1">
+            <a:schemeClr val="accent1"/>
+          </a:lnRef>
+          <a:fillRef idx="3">
+            <a:schemeClr val="accent1"/>
+          </a:fillRef>
+          <a:effectRef idx="2">
+            <a:schemeClr val="accent1"/>
+          </a:effectRef>
+          <a:fontRef idx="minor">
+            <a:schemeClr val="lt1"/>
+          </a:fontRef>
+        </p:style>
+        <p:txBody>
+          <a:bodyPr rtlCol="0" anchor="ctr"/>
+          <a:lstStyle/>
+          <a:p>
+            <a:pPr algn="ctr"/>
+          </a:p>
+        </p:txBody>
+      </p:sp>
+      <p:pic>
+        <p:nvPicPr>
+          <p:cNvPr id="13" name="Picture 12" descr="image.png"/>
+          <p:cNvPicPr>
+            <a:picLocks noChangeAspect="1"/>
+          </p:cNvPicPr>
+          <p:nvPr/>
+        </p:nvPicPr>
+        <p:blipFill>
+          <a:blip r:embed="rId3"/>
+          <a:stretch>
+            <a:fillRect/>
+          </a:stretch>
+        </p:blipFill>
+        <p:spPr>
+          <a:xfrm>
+            <a:off x="876300" y="2933700"/>
+            <a:ext cx="482600" cy="482600"/>
+          </a:xfrm>
+          <a:prstGeom prst="rect">
+            <a:avLst/>
+          </a:prstGeom>
+        </p:spPr>
+      </p:pic>
+      <p:sp>
+        <p:nvSpPr>
+          <p:cNvPr id="14" name="TextBox 13"/>
+          <p:cNvSpPr txBox="1"/>
+          <p:nvPr/>
+        </p:nvSpPr>
+        <p:spPr>
+          <a:xfrm>
+            <a:off x="812800" y="3683000"/>
+            <a:ext cx="2946400" cy="344805"/>
+          </a:xfrm>
+          <a:prstGeom prst="rect">
+            <a:avLst/>
+          </a:prstGeom>
+          <a:noFill/>
+        </p:spPr>
+        <p:txBody>
+          <a:bodyPr wrap="none" lIns="0" rIns="0" tIns="0" bIns="0" anchor="t">
+            <a:noAutofit/>
+          </a:bodyPr>
+          <a:lstStyle/>
+          <a:p>
+            <a:pPr algn="l">
+              <a:lnSpc>
+                <a:spcPts val="2415"/>
+              </a:lnSpc>
+              <a:spcBef>
+                <a:spcPts val="0"/>
+              </a:spcBef>
+              <a:spcAft>
+                <a:spcPts val="0"/>
+              </a:spcAft>
+            </a:pPr>
+            <a:r>
+              <a:rPr sz="2100" b="1">
+                <a:solidFill>
+                  <a:srgbClr val="83ADFF"/>
+                </a:solidFill>
+                <a:latin typeface="Arial"/>
+              </a:rPr>
+              <a:t>Environment agnostic</a:t>
+            </a:r>
+          </a:p>
+        </p:txBody>
+      </p:sp>
+      <p:sp>
+        <p:nvSpPr>
+          <p:cNvPr id="15" name="TextBox 14"/>
+          <p:cNvSpPr txBox="1"/>
+          <p:nvPr/>
+        </p:nvSpPr>
+        <p:spPr>
+          <a:xfrm>
+            <a:off x="812800" y="4178300"/>
+            <a:ext cx="2946400" cy="921257"/>
+          </a:xfrm>
+          <a:prstGeom prst="rect">
+            <a:avLst/>
+          </a:prstGeom>
+          <a:noFill/>
+        </p:spPr>
+        <p:txBody>
+          <a:bodyPr wrap="none" lIns="0" rIns="0" tIns="0" bIns="0" anchor="t">
+            <a:noAutofit/>
+          </a:bodyPr>
+          <a:lstStyle/>
+          <a:p>
+            <a:pPr algn="l">
+              <a:lnSpc>
+                <a:spcPts val="2318"/>
+              </a:lnSpc>
+              <a:spcBef>
+                <a:spcPts val="0"/>
+              </a:spcBef>
+              <a:spcAft>
+                <a:spcPts val="0"/>
+              </a:spcAft>
+            </a:pPr>
+            <a:r>
+              <a:rPr sz="1900" b="0">
+                <a:solidFill>
+                  <a:srgbClr val="FFFFFF"/>
+                </a:solidFill>
+                <a:latin typeface="Arial"/>
+              </a:rPr>
+              <a:t>Conformant Kubernetes.</a:t>
+            </a:r>
+          </a:p>
+          <a:p>
+            <a:pPr algn="l">
+              <a:lnSpc>
+                <a:spcPts val="2318"/>
+              </a:lnSpc>
+              <a:spcBef>
+                <a:spcPts val="0"/>
+              </a:spcBef>
+              <a:spcAft>
+                <a:spcPts val="0"/>
+              </a:spcAft>
+            </a:pPr>
+            <a:r>
+              <a:rPr sz="1900" b="0">
+                <a:solidFill>
+                  <a:srgbClr val="FFFFFF"/>
+                </a:solidFill>
+                <a:latin typeface="Arial"/>
+              </a:rPr>
+              <a:t>Cloud, on-premises,</a:t>
+            </a:r>
+          </a:p>
+          <a:p>
+            <a:pPr algn="l">
+              <a:lnSpc>
+                <a:spcPts val="2318"/>
+              </a:lnSpc>
+              <a:spcBef>
+                <a:spcPts val="0"/>
+              </a:spcBef>
+              <a:spcAft>
+                <a:spcPts val="0"/>
+              </a:spcAft>
+            </a:pPr>
+            <a:r>
+              <a:rPr sz="1900" b="0">
+                <a:solidFill>
+                  <a:srgbClr val="FFFFFF"/>
+                </a:solidFill>
+                <a:latin typeface="Arial"/>
+              </a:rPr>
+              <a:t>or hybrid.</a:t>
+            </a:r>
+          </a:p>
+        </p:txBody>
+      </p:sp>
+      <p:sp>
+        <p:nvSpPr>
+          <p:cNvPr id="16" name="Rounded Rectangle 15"/>
+          <p:cNvSpPr/>
+          <p:nvPr/>
+        </p:nvSpPr>
+        <p:spPr>
+          <a:xfrm>
+            <a:off x="4419600" y="2654300"/>
+            <a:ext cx="3352800" cy="2705100"/>
+          </a:xfrm>
+          <a:prstGeom prst="roundRect">
+            <a:avLst>
+              <a:gd name="adj" fmla="val 4225"/>
+            </a:avLst>
+          </a:prstGeom>
+          <a:solidFill>
+            <a:srgbClr val="1A3047"/>
+          </a:solidFill>
+          <a:ln>
+            <a:noFill/>
+          </a:ln>
+          <a:effectLst/>
+        </p:spPr>
+        <p:style>
+          <a:lnRef idx="1">
+            <a:schemeClr val="accent1"/>
+          </a:lnRef>
+          <a:fillRef idx="3">
+            <a:schemeClr val="accent1"/>
+          </a:fillRef>
+          <a:effectRef idx="2">
+            <a:schemeClr val="accent1"/>
+          </a:effectRef>
+          <a:fontRef idx="minor">
+            <a:schemeClr val="lt1"/>
+          </a:fontRef>
+        </p:style>
+        <p:txBody>
+          <a:bodyPr rtlCol="0" anchor="ctr"/>
+          <a:lstStyle/>
+          <a:p>
+            <a:pPr algn="ctr"/>
+          </a:p>
+        </p:txBody>
+      </p:sp>
+      <p:cxnSp>
+        <p:nvCxnSpPr>
+          <p:cNvPr id="17" name="Connector 16"/>
+          <p:cNvCxnSpPr/>
+          <p:nvPr/>
+        </p:nvCxnSpPr>
+        <p:spPr>
+          <a:xfrm>
+            <a:off x="4622800" y="2654300"/>
+            <a:ext cx="2946400" cy="0"/>
+          </a:xfrm>
+          <a:prstGeom prst="line">
+            <a:avLst/>
+          </a:prstGeom>
+          <a:ln w="31750">
+            <a:solidFill>
+              <a:srgbClr val="66CBC9"/>
+            </a:solidFill>
+          </a:ln>
+        </p:spPr>
+        <p:style>
+          <a:lnRef idx="2">
+            <a:schemeClr val="accent1"/>
+          </a:lnRef>
+          <a:fillRef idx="0">
+            <a:schemeClr val="accent1"/>
+          </a:fillRef>
+          <a:effectRef idx="1">
+            <a:schemeClr val="accent1"/>
+          </a:effectRef>
+          <a:fontRef idx="minor">
+            <a:schemeClr val="tx1"/>
+          </a:fontRef>
+        </p:style>
+      </p:cxnSp>
+      <p:sp>
+        <p:nvSpPr>
+          <p:cNvPr id="18" name="Rounded Rectangle 17"/>
+          <p:cNvSpPr/>
+          <p:nvPr/>
+        </p:nvSpPr>
+        <p:spPr>
+          <a:xfrm>
+            <a:off x="4622800" y="2870200"/>
+            <a:ext cx="609600" cy="609600"/>
+          </a:xfrm>
+          <a:prstGeom prst="roundRect">
+            <a:avLst>
+              <a:gd name="adj" fmla="val 18750"/>
+            </a:avLst>
+          </a:prstGeom>
+          <a:solidFill>
+            <a:srgbClr val="FFFFFF"/>
+          </a:solidFill>
+          <a:ln>
+            <a:noFill/>
+          </a:ln>
+          <a:effectLst/>
+        </p:spPr>
+        <p:style>
+          <a:lnRef idx="1">
+            <a:schemeClr val="accent1"/>
+          </a:lnRef>
+          <a:fillRef idx="3">
+            <a:schemeClr val="accent1"/>
+          </a:fillRef>
+          <a:effectRef idx="2">
+            <a:schemeClr val="accent1"/>
+          </a:effectRef>
+          <a:fontRef idx="minor">
+            <a:schemeClr val="lt1"/>
+          </a:fontRef>
+        </p:style>
+        <p:txBody>
+          <a:bodyPr rtlCol="0" anchor="ctr"/>
+          <a:lstStyle/>
+          <a:p>
+            <a:pPr algn="ctr"/>
+          </a:p>
+        </p:txBody>
+      </p:sp>
+      <p:pic>
+        <p:nvPicPr>
+          <p:cNvPr id="19" name="Picture 18" descr="image.png"/>
+          <p:cNvPicPr>
+            <a:picLocks noChangeAspect="1"/>
+          </p:cNvPicPr>
+          <p:nvPr/>
+        </p:nvPicPr>
+        <p:blipFill>
+          <a:blip r:embed="rId4"/>
+          <a:stretch>
+            <a:fillRect/>
+          </a:stretch>
+        </p:blipFill>
+        <p:spPr>
+          <a:xfrm>
+            <a:off x="4686300" y="2933700"/>
+            <a:ext cx="482600" cy="482600"/>
+          </a:xfrm>
+          <a:prstGeom prst="rect">
+            <a:avLst/>
+          </a:prstGeom>
+        </p:spPr>
+      </p:pic>
+      <p:sp>
+        <p:nvSpPr>
+          <p:cNvPr id="20" name="TextBox 19"/>
+          <p:cNvSpPr txBox="1"/>
+          <p:nvPr/>
+        </p:nvSpPr>
+        <p:spPr>
+          <a:xfrm>
+            <a:off x="4622800" y="3683000"/>
+            <a:ext cx="2946400" cy="344805"/>
+          </a:xfrm>
+          <a:prstGeom prst="rect">
+            <a:avLst/>
+          </a:prstGeom>
+          <a:noFill/>
+        </p:spPr>
+        <p:txBody>
+          <a:bodyPr wrap="none" lIns="0" rIns="0" tIns="0" bIns="0" anchor="t">
+            <a:noAutofit/>
+          </a:bodyPr>
+          <a:lstStyle/>
+          <a:p>
+            <a:pPr algn="l">
+              <a:lnSpc>
+                <a:spcPts val="2415"/>
+              </a:lnSpc>
+              <a:spcBef>
+                <a:spcPts val="0"/>
+              </a:spcBef>
+              <a:spcAft>
+                <a:spcPts val="0"/>
+              </a:spcAft>
+            </a:pPr>
+            <a:r>
+              <a:rPr sz="2100" b="1">
+                <a:solidFill>
+                  <a:srgbClr val="66CBC9"/>
+                </a:solidFill>
+                <a:latin typeface="Arial"/>
+              </a:rPr>
+              <a:t>Distributed DNS</a:t>
+            </a:r>
+          </a:p>
+        </p:txBody>
+      </p:sp>
+      <p:sp>
+        <p:nvSpPr>
+          <p:cNvPr id="21" name="TextBox 20"/>
+          <p:cNvSpPr txBox="1"/>
+          <p:nvPr/>
+        </p:nvSpPr>
+        <p:spPr>
+          <a:xfrm>
+            <a:off x="4622800" y="4178300"/>
+            <a:ext cx="2946400" cy="921257"/>
+          </a:xfrm>
+          <a:prstGeom prst="rect">
+            <a:avLst/>
+          </a:prstGeom>
+          <a:noFill/>
+        </p:spPr>
+        <p:txBody>
+          <a:bodyPr wrap="none" lIns="0" rIns="0" tIns="0" bIns="0" anchor="t">
+            <a:noAutofit/>
+          </a:bodyPr>
+          <a:lstStyle/>
+          <a:p>
+            <a:pPr algn="l">
+              <a:lnSpc>
+                <a:spcPts val="2318"/>
+              </a:lnSpc>
+              <a:spcBef>
+                <a:spcPts val="0"/>
+              </a:spcBef>
+              <a:spcAft>
+                <a:spcPts val="0"/>
+              </a:spcAft>
+            </a:pPr>
+            <a:r>
+              <a:rPr sz="1900" b="0">
+                <a:solidFill>
+                  <a:srgbClr val="FFFFFF"/>
+                </a:solidFill>
+                <a:latin typeface="Arial"/>
+              </a:rPr>
+              <a:t>k8gb + authoritative</a:t>
+            </a:r>
+          </a:p>
+          <a:p>
+            <a:pPr algn="l">
+              <a:lnSpc>
+                <a:spcPts val="2318"/>
+              </a:lnSpc>
+              <a:spcBef>
+                <a:spcPts val="0"/>
+              </a:spcBef>
+              <a:spcAft>
+                <a:spcPts val="0"/>
+              </a:spcAft>
+            </a:pPr>
+            <a:r>
+              <a:rPr sz="1900" b="0">
+                <a:solidFill>
+                  <a:srgbClr val="FFFFFF"/>
+                </a:solidFill>
+                <a:latin typeface="Arial"/>
+              </a:rPr>
+              <a:t>CoreDNS in each</a:t>
+            </a:r>
+          </a:p>
+          <a:p>
+            <a:pPr algn="l">
+              <a:lnSpc>
+                <a:spcPts val="2318"/>
+              </a:lnSpc>
+              <a:spcBef>
+                <a:spcPts val="0"/>
+              </a:spcBef>
+              <a:spcAft>
+                <a:spcPts val="0"/>
+              </a:spcAft>
+            </a:pPr>
+            <a:r>
+              <a:rPr sz="1900" b="0">
+                <a:solidFill>
+                  <a:srgbClr val="FFFFFF"/>
+                </a:solidFill>
+                <a:latin typeface="Arial"/>
+              </a:rPr>
+              <a:t>participating cluster.</a:t>
+            </a:r>
+          </a:p>
+        </p:txBody>
+      </p:sp>
+      <p:sp>
+        <p:nvSpPr>
+          <p:cNvPr id="22" name="Rounded Rectangle 21"/>
+          <p:cNvSpPr/>
+          <p:nvPr/>
+        </p:nvSpPr>
+        <p:spPr>
+          <a:xfrm>
+            <a:off x="8229600" y="2654300"/>
+            <a:ext cx="3352800" cy="2705100"/>
+          </a:xfrm>
+          <a:prstGeom prst="roundRect">
+            <a:avLst>
+              <a:gd name="adj" fmla="val 4225"/>
+            </a:avLst>
+          </a:prstGeom>
+          <a:solidFill>
+            <a:srgbClr val="1A3047"/>
+          </a:solidFill>
+          <a:ln>
+            <a:noFill/>
+          </a:ln>
+          <a:effectLst/>
+        </p:spPr>
+        <p:style>
+          <a:lnRef idx="1">
+            <a:schemeClr val="accent1"/>
+          </a:lnRef>
+          <a:fillRef idx="3">
+            <a:schemeClr val="accent1"/>
+          </a:fillRef>
+          <a:effectRef idx="2">
+            <a:schemeClr val="accent1"/>
+          </a:effectRef>
+          <a:fontRef idx="minor">
+            <a:schemeClr val="lt1"/>
+          </a:fontRef>
+        </p:style>
+        <p:txBody>
+          <a:bodyPr rtlCol="0" anchor="ctr"/>
+          <a:lstStyle/>
+          <a:p>
+            <a:pPr algn="ctr"/>
+          </a:p>
+        </p:txBody>
+      </p:sp>
+      <p:cxnSp>
+        <p:nvCxnSpPr>
+          <p:cNvPr id="23" name="Connector 22"/>
+          <p:cNvCxnSpPr/>
+          <p:nvPr/>
+        </p:nvCxnSpPr>
+        <p:spPr>
+          <a:xfrm>
+            <a:off x="8432800" y="2654300"/>
+            <a:ext cx="2946400" cy="0"/>
+          </a:xfrm>
+          <a:prstGeom prst="line">
+            <a:avLst/>
+          </a:prstGeom>
+          <a:ln w="31750">
+            <a:solidFill>
+              <a:srgbClr val="F79BB0"/>
+            </a:solidFill>
+          </a:ln>
+        </p:spPr>
+        <p:style>
+          <a:lnRef idx="2">
+            <a:schemeClr val="accent1"/>
+          </a:lnRef>
+          <a:fillRef idx="0">
+            <a:schemeClr val="accent1"/>
+          </a:fillRef>
+          <a:effectRef idx="1">
+            <a:schemeClr val="accent1"/>
+          </a:effectRef>
+          <a:fontRef idx="minor">
+            <a:schemeClr val="tx1"/>
+          </a:fontRef>
+        </p:style>
+      </p:cxnSp>
+      <p:sp>
+        <p:nvSpPr>
+          <p:cNvPr id="24" name="Rounded Rectangle 23"/>
+          <p:cNvSpPr/>
+          <p:nvPr/>
+        </p:nvSpPr>
+        <p:spPr>
+          <a:xfrm>
+            <a:off x="8432800" y="2870200"/>
+            <a:ext cx="609600" cy="609600"/>
+          </a:xfrm>
+          <a:prstGeom prst="roundRect">
+            <a:avLst>
+              <a:gd name="adj" fmla="val 18750"/>
+            </a:avLst>
+          </a:prstGeom>
+          <a:solidFill>
+            <a:srgbClr val="FFFFFF"/>
+          </a:solidFill>
+          <a:ln>
+            <a:noFill/>
+          </a:ln>
+          <a:effectLst/>
+        </p:spPr>
+        <p:style>
+          <a:lnRef idx="1">
+            <a:schemeClr val="accent1"/>
+          </a:lnRef>
+          <a:fillRef idx="3">
+            <a:schemeClr val="accent1"/>
+          </a:fillRef>
+          <a:effectRef idx="2">
+            <a:schemeClr val="accent1"/>
+          </a:effectRef>
+          <a:fontRef idx="minor">
+            <a:schemeClr val="lt1"/>
+          </a:fontRef>
+        </p:style>
+        <p:txBody>
+          <a:bodyPr rtlCol="0" anchor="ctr"/>
+          <a:lstStyle/>
+          <a:p>
+            <a:pPr algn="ctr"/>
+          </a:p>
+        </p:txBody>
+      </p:sp>
+      <p:sp>
+        <p:nvSpPr>
+          <p:cNvPr id="25" name="Oval 24"/>
+          <p:cNvSpPr/>
+          <p:nvPr/>
+        </p:nvSpPr>
+        <p:spPr>
+          <a:xfrm>
+            <a:off x="8534400" y="2971800"/>
+            <a:ext cx="406400" cy="406400"/>
+          </a:xfrm>
+          <a:prstGeom prst="ellipse">
+            <a:avLst/>
+          </a:prstGeom>
+          <a:solidFill>
+            <a:srgbClr val="FFFFFF"/>
+          </a:solidFill>
+          <a:ln w="19050">
+            <a:solidFill>
+              <a:srgbClr val="CF0035"/>
+            </a:solidFill>
+          </a:ln>
+          <a:effectLst/>
+        </p:spPr>
+        <p:style>
+          <a:lnRef idx="1">
+            <a:schemeClr val="accent1"/>
+          </a:lnRef>
+          <a:fillRef idx="3">
+            <a:schemeClr val="accent1"/>
+          </a:fillRef>
+          <a:effectRef idx="2">
+            <a:schemeClr val="accent1"/>
+          </a:effectRef>
+          <a:fontRef idx="minor">
+            <a:schemeClr val="lt1"/>
+          </a:fontRef>
+        </p:style>
+        <p:txBody>
+          <a:bodyPr rtlCol="0" anchor="ctr"/>
+          <a:lstStyle/>
+          <a:p>
+            <a:pPr algn="ctr"/>
+          </a:p>
+        </p:txBody>
+      </p:sp>
+      <p:cxnSp>
+        <p:nvCxnSpPr>
+          <p:cNvPr id="26" name="Connector 25"/>
+          <p:cNvCxnSpPr/>
+          <p:nvPr/>
+        </p:nvCxnSpPr>
+        <p:spPr>
+          <a:xfrm flipH="1">
+            <a:off x="8821079" y="3175000"/>
+            <a:ext cx="1865" cy="42247"/>
+          </a:xfrm>
+          <a:prstGeom prst="line">
+            <a:avLst/>
+          </a:prstGeom>
+          <a:ln w="15240">
+            <a:solidFill>
+              <a:srgbClr val="CF0035"/>
+            </a:solidFill>
+          </a:ln>
+        </p:spPr>
+        <p:style>
+          <a:lnRef idx="2">
+            <a:schemeClr val="accent1"/>
+          </a:lnRef>
+          <a:fillRef idx="0">
+            <a:schemeClr val="accent1"/>
+          </a:fillRef>
+          <a:effectRef idx="1">
+            <a:schemeClr val="accent1"/>
+          </a:effectRef>
+          <a:fontRef idx="minor">
+            <a:schemeClr val="tx1"/>
+          </a:fontRef>
+        </p:style>
+      </p:cxnSp>
+      <p:cxnSp>
+        <p:nvCxnSpPr>
+          <p:cNvPr id="27" name="Connector 26"/>
+          <p:cNvCxnSpPr/>
+          <p:nvPr/>
+        </p:nvCxnSpPr>
+        <p:spPr>
+          <a:xfrm flipH="1">
+            <a:off x="8815565" y="3217247"/>
+            <a:ext cx="5514" cy="40401"/>
+          </a:xfrm>
+          <a:prstGeom prst="line">
+            <a:avLst/>
+          </a:prstGeom>
+          <a:ln w="15240">
+            <a:solidFill>
+              <a:srgbClr val="CF0035"/>
+            </a:solidFill>
+          </a:ln>
+        </p:spPr>
+        <p:style>
+          <a:lnRef idx="2">
+            <a:schemeClr val="accent1"/>
+          </a:lnRef>
+          <a:fillRef idx="0">
+            <a:schemeClr val="accent1"/>
+          </a:fillRef>
+          <a:effectRef idx="1">
+            <a:schemeClr val="accent1"/>
+          </a:effectRef>
+          <a:fontRef idx="minor">
+            <a:schemeClr val="tx1"/>
+          </a:fontRef>
+        </p:style>
+      </p:cxnSp>
+      <p:cxnSp>
+        <p:nvCxnSpPr>
+          <p:cNvPr id="28" name="Connector 27"/>
+          <p:cNvCxnSpPr/>
+          <p:nvPr/>
+        </p:nvCxnSpPr>
+        <p:spPr>
+          <a:xfrm flipH="1">
+            <a:off x="8806644" y="3257648"/>
+            <a:ext cx="8921" cy="36789"/>
+          </a:xfrm>
+          <a:prstGeom prst="line">
+            <a:avLst/>
+          </a:prstGeom>
+          <a:ln w="15240">
+            <a:solidFill>
+              <a:srgbClr val="CF0035"/>
+            </a:solidFill>
+          </a:ln>
+        </p:spPr>
+        <p:style>
+          <a:lnRef idx="2">
+            <a:schemeClr val="accent1"/>
+          </a:lnRef>
+          <a:fillRef idx="0">
+            <a:schemeClr val="accent1"/>
+          </a:fillRef>
+          <a:effectRef idx="1">
+            <a:schemeClr val="accent1"/>
+          </a:effectRef>
+          <a:fontRef idx="minor">
+            <a:schemeClr val="tx1"/>
+          </a:fontRef>
+        </p:style>
+      </p:cxnSp>
+      <p:cxnSp>
+        <p:nvCxnSpPr>
+          <p:cNvPr id="29" name="Connector 28"/>
+          <p:cNvCxnSpPr/>
+          <p:nvPr/>
+        </p:nvCxnSpPr>
+        <p:spPr>
+          <a:xfrm flipH="1">
+            <a:off x="8794706" y="3294437"/>
+            <a:ext cx="11938" cy="31570"/>
+          </a:xfrm>
+          <a:prstGeom prst="line">
+            <a:avLst/>
+          </a:prstGeom>
+          <a:ln w="15240">
+            <a:solidFill>
+              <a:srgbClr val="CF0035"/>
+            </a:solidFill>
+          </a:ln>
+        </p:spPr>
+        <p:style>
+          <a:lnRef idx="2">
+            <a:schemeClr val="accent1"/>
+          </a:lnRef>
+          <a:fillRef idx="0">
+            <a:schemeClr val="accent1"/>
+          </a:fillRef>
+          <a:effectRef idx="1">
+            <a:schemeClr val="accent1"/>
+          </a:effectRef>
+          <a:fontRef idx="minor">
+            <a:schemeClr val="tx1"/>
+          </a:fontRef>
+        </p:style>
+      </p:cxnSp>
+      <p:cxnSp>
+        <p:nvCxnSpPr>
+          <p:cNvPr id="30" name="Connector 29"/>
+          <p:cNvCxnSpPr/>
+          <p:nvPr/>
+        </p:nvCxnSpPr>
+        <p:spPr>
+          <a:xfrm flipH="1">
+            <a:off x="8780272" y="3326007"/>
+            <a:ext cx="14434" cy="24969"/>
+          </a:xfrm>
+          <a:prstGeom prst="line">
+            <a:avLst/>
+          </a:prstGeom>
+          <a:ln w="15240">
+            <a:solidFill>
+              <a:srgbClr val="CF0035"/>
+            </a:solidFill>
+          </a:ln>
+        </p:spPr>
+        <p:style>
+          <a:lnRef idx="2">
+            <a:schemeClr val="accent1"/>
+          </a:lnRef>
+          <a:fillRef idx="0">
+            <a:schemeClr val="accent1"/>
+          </a:fillRef>
+          <a:effectRef idx="1">
+            <a:schemeClr val="accent1"/>
+          </a:effectRef>
+          <a:fontRef idx="minor">
+            <a:schemeClr val="tx1"/>
+          </a:fontRef>
+        </p:style>
+      </p:cxnSp>
+      <p:cxnSp>
+        <p:nvCxnSpPr>
+          <p:cNvPr id="31" name="Connector 30"/>
+          <p:cNvCxnSpPr/>
+          <p:nvPr/>
+        </p:nvCxnSpPr>
+        <p:spPr>
+          <a:xfrm flipH="1">
+            <a:off x="8763972" y="3350976"/>
+            <a:ext cx="16300" cy="17278"/>
+          </a:xfrm>
+          <a:prstGeom prst="line">
+            <a:avLst/>
+          </a:prstGeom>
+          <a:ln w="15240">
+            <a:solidFill>
+              <a:srgbClr val="CF0035"/>
+            </a:solidFill>
+          </a:ln>
+        </p:spPr>
+        <p:style>
+          <a:lnRef idx="2">
+            <a:schemeClr val="accent1"/>
+          </a:lnRef>
+          <a:fillRef idx="0">
+            <a:schemeClr val="accent1"/>
+          </a:fillRef>
+          <a:effectRef idx="1">
+            <a:schemeClr val="accent1"/>
+          </a:effectRef>
+          <a:fontRef idx="minor">
+            <a:schemeClr val="tx1"/>
+          </a:fontRef>
+        </p:style>
+      </p:cxnSp>
+      <p:cxnSp>
+        <p:nvCxnSpPr>
+          <p:cNvPr id="32" name="Connector 31"/>
+          <p:cNvCxnSpPr/>
+          <p:nvPr/>
+        </p:nvCxnSpPr>
+        <p:spPr>
+          <a:xfrm flipH="1">
+            <a:off x="8746520" y="3368254"/>
+            <a:ext cx="17452" cy="8832"/>
+          </a:xfrm>
+          <a:prstGeom prst="line">
+            <a:avLst/>
+          </a:prstGeom>
+          <a:ln w="15240">
+            <a:solidFill>
+              <a:srgbClr val="CF0035"/>
+            </a:solidFill>
+          </a:ln>
+        </p:spPr>
+        <p:style>
+          <a:lnRef idx="2">
+            <a:schemeClr val="accent1"/>
+          </a:lnRef>
+          <a:fillRef idx="0">
+            <a:schemeClr val="accent1"/>
+          </a:fillRef>
+          <a:effectRef idx="1">
+            <a:schemeClr val="accent1"/>
+          </a:effectRef>
+          <a:fontRef idx="minor">
+            <a:schemeClr val="tx1"/>
+          </a:fontRef>
+        </p:style>
+      </p:cxnSp>
+      <p:cxnSp>
+        <p:nvCxnSpPr>
+          <p:cNvPr id="33" name="Connector 32"/>
+          <p:cNvCxnSpPr/>
+          <p:nvPr/>
+        </p:nvCxnSpPr>
+        <p:spPr>
+          <a:xfrm flipH="1">
+            <a:off x="8728679" y="3377086"/>
+            <a:ext cx="17841" cy="0"/>
+          </a:xfrm>
+          <a:prstGeom prst="line">
+            <a:avLst/>
+          </a:prstGeom>
+          <a:ln w="15240">
+            <a:solidFill>
+              <a:srgbClr val="CF0035"/>
+            </a:solidFill>
+          </a:ln>
+        </p:spPr>
+        <p:style>
+          <a:lnRef idx="2">
+            <a:schemeClr val="accent1"/>
+          </a:lnRef>
+          <a:fillRef idx="0">
+            <a:schemeClr val="accent1"/>
+          </a:fillRef>
+          <a:effectRef idx="1">
+            <a:schemeClr val="accent1"/>
+          </a:effectRef>
+          <a:fontRef idx="minor">
+            <a:schemeClr val="tx1"/>
+          </a:fontRef>
+        </p:style>
+      </p:cxnSp>
+      <p:cxnSp>
+        <p:nvCxnSpPr>
+          <p:cNvPr id="34" name="Connector 33"/>
+          <p:cNvCxnSpPr/>
+          <p:nvPr/>
+        </p:nvCxnSpPr>
+        <p:spPr>
+          <a:xfrm flipH="1" flipV="1">
+            <a:off x="8711227" y="3368254"/>
+            <a:ext cx="17452" cy="8832"/>
+          </a:xfrm>
+          <a:prstGeom prst="line">
+            <a:avLst/>
+          </a:prstGeom>
+          <a:ln w="15240">
+            <a:solidFill>
+              <a:srgbClr val="CF0035"/>
+            </a:solidFill>
+          </a:ln>
+        </p:spPr>
+        <p:style>
+          <a:lnRef idx="2">
+            <a:schemeClr val="accent1"/>
+          </a:lnRef>
+          <a:fillRef idx="0">
+            <a:schemeClr val="accent1"/>
+          </a:fillRef>
+          <a:effectRef idx="1">
+            <a:schemeClr val="accent1"/>
+          </a:effectRef>
+          <a:fontRef idx="minor">
+            <a:schemeClr val="tx1"/>
+          </a:fontRef>
+        </p:style>
+      </p:cxnSp>
+      <p:cxnSp>
+        <p:nvCxnSpPr>
+          <p:cNvPr id="35" name="Connector 34"/>
+          <p:cNvCxnSpPr/>
+          <p:nvPr/>
+        </p:nvCxnSpPr>
+        <p:spPr>
+          <a:xfrm flipH="1" flipV="1">
+            <a:off x="8694928" y="3350976"/>
+            <a:ext cx="16299" cy="17278"/>
+          </a:xfrm>
+          <a:prstGeom prst="line">
+            <a:avLst/>
+          </a:prstGeom>
+          <a:ln w="15240">
+            <a:solidFill>
+              <a:srgbClr val="CF0035"/>
+            </a:solidFill>
+          </a:ln>
+        </p:spPr>
+        <p:style>
+          <a:lnRef idx="2">
+            <a:schemeClr val="accent1"/>
+          </a:lnRef>
+          <a:fillRef idx="0">
+            <a:schemeClr val="accent1"/>
+          </a:fillRef>
+          <a:effectRef idx="1">
+            <a:schemeClr val="accent1"/>
+          </a:effectRef>
+          <a:fontRef idx="minor">
+            <a:schemeClr val="tx1"/>
+          </a:fontRef>
+        </p:style>
+      </p:cxnSp>
+      <p:cxnSp>
+        <p:nvCxnSpPr>
+          <p:cNvPr id="36" name="Connector 35"/>
+          <p:cNvCxnSpPr/>
+          <p:nvPr/>
+        </p:nvCxnSpPr>
+        <p:spPr>
+          <a:xfrm flipH="1" flipV="1">
+            <a:off x="8680493" y="3326007"/>
+            <a:ext cx="14435" cy="24969"/>
+          </a:xfrm>
+          <a:prstGeom prst="line">
+            <a:avLst/>
+          </a:prstGeom>
+          <a:ln w="15240">
+            <a:solidFill>
+              <a:srgbClr val="CF0035"/>
+            </a:solidFill>
+          </a:ln>
+        </p:spPr>
+        <p:style>
+          <a:lnRef idx="2">
+            <a:schemeClr val="accent1"/>
+          </a:lnRef>
+          <a:fillRef idx="0">
+            <a:schemeClr val="accent1"/>
+          </a:fillRef>
+          <a:effectRef idx="1">
+            <a:schemeClr val="accent1"/>
+          </a:effectRef>
+          <a:fontRef idx="minor">
+            <a:schemeClr val="tx1"/>
+          </a:fontRef>
+        </p:style>
+      </p:cxnSp>
+      <p:cxnSp>
+        <p:nvCxnSpPr>
+          <p:cNvPr id="37" name="Connector 36"/>
+          <p:cNvCxnSpPr/>
+          <p:nvPr/>
+        </p:nvCxnSpPr>
+        <p:spPr>
+          <a:xfrm flipH="1" flipV="1">
+            <a:off x="8668555" y="3294437"/>
+            <a:ext cx="11938" cy="31570"/>
+          </a:xfrm>
+          <a:prstGeom prst="line">
+            <a:avLst/>
+          </a:prstGeom>
+          <a:ln w="15240">
+            <a:solidFill>
+              <a:srgbClr val="CF0035"/>
+            </a:solidFill>
+          </a:ln>
+        </p:spPr>
+        <p:style>
+          <a:lnRef idx="2">
+            <a:schemeClr val="accent1"/>
+          </a:lnRef>
+          <a:fillRef idx="0">
+            <a:schemeClr val="accent1"/>
+          </a:fillRef>
+          <a:effectRef idx="1">
+            <a:schemeClr val="accent1"/>
+          </a:effectRef>
+          <a:fontRef idx="minor">
+            <a:schemeClr val="tx1"/>
+          </a:fontRef>
+        </p:style>
+      </p:cxnSp>
+      <p:cxnSp>
+        <p:nvCxnSpPr>
+          <p:cNvPr id="38" name="Connector 37"/>
+          <p:cNvCxnSpPr/>
+          <p:nvPr/>
+        </p:nvCxnSpPr>
+        <p:spPr>
+          <a:xfrm flipH="1" flipV="1">
+            <a:off x="8659634" y="3257648"/>
+            <a:ext cx="8921" cy="36789"/>
+          </a:xfrm>
+          <a:prstGeom prst="line">
+            <a:avLst/>
+          </a:prstGeom>
+          <a:ln w="15240">
+            <a:solidFill>
+              <a:srgbClr val="CF0035"/>
+            </a:solidFill>
+          </a:ln>
+        </p:spPr>
+        <p:style>
+          <a:lnRef idx="2">
+            <a:schemeClr val="accent1"/>
+          </a:lnRef>
+          <a:fillRef idx="0">
+            <a:schemeClr val="accent1"/>
+          </a:fillRef>
+          <a:effectRef idx="1">
+            <a:schemeClr val="accent1"/>
+          </a:effectRef>
+          <a:fontRef idx="minor">
+            <a:schemeClr val="tx1"/>
+          </a:fontRef>
+        </p:style>
+      </p:cxnSp>
+      <p:cxnSp>
+        <p:nvCxnSpPr>
+          <p:cNvPr id="39" name="Connector 38"/>
+          <p:cNvCxnSpPr/>
+          <p:nvPr/>
+        </p:nvCxnSpPr>
+        <p:spPr>
+          <a:xfrm flipH="1" flipV="1">
+            <a:off x="8654120" y="3217247"/>
+            <a:ext cx="5514" cy="40401"/>
+          </a:xfrm>
+          <a:prstGeom prst="line">
+            <a:avLst/>
+          </a:prstGeom>
+          <a:ln w="15240">
+            <a:solidFill>
+              <a:srgbClr val="CF0035"/>
+            </a:solidFill>
+          </a:ln>
+        </p:spPr>
+        <p:style>
+          <a:lnRef idx="2">
+            <a:schemeClr val="accent1"/>
+          </a:lnRef>
+          <a:fillRef idx="0">
+            <a:schemeClr val="accent1"/>
+          </a:fillRef>
+          <a:effectRef idx="1">
+            <a:schemeClr val="accent1"/>
+          </a:effectRef>
+          <a:fontRef idx="minor">
+            <a:schemeClr val="tx1"/>
+          </a:fontRef>
+        </p:style>
+      </p:cxnSp>
+      <p:cxnSp>
+        <p:nvCxnSpPr>
+          <p:cNvPr id="40" name="Connector 39"/>
+          <p:cNvCxnSpPr/>
+          <p:nvPr/>
+        </p:nvCxnSpPr>
+        <p:spPr>
+          <a:xfrm flipH="1" flipV="1">
+            <a:off x="8652256" y="3175000"/>
+            <a:ext cx="1864" cy="42247"/>
+          </a:xfrm>
+          <a:prstGeom prst="line">
+            <a:avLst/>
+          </a:prstGeom>
+          <a:ln w="15240">
+            <a:solidFill>
+              <a:srgbClr val="CF0035"/>
+            </a:solidFill>
+          </a:ln>
+        </p:spPr>
+        <p:style>
+          <a:lnRef idx="2">
+            <a:schemeClr val="accent1"/>
+          </a:lnRef>
+          <a:fillRef idx="0">
+            <a:schemeClr val="accent1"/>
+          </a:fillRef>
+          <a:effectRef idx="1">
+            <a:schemeClr val="accent1"/>
+          </a:effectRef>
+          <a:fontRef idx="minor">
+            <a:schemeClr val="tx1"/>
+          </a:fontRef>
+        </p:style>
+      </p:cxnSp>
+      <p:cxnSp>
+        <p:nvCxnSpPr>
+          <p:cNvPr id="41" name="Connector 40"/>
+          <p:cNvCxnSpPr/>
+          <p:nvPr/>
+        </p:nvCxnSpPr>
+        <p:spPr>
+          <a:xfrm flipV="1">
+            <a:off x="8652256" y="3132752"/>
+            <a:ext cx="1864" cy="42248"/>
+          </a:xfrm>
+          <a:prstGeom prst="line">
+            <a:avLst/>
+          </a:prstGeom>
+          <a:ln w="15240">
+            <a:solidFill>
+              <a:srgbClr val="CF0035"/>
+            </a:solidFill>
+          </a:ln>
+        </p:spPr>
+        <p:style>
+          <a:lnRef idx="2">
+            <a:schemeClr val="accent1"/>
+          </a:lnRef>
+          <a:fillRef idx="0">
+            <a:schemeClr val="accent1"/>
+          </a:fillRef>
+          <a:effectRef idx="1">
+            <a:schemeClr val="accent1"/>
+          </a:effectRef>
+          <a:fontRef idx="minor">
+            <a:schemeClr val="tx1"/>
+          </a:fontRef>
+        </p:style>
+      </p:cxnSp>
+      <p:cxnSp>
+        <p:nvCxnSpPr>
+          <p:cNvPr id="42" name="Connector 41"/>
+          <p:cNvCxnSpPr/>
+          <p:nvPr/>
+        </p:nvCxnSpPr>
+        <p:spPr>
+          <a:xfrm flipV="1">
+            <a:off x="8654120" y="3092351"/>
+            <a:ext cx="5514" cy="40401"/>
+          </a:xfrm>
+          <a:prstGeom prst="line">
+            <a:avLst/>
+          </a:prstGeom>
+          <a:ln w="15240">
+            <a:solidFill>
+              <a:srgbClr val="CF0035"/>
+            </a:solidFill>
+          </a:ln>
+        </p:spPr>
+        <p:style>
+          <a:lnRef idx="2">
+            <a:schemeClr val="accent1"/>
+          </a:lnRef>
+          <a:fillRef idx="0">
+            <a:schemeClr val="accent1"/>
+          </a:fillRef>
+          <a:effectRef idx="1">
+            <a:schemeClr val="accent1"/>
+          </a:effectRef>
+          <a:fontRef idx="minor">
+            <a:schemeClr val="tx1"/>
+          </a:fontRef>
+        </p:style>
+      </p:cxnSp>
+      <p:cxnSp>
+        <p:nvCxnSpPr>
+          <p:cNvPr id="43" name="Connector 42"/>
+          <p:cNvCxnSpPr/>
+          <p:nvPr/>
+        </p:nvCxnSpPr>
+        <p:spPr>
+          <a:xfrm flipV="1">
+            <a:off x="8659634" y="3055562"/>
+            <a:ext cx="8921" cy="36789"/>
+          </a:xfrm>
+          <a:prstGeom prst="line">
+            <a:avLst/>
+          </a:prstGeom>
+          <a:ln w="15240">
+            <a:solidFill>
+              <a:srgbClr val="CF0035"/>
+            </a:solidFill>
+          </a:ln>
+        </p:spPr>
+        <p:style>
+          <a:lnRef idx="2">
+            <a:schemeClr val="accent1"/>
+          </a:lnRef>
+          <a:fillRef idx="0">
+            <a:schemeClr val="accent1"/>
+          </a:fillRef>
+          <a:effectRef idx="1">
+            <a:schemeClr val="accent1"/>
+          </a:effectRef>
+          <a:fontRef idx="minor">
+            <a:schemeClr val="tx1"/>
+          </a:fontRef>
+        </p:style>
+      </p:cxnSp>
+      <p:cxnSp>
+        <p:nvCxnSpPr>
+          <p:cNvPr id="44" name="Connector 43"/>
+          <p:cNvCxnSpPr/>
+          <p:nvPr/>
+        </p:nvCxnSpPr>
+        <p:spPr>
+          <a:xfrm flipV="1">
+            <a:off x="8668555" y="3023992"/>
+            <a:ext cx="11938" cy="31570"/>
+          </a:xfrm>
+          <a:prstGeom prst="line">
+            <a:avLst/>
+          </a:prstGeom>
+          <a:ln w="15240">
+            <a:solidFill>
+              <a:srgbClr val="CF0035"/>
+            </a:solidFill>
+          </a:ln>
+        </p:spPr>
+        <p:style>
+          <a:lnRef idx="2">
+            <a:schemeClr val="accent1"/>
+          </a:lnRef>
+          <a:fillRef idx="0">
+            <a:schemeClr val="accent1"/>
+          </a:fillRef>
+          <a:effectRef idx="1">
+            <a:schemeClr val="accent1"/>
+          </a:effectRef>
+          <a:fontRef idx="minor">
+            <a:schemeClr val="tx1"/>
+          </a:fontRef>
+        </p:style>
+      </p:cxnSp>
+      <p:cxnSp>
+        <p:nvCxnSpPr>
+          <p:cNvPr id="45" name="Connector 44"/>
+          <p:cNvCxnSpPr/>
+          <p:nvPr/>
+        </p:nvCxnSpPr>
+        <p:spPr>
+          <a:xfrm flipV="1">
+            <a:off x="8680493" y="2999023"/>
+            <a:ext cx="14435" cy="24969"/>
+          </a:xfrm>
+          <a:prstGeom prst="line">
+            <a:avLst/>
+          </a:prstGeom>
+          <a:ln w="15240">
+            <a:solidFill>
+              <a:srgbClr val="CF0035"/>
+            </a:solidFill>
+          </a:ln>
+        </p:spPr>
+        <p:style>
+          <a:lnRef idx="2">
+            <a:schemeClr val="accent1"/>
+          </a:lnRef>
+          <a:fillRef idx="0">
+            <a:schemeClr val="accent1"/>
+          </a:fillRef>
+          <a:effectRef idx="1">
+            <a:schemeClr val="accent1"/>
+          </a:effectRef>
+          <a:fontRef idx="minor">
+            <a:schemeClr val="tx1"/>
+          </a:fontRef>
+        </p:style>
+      </p:cxnSp>
+      <p:cxnSp>
+        <p:nvCxnSpPr>
+          <p:cNvPr id="46" name="Connector 45"/>
+          <p:cNvCxnSpPr/>
+          <p:nvPr/>
+        </p:nvCxnSpPr>
+        <p:spPr>
+          <a:xfrm flipV="1">
+            <a:off x="8694928" y="2981745"/>
+            <a:ext cx="16299" cy="17278"/>
+          </a:xfrm>
+          <a:prstGeom prst="line">
+            <a:avLst/>
+          </a:prstGeom>
+          <a:ln w="15240">
+            <a:solidFill>
+              <a:srgbClr val="CF0035"/>
+            </a:solidFill>
+          </a:ln>
+        </p:spPr>
+        <p:style>
+          <a:lnRef idx="2">
+            <a:schemeClr val="accent1"/>
+          </a:lnRef>
+          <a:fillRef idx="0">
+            <a:schemeClr val="accent1"/>
+          </a:fillRef>
+          <a:effectRef idx="1">
+            <a:schemeClr val="accent1"/>
+          </a:effectRef>
+          <a:fontRef idx="minor">
+            <a:schemeClr val="tx1"/>
+          </a:fontRef>
+        </p:style>
+      </p:cxnSp>
+      <p:cxnSp>
+        <p:nvCxnSpPr>
+          <p:cNvPr id="47" name="Connector 46"/>
+          <p:cNvCxnSpPr/>
+          <p:nvPr/>
+        </p:nvCxnSpPr>
+        <p:spPr>
+          <a:xfrm flipV="1">
+            <a:off x="8711227" y="2972913"/>
+            <a:ext cx="17452" cy="8832"/>
+          </a:xfrm>
+          <a:prstGeom prst="line">
+            <a:avLst/>
+          </a:prstGeom>
+          <a:ln w="15240">
+            <a:solidFill>
+              <a:srgbClr val="CF0035"/>
+            </a:solidFill>
+          </a:ln>
+        </p:spPr>
+        <p:style>
+          <a:lnRef idx="2">
+            <a:schemeClr val="accent1"/>
+          </a:lnRef>
+          <a:fillRef idx="0">
+            <a:schemeClr val="accent1"/>
+          </a:fillRef>
+          <a:effectRef idx="1">
+            <a:schemeClr val="accent1"/>
+          </a:effectRef>
+          <a:fontRef idx="minor">
+            <a:schemeClr val="tx1"/>
+          </a:fontRef>
+        </p:style>
+      </p:cxnSp>
+      <p:cxnSp>
+        <p:nvCxnSpPr>
+          <p:cNvPr id="48" name="Connector 47"/>
+          <p:cNvCxnSpPr/>
+          <p:nvPr/>
+        </p:nvCxnSpPr>
+        <p:spPr>
+          <a:xfrm>
+            <a:off x="8728679" y="2972913"/>
+            <a:ext cx="17841" cy="0"/>
+          </a:xfrm>
+          <a:prstGeom prst="line">
+            <a:avLst/>
+          </a:prstGeom>
+          <a:ln w="15240">
+            <a:solidFill>
+              <a:srgbClr val="CF0035"/>
+            </a:solidFill>
+          </a:ln>
+        </p:spPr>
+        <p:style>
+          <a:lnRef idx="2">
+            <a:schemeClr val="accent1"/>
+          </a:lnRef>
+          <a:fillRef idx="0">
+            <a:schemeClr val="accent1"/>
+          </a:fillRef>
+          <a:effectRef idx="1">
+            <a:schemeClr val="accent1"/>
+          </a:effectRef>
+          <a:fontRef idx="minor">
+            <a:schemeClr val="tx1"/>
+          </a:fontRef>
+        </p:style>
+      </p:cxnSp>
+      <p:cxnSp>
+        <p:nvCxnSpPr>
+          <p:cNvPr id="49" name="Connector 48"/>
+          <p:cNvCxnSpPr/>
+          <p:nvPr/>
+        </p:nvCxnSpPr>
+        <p:spPr>
+          <a:xfrm>
+            <a:off x="8746520" y="2972913"/>
+            <a:ext cx="17452" cy="8832"/>
+          </a:xfrm>
+          <a:prstGeom prst="line">
+            <a:avLst/>
+          </a:prstGeom>
+          <a:ln w="15240">
+            <a:solidFill>
+              <a:srgbClr val="CF0035"/>
+            </a:solidFill>
+          </a:ln>
+        </p:spPr>
+        <p:style>
+          <a:lnRef idx="2">
+            <a:schemeClr val="accent1"/>
+          </a:lnRef>
+          <a:fillRef idx="0">
+            <a:schemeClr val="accent1"/>
+          </a:fillRef>
+          <a:effectRef idx="1">
+            <a:schemeClr val="accent1"/>
+          </a:effectRef>
+          <a:fontRef idx="minor">
+            <a:schemeClr val="tx1"/>
+          </a:fontRef>
+        </p:style>
+      </p:cxnSp>
+      <p:cxnSp>
+        <p:nvCxnSpPr>
+          <p:cNvPr id="50" name="Connector 49"/>
+          <p:cNvCxnSpPr/>
+          <p:nvPr/>
+        </p:nvCxnSpPr>
+        <p:spPr>
+          <a:xfrm>
+            <a:off x="8763972" y="2981745"/>
+            <a:ext cx="16300" cy="17278"/>
+          </a:xfrm>
+          <a:prstGeom prst="line">
+            <a:avLst/>
+          </a:prstGeom>
+          <a:ln w="15240">
+            <a:solidFill>
+              <a:srgbClr val="CF0035"/>
+            </a:solidFill>
+          </a:ln>
+        </p:spPr>
+        <p:style>
+          <a:lnRef idx="2">
+            <a:schemeClr val="accent1"/>
+          </a:lnRef>
+          <a:fillRef idx="0">
+            <a:schemeClr val="accent1"/>
+          </a:fillRef>
+          <a:effectRef idx="1">
+            <a:schemeClr val="accent1"/>
+          </a:effectRef>
+          <a:fontRef idx="minor">
+            <a:schemeClr val="tx1"/>
+          </a:fontRef>
+        </p:style>
+      </p:cxnSp>
+      <p:cxnSp>
+        <p:nvCxnSpPr>
+          <p:cNvPr id="51" name="Connector 50"/>
+          <p:cNvCxnSpPr/>
+          <p:nvPr/>
+        </p:nvCxnSpPr>
+        <p:spPr>
+          <a:xfrm>
+            <a:off x="8780272" y="2999023"/>
+            <a:ext cx="14434" cy="24969"/>
+          </a:xfrm>
+          <a:prstGeom prst="line">
+            <a:avLst/>
+          </a:prstGeom>
+          <a:ln w="15240">
+            <a:solidFill>
+              <a:srgbClr val="CF0035"/>
+            </a:solidFill>
+          </a:ln>
+        </p:spPr>
+        <p:style>
+          <a:lnRef idx="2">
+            <a:schemeClr val="accent1"/>
+          </a:lnRef>
+          <a:fillRef idx="0">
+            <a:schemeClr val="accent1"/>
+          </a:fillRef>
+          <a:effectRef idx="1">
+            <a:schemeClr val="accent1"/>
+          </a:effectRef>
+          <a:fontRef idx="minor">
+            <a:schemeClr val="tx1"/>
+          </a:fontRef>
+        </p:style>
+      </p:cxnSp>
+      <p:cxnSp>
+        <p:nvCxnSpPr>
+          <p:cNvPr id="52" name="Connector 51"/>
+          <p:cNvCxnSpPr/>
+          <p:nvPr/>
+        </p:nvCxnSpPr>
+        <p:spPr>
+          <a:xfrm>
+            <a:off x="8794706" y="3023992"/>
+            <a:ext cx="11938" cy="31570"/>
+          </a:xfrm>
+          <a:prstGeom prst="line">
+            <a:avLst/>
+          </a:prstGeom>
+          <a:ln w="15240">
+            <a:solidFill>
+              <a:srgbClr val="CF0035"/>
+            </a:solidFill>
+          </a:ln>
+        </p:spPr>
+        <p:style>
+          <a:lnRef idx="2">
+            <a:schemeClr val="accent1"/>
+          </a:lnRef>
+          <a:fillRef idx="0">
+            <a:schemeClr val="accent1"/>
+          </a:fillRef>
+          <a:effectRef idx="1">
+            <a:schemeClr val="accent1"/>
+          </a:effectRef>
+          <a:fontRef idx="minor">
+            <a:schemeClr val="tx1"/>
+          </a:fontRef>
+        </p:style>
+      </p:cxnSp>
+      <p:cxnSp>
+        <p:nvCxnSpPr>
+          <p:cNvPr id="53" name="Connector 52"/>
+          <p:cNvCxnSpPr/>
+          <p:nvPr/>
+        </p:nvCxnSpPr>
+        <p:spPr>
+          <a:xfrm>
+            <a:off x="8806644" y="3055562"/>
+            <a:ext cx="8921" cy="36789"/>
+          </a:xfrm>
+          <a:prstGeom prst="line">
+            <a:avLst/>
+          </a:prstGeom>
+          <a:ln w="15240">
+            <a:solidFill>
+              <a:srgbClr val="CF0035"/>
+            </a:solidFill>
+          </a:ln>
+        </p:spPr>
+        <p:style>
+          <a:lnRef idx="2">
+            <a:schemeClr val="accent1"/>
+          </a:lnRef>
+          <a:fillRef idx="0">
+            <a:schemeClr val="accent1"/>
+          </a:fillRef>
+          <a:effectRef idx="1">
+            <a:schemeClr val="accent1"/>
+          </a:effectRef>
+          <a:fontRef idx="minor">
+            <a:schemeClr val="tx1"/>
+          </a:fontRef>
+        </p:style>
+      </p:cxnSp>
+      <p:cxnSp>
+        <p:nvCxnSpPr>
+          <p:cNvPr id="54" name="Connector 53"/>
+          <p:cNvCxnSpPr/>
+          <p:nvPr/>
+        </p:nvCxnSpPr>
+        <p:spPr>
+          <a:xfrm>
+            <a:off x="8815565" y="3092351"/>
+            <a:ext cx="5514" cy="40401"/>
+          </a:xfrm>
+          <a:prstGeom prst="line">
+            <a:avLst/>
+          </a:prstGeom>
+          <a:ln w="15240">
+            <a:solidFill>
+              <a:srgbClr val="CF0035"/>
+            </a:solidFill>
+          </a:ln>
+        </p:spPr>
+        <p:style>
+          <a:lnRef idx="2">
+            <a:schemeClr val="accent1"/>
+          </a:lnRef>
+          <a:fillRef idx="0">
+            <a:schemeClr val="accent1"/>
+          </a:fillRef>
+          <a:effectRef idx="1">
+            <a:schemeClr val="accent1"/>
+          </a:effectRef>
+          <a:fontRef idx="minor">
+            <a:schemeClr val="tx1"/>
+          </a:fontRef>
+        </p:style>
+      </p:cxnSp>
+      <p:cxnSp>
+        <p:nvCxnSpPr>
+          <p:cNvPr id="55" name="Connector 54"/>
+          <p:cNvCxnSpPr/>
+          <p:nvPr/>
+        </p:nvCxnSpPr>
+        <p:spPr>
+          <a:xfrm>
+            <a:off x="8821079" y="3132752"/>
+            <a:ext cx="1865" cy="42248"/>
+          </a:xfrm>
+          <a:prstGeom prst="line">
+            <a:avLst/>
+          </a:prstGeom>
+          <a:ln w="15240">
+            <a:solidFill>
+              <a:srgbClr val="CF0035"/>
+            </a:solidFill>
+          </a:ln>
+        </p:spPr>
+        <p:style>
+          <a:lnRef idx="2">
+            <a:schemeClr val="accent1"/>
+          </a:lnRef>
+          <a:fillRef idx="0">
+            <a:schemeClr val="accent1"/>
+          </a:fillRef>
+          <a:effectRef idx="1">
+            <a:schemeClr val="accent1"/>
+          </a:effectRef>
+          <a:fontRef idx="minor">
+            <a:schemeClr val="tx1"/>
+          </a:fontRef>
+        </p:style>
+      </p:cxnSp>
+      <p:cxnSp>
+        <p:nvCxnSpPr>
+          <p:cNvPr id="56" name="Connector 55"/>
+          <p:cNvCxnSpPr/>
+          <p:nvPr/>
+        </p:nvCxnSpPr>
+        <p:spPr>
+          <a:xfrm>
+            <a:off x="8534400" y="3175000"/>
+            <a:ext cx="406400" cy="0"/>
+          </a:xfrm>
+          <a:prstGeom prst="line">
+            <a:avLst/>
+          </a:prstGeom>
+          <a:ln w="15240">
+            <a:solidFill>
+              <a:srgbClr val="CF0035"/>
+            </a:solidFill>
+          </a:ln>
+        </p:spPr>
+        <p:style>
+          <a:lnRef idx="2">
+            <a:schemeClr val="accent1"/>
+          </a:lnRef>
+          <a:fillRef idx="0">
+            <a:schemeClr val="accent1"/>
+          </a:fillRef>
+          <a:effectRef idx="1">
+            <a:schemeClr val="accent1"/>
+          </a:effectRef>
+          <a:fontRef idx="minor">
+            <a:schemeClr val="tx1"/>
+          </a:fontRef>
+        </p:style>
+      </p:cxnSp>
+      <p:cxnSp>
+        <p:nvCxnSpPr>
+          <p:cNvPr id="57" name="Connector 56"/>
+          <p:cNvCxnSpPr/>
+          <p:nvPr/>
+        </p:nvCxnSpPr>
+        <p:spPr>
+          <a:xfrm>
+            <a:off x="8562340" y="3073400"/>
+            <a:ext cx="350520" cy="0"/>
+          </a:xfrm>
+          <a:prstGeom prst="line">
+            <a:avLst/>
+          </a:prstGeom>
+          <a:ln w="15240">
+            <a:solidFill>
+              <a:srgbClr val="CF0035"/>
+            </a:solidFill>
+          </a:ln>
+        </p:spPr>
+        <p:style>
+          <a:lnRef idx="2">
+            <a:schemeClr val="accent1"/>
+          </a:lnRef>
+          <a:fillRef idx="0">
+            <a:schemeClr val="accent1"/>
+          </a:fillRef>
+          <a:effectRef idx="1">
+            <a:schemeClr val="accent1"/>
+          </a:effectRef>
+          <a:fontRef idx="minor">
+            <a:schemeClr val="tx1"/>
+          </a:fontRef>
+        </p:style>
+      </p:cxnSp>
+      <p:cxnSp>
+        <p:nvCxnSpPr>
+          <p:cNvPr id="58" name="Connector 57"/>
+          <p:cNvCxnSpPr/>
+          <p:nvPr/>
+        </p:nvCxnSpPr>
+        <p:spPr>
+          <a:xfrm>
+            <a:off x="8562340" y="3276600"/>
+            <a:ext cx="350520" cy="0"/>
+          </a:xfrm>
+          <a:prstGeom prst="line">
+            <a:avLst/>
+          </a:prstGeom>
+          <a:ln w="15240">
+            <a:solidFill>
+              <a:srgbClr val="CF0035"/>
+            </a:solidFill>
+          </a:ln>
+        </p:spPr>
+        <p:style>
+          <a:lnRef idx="2">
+            <a:schemeClr val="accent1"/>
+          </a:lnRef>
+          <a:fillRef idx="0">
+            <a:schemeClr val="accent1"/>
+          </a:fillRef>
+          <a:effectRef idx="1">
+            <a:schemeClr val="accent1"/>
+          </a:effectRef>
+          <a:fontRef idx="minor">
+            <a:schemeClr val="tx1"/>
+          </a:fontRef>
+        </p:style>
+      </p:cxnSp>
+      <p:sp>
+        <p:nvSpPr>
+          <p:cNvPr id="59" name="TextBox 58"/>
+          <p:cNvSpPr txBox="1"/>
+          <p:nvPr/>
+        </p:nvSpPr>
+        <p:spPr>
+          <a:xfrm>
+            <a:off x="8432800" y="3683000"/>
+            <a:ext cx="2946400" cy="344805"/>
+          </a:xfrm>
+          <a:prstGeom prst="rect">
+            <a:avLst/>
+          </a:prstGeom>
+          <a:noFill/>
+        </p:spPr>
+        <p:txBody>
+          <a:bodyPr wrap="none" lIns="0" rIns="0" tIns="0" bIns="0" anchor="t">
+            <a:noAutofit/>
+          </a:bodyPr>
+          <a:lstStyle/>
+          <a:p>
+            <a:pPr algn="l">
+              <a:lnSpc>
+                <a:spcPts val="2415"/>
+              </a:lnSpc>
+              <a:spcBef>
+                <a:spcPts val="0"/>
+              </a:spcBef>
+              <a:spcAft>
+                <a:spcPts val="0"/>
+              </a:spcAft>
+            </a:pPr>
+            <a:r>
+              <a:rPr sz="2100" b="1">
+                <a:solidFill>
+                  <a:srgbClr val="F79BB0"/>
+                </a:solidFill>
+                <a:latin typeface="Arial"/>
+              </a:rPr>
+              <a:t>Own your DNS</a:t>
+            </a:r>
+          </a:p>
+        </p:txBody>
+      </p:sp>
+      <p:sp>
+        <p:nvSpPr>
+          <p:cNvPr id="60" name="TextBox 59"/>
+          <p:cNvSpPr txBox="1"/>
+          <p:nvPr/>
+        </p:nvSpPr>
+        <p:spPr>
+          <a:xfrm>
+            <a:off x="8432800" y="4178300"/>
+            <a:ext cx="2946400" cy="921257"/>
+          </a:xfrm>
+          <a:prstGeom prst="rect">
+            <a:avLst/>
+          </a:prstGeom>
+          <a:noFill/>
+        </p:spPr>
+        <p:txBody>
+          <a:bodyPr wrap="none" lIns="0" rIns="0" tIns="0" bIns="0" anchor="t">
+            <a:noAutofit/>
+          </a:bodyPr>
+          <a:lstStyle/>
+          <a:p>
+            <a:pPr algn="l">
+              <a:lnSpc>
+                <a:spcPts val="2318"/>
+              </a:lnSpc>
+              <a:spcBef>
+                <a:spcPts val="0"/>
+              </a:spcBef>
+              <a:spcAft>
+                <a:spcPts val="0"/>
+              </a:spcAft>
+            </a:pPr>
+            <a:r>
+              <a:rPr sz="1900" b="0">
+                <a:solidFill>
+                  <a:srgbClr val="FFFFFF"/>
+                </a:solidFill>
+                <a:latin typeface="Arial"/>
+              </a:rPr>
+              <a:t>Self-hosted BIND9</a:t>
+            </a:r>
+          </a:p>
+          <a:p>
+            <a:pPr algn="l">
+              <a:lnSpc>
+                <a:spcPts val="2318"/>
+              </a:lnSpc>
+              <a:spcBef>
+                <a:spcPts val="0"/>
+              </a:spcBef>
+              <a:spcAft>
+                <a:spcPts val="0"/>
+              </a:spcAft>
+            </a:pPr>
+            <a:r>
+              <a:rPr sz="1900" b="0">
+                <a:solidFill>
+                  <a:srgbClr val="FFFFFF"/>
+                </a:solidFill>
+                <a:latin typeface="Arial"/>
+              </a:rPr>
+              <a:t>for the parent zone</a:t>
+            </a:r>
+          </a:p>
+          <a:p>
+            <a:pPr algn="l">
+              <a:lnSpc>
+                <a:spcPts val="2318"/>
+              </a:lnSpc>
+              <a:spcBef>
+                <a:spcPts val="0"/>
+              </a:spcBef>
+              <a:spcAft>
+                <a:spcPts val="0"/>
+              </a:spcAft>
+            </a:pPr>
+            <a:r>
+              <a:rPr sz="1900" b="0">
+                <a:solidFill>
+                  <a:srgbClr val="FFFFFF"/>
+                </a:solidFill>
+                <a:latin typeface="Arial"/>
+              </a:rPr>
+              <a:t>and delegation.</a:t>
+            </a:r>
+          </a:p>
+        </p:txBody>
+      </p:sp>
+      <p:sp>
+        <p:nvSpPr>
+          <p:cNvPr id="61" name="Rounded Rectangle 60"/>
+          <p:cNvSpPr/>
+          <p:nvPr/>
+        </p:nvSpPr>
+        <p:spPr>
+          <a:xfrm>
+            <a:off x="609600" y="5727700"/>
+            <a:ext cx="10972800" cy="520700"/>
+          </a:xfrm>
+          <a:prstGeom prst="roundRect">
+            <a:avLst>
+              <a:gd name="adj" fmla="val 17073"/>
+            </a:avLst>
+          </a:prstGeom>
+          <a:solidFill>
+            <a:srgbClr val="1A3047"/>
+          </a:solidFill>
+          <a:ln>
+            <a:noFill/>
+          </a:ln>
+          <a:effectLst/>
+        </p:spPr>
+        <p:style>
+          <a:lnRef idx="1">
+            <a:schemeClr val="accent1"/>
+          </a:lnRef>
+          <a:fillRef idx="3">
+            <a:schemeClr val="accent1"/>
+          </a:fillRef>
+          <a:effectRef idx="2">
+            <a:schemeClr val="accent1"/>
+          </a:effectRef>
+          <a:fontRef idx="minor">
+            <a:schemeClr val="lt1"/>
+          </a:fontRef>
+        </p:style>
+        <p:txBody>
+          <a:bodyPr rtlCol="0" anchor="ctr"/>
+          <a:lstStyle/>
+          <a:p>
+            <a:pPr algn="ctr"/>
+          </a:p>
+        </p:txBody>
+      </p:sp>
+      <p:sp>
+        <p:nvSpPr>
+          <p:cNvPr id="62" name="TextBox 61"/>
+          <p:cNvSpPr txBox="1"/>
+          <p:nvPr/>
+        </p:nvSpPr>
+        <p:spPr>
+          <a:xfrm>
+            <a:off x="838200" y="5854700"/>
+            <a:ext cx="10515600" cy="349250"/>
+          </a:xfrm>
+          <a:prstGeom prst="rect">
+            <a:avLst/>
+          </a:prstGeom>
+          <a:noFill/>
+        </p:spPr>
+        <p:txBody>
+          <a:bodyPr wrap="none" lIns="0" rIns="0" tIns="0" bIns="0" anchor="t">
+            <a:noAutofit/>
+          </a:bodyPr>
+          <a:lstStyle/>
+          <a:p>
+            <a:pPr algn="ctr">
+              <a:lnSpc>
+                <a:spcPts val="2200"/>
+              </a:lnSpc>
+              <a:spcBef>
+                <a:spcPts val="0"/>
+              </a:spcBef>
+              <a:spcAft>
+                <a:spcPts val="0"/>
+              </a:spcAft>
+            </a:pPr>
+            <a:r>
+              <a:rPr sz="2200" b="1">
+                <a:solidFill>
+                  <a:srgbClr val="FFFFFF"/>
+                </a:solidFill>
+                <a:latin typeface="Arial"/>
+              </a:rPr>
+              <a:t>You define the traffic strategy. k8gb automates it.</a:t>
+            </a:r>
+          </a:p>
+        </p:txBody>
+      </p:sp>
+    </p:spTree>
+  </p:cSld>
+  <p:clrMapOvr>
+    <a:masterClrMapping/>
+  </p:clrMapOvr>
+</p:sld>
+</file>
+
+<file path=ppt/slides/slide27.xml><?xml version="1.0" encoding="utf-8"?>
+<p:sld xmlns:a="http://schemas.openxmlformats.org/drawingml/2006/main" xmlns:p="http://schemas.openxmlformats.org/presentationml/2006/main" xmlns:r="http://schemas.openxmlformats.org/officeDocument/2006/relationships">
+  <p:cSld>
+    <p:spTree>
+      <p:nvGrpSpPr>
+        <p:cNvPr id="1" name=""/>
+        <p:cNvGrpSpPr/>
+        <p:nvPr/>
+      </p:nvGrpSpPr>
+      <p:grpSpPr/>
+      <p:sp>
+        <p:nvSpPr>
+          <p:cNvPr id="2" name="Rectangle 1"/>
+          <p:cNvSpPr/>
+          <p:nvPr/>
+        </p:nvSpPr>
+        <p:spPr>
+          <a:xfrm>
+            <a:off x="0" y="0"/>
+            <a:ext cx="12192000" cy="6858000"/>
+          </a:xfrm>
+          <a:prstGeom prst="rect">
+            <a:avLst/>
+          </a:prstGeom>
+          <a:solidFill>
             <a:srgbClr val="F8FAFC"/>
           </a:solidFill>
           <a:ln>
@@ -51130,7 +53730,7 @@
                 </a:solidFill>
                 <a:latin typeface="Arial"/>
               </a:rPr>
-              <a:t>26 / 26</a:t>
+              <a:t>27 / 27</a:t>
             </a:r>
           </a:p>
         </p:txBody>
@@ -53255,7 +55855,7 @@
                 </a:solidFill>
                 <a:latin typeface="Arial"/>
               </a:rPr>
-              <a:t>03 / 26</a:t>
+              <a:t>03 / 27</a:t>
             </a:r>
           </a:p>
         </p:txBody>
@@ -55441,7 +58041,7 @@
                 </a:solidFill>
                 <a:latin typeface="Arial"/>
               </a:rPr>
-              <a:t>04 / 26</a:t>
+              <a:t>04 / 27</a:t>
             </a:r>
           </a:p>
         </p:txBody>
@@ -56284,7 +58884,7 @@
                 </a:solidFill>
                 <a:latin typeface="Arial"/>
               </a:rPr>
-              <a:t>05 / 26</a:t>
+              <a:t>05 / 27</a:t>
             </a:r>
           </a:p>
         </p:txBody>
@@ -59471,7 +62071,7 @@
                 </a:solidFill>
                 <a:latin typeface="Arial"/>
               </a:rPr>
-              <a:t>06 / 26</a:t>
+              <a:t>06 / 27</a:t>
             </a:r>
           </a:p>
         </p:txBody>
@@ -63518,7 +66118,7 @@
                 </a:solidFill>
                 <a:latin typeface="Arial"/>
               </a:rPr>
-              <a:t>07 / 26</a:t>
+              <a:t>07 / 27</a:t>
             </a:r>
           </a:p>
         </p:txBody>
@@ -64483,7 +67083,7 @@
                 </a:solidFill>
                 <a:latin typeface="Arial"/>
               </a:rPr>
-              <a:t>08 / 26</a:t>
+              <a:t>08 / 27</a:t>
             </a:r>
           </a:p>
         </p:txBody>
@@ -66971,7 +69571,7 @@
                 </a:solidFill>
                 <a:latin typeface="Arial"/>
               </a:rPr>
-              <a:t>09 / 26</a:t>
+              <a:t>09 / 27</a:t>
             </a:r>
           </a:p>
         </p:txBody>

</xml_diff>